<commit_message>
ommit conclusão Trbalho de Matemática
</commit_message>
<xml_diff>
--- a/Downloads/Matematica Fundamental.pptx
+++ b/Downloads/Matematica Fundamental.pptx
@@ -18,11 +18,15 @@
     <p:sldId id="266" r:id="rId12"/>
     <p:sldId id="267" r:id="rId13"/>
     <p:sldId id="268" r:id="rId14"/>
-    <p:sldId id="269" r:id="rId15"/>
-    <p:sldId id="270" r:id="rId16"/>
-    <p:sldId id="271" r:id="rId17"/>
-    <p:sldId id="272" r:id="rId18"/>
-    <p:sldId id="273" r:id="rId19"/>
+    <p:sldId id="274" r:id="rId15"/>
+    <p:sldId id="275" r:id="rId16"/>
+    <p:sldId id="276" r:id="rId17"/>
+    <p:sldId id="277" r:id="rId18"/>
+    <p:sldId id="269" r:id="rId19"/>
+    <p:sldId id="270" r:id="rId20"/>
+    <p:sldId id="271" r:id="rId21"/>
+    <p:sldId id="272" r:id="rId22"/>
+    <p:sldId id="273" r:id="rId23"/>
   </p:sldIdLst>
   <p:sldSz cx="12192000" cy="6858000"/>
   <p:notesSz cx="6858000" cy="9144000"/>
@@ -132,12 +136,7 @@
 <file path=ppt/revisionInfo.xml><?xml version="1.0" encoding="utf-8"?>
 <p1510:revInfo xmlns:a="http://schemas.openxmlformats.org/drawingml/2006/main" xmlns:r="http://schemas.openxmlformats.org/officeDocument/2006/relationships" xmlns:p1510="http://schemas.microsoft.com/office/powerpoint/2015/10/main">
   <p1510:revLst>
-    <p1510:client id="{252E4B12-BEF7-43D7-AE07-E10006ACA66C}" v="248" dt="2025-11-22T16:03:38.883"/>
-    <p1510:client id="{4631A1FD-77BE-32E9-3FB4-09C6655F5158}" v="130" dt="2025-11-22T19:04:40.422"/>
-    <p1510:client id="{4924F9F8-C944-AB21-26BE-07AED480F340}" v="349" dt="2025-11-23T05:56:08.458"/>
-    <p1510:client id="{92141E93-F7CA-408E-BB8C-BE39897542AC}" v="10" dt="2025-11-22T15:15:06.572"/>
-    <p1510:client id="{A1CF8971-E6A9-934F-377C-41326C21A2A9}" v="971" dt="2025-11-23T05:19:23.031"/>
-    <p1510:client id="{CF3FB4EE-1D60-6C81-DE56-BEB7F2CAEBDA}" v="45" dt="2025-11-23T05:29:20.086"/>
+    <p1510:client id="{6E2347CC-3A19-4E5C-B610-004F2E4A0D56}" v="126" dt="2025-11-26T09:21:21.397"/>
   </p1510:revLst>
 </p1510:revInfo>
 </file>
@@ -273,7 +272,7 @@
           <a:p>
             <a:fld id="{F0E51C7C-CEA3-4CAA-BE4B-344879E7C377}" type="datetimeFigureOut">
               <a:rPr lang="de-DE" smtClean="0"/>
-              <a:t>22.11.2025</a:t>
+              <a:t>26.11.2025</a:t>
             </a:fld>
             <a:endParaRPr lang="de-DE"/>
           </a:p>
@@ -443,7 +442,7 @@
           <a:p>
             <a:fld id="{F0E51C7C-CEA3-4CAA-BE4B-344879E7C377}" type="datetimeFigureOut">
               <a:rPr lang="de-DE" smtClean="0"/>
-              <a:t>22.11.2025</a:t>
+              <a:t>26.11.2025</a:t>
             </a:fld>
             <a:endParaRPr lang="de-DE"/>
           </a:p>
@@ -623,7 +622,7 @@
           <a:p>
             <a:fld id="{F0E51C7C-CEA3-4CAA-BE4B-344879E7C377}" type="datetimeFigureOut">
               <a:rPr lang="de-DE" smtClean="0"/>
-              <a:t>22.11.2025</a:t>
+              <a:t>26.11.2025</a:t>
             </a:fld>
             <a:endParaRPr lang="de-DE"/>
           </a:p>
@@ -793,7 +792,7 @@
           <a:p>
             <a:fld id="{F0E51C7C-CEA3-4CAA-BE4B-344879E7C377}" type="datetimeFigureOut">
               <a:rPr lang="de-DE" smtClean="0"/>
-              <a:t>22.11.2025</a:t>
+              <a:t>26.11.2025</a:t>
             </a:fld>
             <a:endParaRPr lang="de-DE"/>
           </a:p>
@@ -1039,7 +1038,7 @@
           <a:p>
             <a:fld id="{F0E51C7C-CEA3-4CAA-BE4B-344879E7C377}" type="datetimeFigureOut">
               <a:rPr lang="de-DE" smtClean="0"/>
-              <a:t>22.11.2025</a:t>
+              <a:t>26.11.2025</a:t>
             </a:fld>
             <a:endParaRPr lang="de-DE"/>
           </a:p>
@@ -1271,7 +1270,7 @@
           <a:p>
             <a:fld id="{F0E51C7C-CEA3-4CAA-BE4B-344879E7C377}" type="datetimeFigureOut">
               <a:rPr lang="de-DE" smtClean="0"/>
-              <a:t>22.11.2025</a:t>
+              <a:t>26.11.2025</a:t>
             </a:fld>
             <a:endParaRPr lang="de-DE"/>
           </a:p>
@@ -1638,7 +1637,7 @@
           <a:p>
             <a:fld id="{F0E51C7C-CEA3-4CAA-BE4B-344879E7C377}" type="datetimeFigureOut">
               <a:rPr lang="de-DE" smtClean="0"/>
-              <a:t>22.11.2025</a:t>
+              <a:t>26.11.2025</a:t>
             </a:fld>
             <a:endParaRPr lang="de-DE"/>
           </a:p>
@@ -1756,7 +1755,7 @@
           <a:p>
             <a:fld id="{F0E51C7C-CEA3-4CAA-BE4B-344879E7C377}" type="datetimeFigureOut">
               <a:rPr lang="de-DE" smtClean="0"/>
-              <a:t>22.11.2025</a:t>
+              <a:t>26.11.2025</a:t>
             </a:fld>
             <a:endParaRPr lang="de-DE"/>
           </a:p>
@@ -1851,7 +1850,7 @@
           <a:p>
             <a:fld id="{F0E51C7C-CEA3-4CAA-BE4B-344879E7C377}" type="datetimeFigureOut">
               <a:rPr lang="de-DE" smtClean="0"/>
-              <a:t>22.11.2025</a:t>
+              <a:t>26.11.2025</a:t>
             </a:fld>
             <a:endParaRPr lang="de-DE"/>
           </a:p>
@@ -2128,7 +2127,7 @@
           <a:p>
             <a:fld id="{F0E51C7C-CEA3-4CAA-BE4B-344879E7C377}" type="datetimeFigureOut">
               <a:rPr lang="de-DE" smtClean="0"/>
-              <a:t>22.11.2025</a:t>
+              <a:t>26.11.2025</a:t>
             </a:fld>
             <a:endParaRPr lang="de-DE"/>
           </a:p>
@@ -2381,7 +2380,7 @@
           <a:p>
             <a:fld id="{F0E51C7C-CEA3-4CAA-BE4B-344879E7C377}" type="datetimeFigureOut">
               <a:rPr lang="de-DE" smtClean="0"/>
-              <a:t>22.11.2025</a:t>
+              <a:t>26.11.2025</a:t>
             </a:fld>
             <a:endParaRPr lang="de-DE"/>
           </a:p>
@@ -2600,7 +2599,7 @@
           <a:p>
             <a:fld id="{F0E51C7C-CEA3-4CAA-BE4B-344879E7C377}" type="datetimeFigureOut">
               <a:rPr lang="de-DE" smtClean="0"/>
-              <a:t>22.11.2025</a:t>
+              <a:t>26.11.2025</a:t>
             </a:fld>
             <a:endParaRPr lang="de-DE"/>
           </a:p>
@@ -3336,8 +3335,8 @@
         </p:blipFill>
         <p:spPr>
           <a:xfrm>
-            <a:off x="1653676" y="131069"/>
-            <a:ext cx="9312182" cy="3889046"/>
+            <a:off x="1439363" y="1297882"/>
+            <a:ext cx="9312182" cy="5258263"/>
           </a:xfrm>
           <a:prstGeom prst="rect">
             <a:avLst/>
@@ -3346,10 +3345,10 @@
       </p:pic>
       <p:sp>
         <p:nvSpPr>
-          <p:cNvPr id="8" name="CaixaDeTexto 7">
+          <p:cNvPr id="4" name="CaixaDeTexto 3">
             <a:extLst>
               <a:ext uri="{FF2B5EF4-FFF2-40B4-BE49-F238E27FC236}">
-                <a16:creationId xmlns:a16="http://schemas.microsoft.com/office/drawing/2014/main" id="{4B4CC7E2-C7F0-D2B0-8A9B-3EF36D36140E}"/>
+                <a16:creationId xmlns:a16="http://schemas.microsoft.com/office/drawing/2014/main" id="{1E58274C-5A19-D822-88D5-3B93A58195D7}"/>
               </a:ext>
             </a:extLst>
           </p:cNvPr>
@@ -3358,8 +3357,8 @@
         </p:nvSpPr>
         <p:spPr>
           <a:xfrm>
-            <a:off x="58318" y="4277234"/>
-            <a:ext cx="5984737" cy="2585323"/>
+            <a:off x="3653769" y="297393"/>
+            <a:ext cx="5183980" cy="646331"/>
           </a:xfrm>
           <a:prstGeom prst="rect">
             <a:avLst/>
@@ -3375,118 +3374,19 @@
           </a:bodyPr>
           <a:lstStyle/>
           <a:p>
-            <a:pPr marL="285750" indent="-285750" algn="just">
-              <a:buFont typeface="Wingdings"/>
-              <a:buChar char="•"/>
-            </a:pPr>
-            <a:r>
-              <a:rPr lang="pt-BR" b="1" dirty="0"/>
-              <a:t>A área azul representa o retângulo que corresponde ao deslocamento devido à velocidade inicial constante.</a:t>
-            </a:r>
-            <a:endParaRPr lang="pt-BR" b="1"/>
-          </a:p>
-          <a:p>
-            <a:pPr marL="285750" indent="-285750" algn="just">
-              <a:buFont typeface="Wingdings"/>
-              <a:buChar char="•"/>
-            </a:pPr>
-            <a:r>
-              <a:rPr lang="pt-BR" b="1" dirty="0"/>
-              <a:t>A área verde representa o triângulo que corresponde ao deslocamento adicional causado pela aceleração.</a:t>
-            </a:r>
-            <a:endParaRPr lang="pt-BR" b="1"/>
-          </a:p>
-          <a:p>
-            <a:pPr marL="285750" indent="-285750" algn="just">
-              <a:buFont typeface="Wingdings"/>
-              <a:buChar char="•"/>
-            </a:pPr>
-            <a:r>
-              <a:rPr lang="pt-BR" b="1" dirty="0"/>
-              <a:t>A soma dessas áreas gera a fórmula completa da posição</a:t>
-            </a:r>
-            <a:endParaRPr lang="pt-BR" b="1"/>
-          </a:p>
-          <a:p>
-            <a:pPr algn="l"/>
-            <a:endParaRPr lang="pt-BR" dirty="0"/>
-          </a:p>
-        </p:txBody>
-      </p:sp>
-      <p:sp>
-        <p:nvSpPr>
-          <p:cNvPr id="9" name="CaixaDeTexto 8">
-            <a:extLst>
-              <a:ext uri="{FF2B5EF4-FFF2-40B4-BE49-F238E27FC236}">
-                <a16:creationId xmlns:a16="http://schemas.microsoft.com/office/drawing/2014/main" id="{368B99D6-1B58-17B2-D386-903798F716F0}"/>
-              </a:ext>
-            </a:extLst>
-          </p:cNvPr>
-          <p:cNvSpPr txBox="1"/>
-          <p:nvPr/>
-        </p:nvSpPr>
-        <p:spPr>
-          <a:xfrm>
-            <a:off x="6305807" y="4272890"/>
-            <a:ext cx="5791198" cy="2308324"/>
-          </a:xfrm>
-          <a:prstGeom prst="rect">
-            <a:avLst/>
-          </a:prstGeom>
-          <a:noFill/>
-        </p:spPr>
-        <p:txBody>
-          <a:bodyPr rot="0" spcFirstLastPara="0" vertOverflow="overflow" horzOverflow="overflow" vert="horz" wrap="square" lIns="91440" tIns="45720" rIns="91440" bIns="45720" numCol="1" spcCol="0" rtlCol="0" fromWordArt="0" anchor="t" anchorCtr="0" forceAA="0" compatLnSpc="1">
-            <a:prstTxWarp prst="textNoShape">
-              <a:avLst/>
-            </a:prstTxWarp>
-            <a:spAutoFit/>
-          </a:bodyPr>
-          <a:lstStyle/>
-          <a:p>
-            <a:pPr algn="just"/>
-            <a:r>
-              <a:rPr lang="pt-BR" b="1" dirty="0">
+            <a:r>
+              <a:rPr lang="pt-BR" sz="3600" b="1" dirty="0">
                 <a:solidFill>
-                  <a:srgbClr val="0F4761"/>
+                  <a:srgbClr val="FF0000"/>
                 </a:solidFill>
               </a:rPr>
-              <a:t>Intuição geométrica</a:t>
-            </a:r>
-          </a:p>
-          <a:p>
-            <a:pPr marL="285750" indent="-285750" algn="just">
-              <a:buFont typeface="Symbol"/>
-              <a:buChar char="•"/>
-            </a:pPr>
-            <a:r>
-              <a:rPr lang="pt-BR" b="1" dirty="0"/>
-              <a:t>Aceleração → inclinação da reta (quanto mais inclinada, maior a variação da velocidade).</a:t>
-            </a:r>
-          </a:p>
-          <a:p>
-            <a:pPr marL="285750" indent="-285750" algn="just">
-              <a:buFont typeface="Symbol"/>
-              <a:buChar char="•"/>
-            </a:pPr>
-            <a:r>
-              <a:rPr lang="pt-BR" b="1" dirty="0"/>
-              <a:t>Espaço → área sob a reta (retângulo + triângulo).</a:t>
-            </a:r>
-          </a:p>
-          <a:p>
-            <a:pPr marL="285750" indent="-285750" algn="just">
-              <a:buFont typeface="Symbol"/>
-              <a:buChar char="•"/>
-            </a:pPr>
-            <a:r>
-              <a:rPr lang="pt-BR" b="1" dirty="0"/>
-              <a:t>A hipotenusa do triângulo é a própria função da velocidade, e a área até ela traduz o deslocamento acumulado.</a:t>
-            </a:r>
-          </a:p>
-          <a:p>
-            <a:pPr algn="l"/>
-            <a:endParaRPr lang="pt-BR" dirty="0"/>
+              <a:t>Simplificando o cálculo</a:t>
+            </a:r>
+            <a:endParaRPr lang="pt-BR" sz="3600" dirty="0">
+              <a:solidFill>
+                <a:srgbClr val="FF0000"/>
+              </a:solidFill>
+            </a:endParaRPr>
           </a:p>
         </p:txBody>
       </p:sp>
@@ -3522,364 +3422,6 @@
       </p:grpSpPr>
       <p:sp>
         <p:nvSpPr>
-          <p:cNvPr id="2" name="Título 1">
-            <a:extLst>
-              <a:ext uri="{FF2B5EF4-FFF2-40B4-BE49-F238E27FC236}">
-                <a16:creationId xmlns:a16="http://schemas.microsoft.com/office/drawing/2014/main" id="{603A2C22-18A1-093A-64EC-65FB55A48C11}"/>
-              </a:ext>
-            </a:extLst>
-          </p:cNvPr>
-          <p:cNvSpPr>
-            <a:spLocks noGrp="1"/>
-          </p:cNvSpPr>
-          <p:nvPr>
-            <p:ph type="title"/>
-          </p:nvPr>
-        </p:nvSpPr>
-        <p:spPr>
-          <a:xfrm>
-            <a:off x="3527612" y="-4670"/>
-            <a:ext cx="4789395" cy="821298"/>
-          </a:xfrm>
-        </p:spPr>
-        <p:txBody>
-          <a:bodyPr>
-            <a:normAutofit/>
-          </a:bodyPr>
-          <a:lstStyle/>
-          <a:p>
-            <a:r>
-              <a:rPr lang="pt-BR" sz="3200" b="1" dirty="0">
-                <a:solidFill>
-                  <a:srgbClr val="FF0000"/>
-                </a:solidFill>
-                <a:latin typeface="Aptos"/>
-              </a:rPr>
-              <a:t>Simplificando o cálculo</a:t>
-            </a:r>
-          </a:p>
-        </p:txBody>
-      </p:sp>
-      <p:sp>
-        <p:nvSpPr>
-          <p:cNvPr id="3" name="Espaço Reservado para Conteúdo 2">
-            <a:extLst>
-              <a:ext uri="{FF2B5EF4-FFF2-40B4-BE49-F238E27FC236}">
-                <a16:creationId xmlns:a16="http://schemas.microsoft.com/office/drawing/2014/main" id="{A7D56919-E9BD-BA7E-1B83-9233768FF6D8}"/>
-              </a:ext>
-            </a:extLst>
-          </p:cNvPr>
-          <p:cNvSpPr>
-            <a:spLocks noGrp="1"/>
-          </p:cNvSpPr>
-          <p:nvPr>
-            <p:ph idx="1"/>
-          </p:nvPr>
-        </p:nvSpPr>
-        <p:spPr>
-          <a:xfrm>
-            <a:off x="670112" y="817096"/>
-            <a:ext cx="10515600" cy="451691"/>
-          </a:xfrm>
-        </p:spPr>
-        <p:txBody>
-          <a:bodyPr vert="horz" lIns="91440" tIns="45720" rIns="91440" bIns="45720" rtlCol="0" anchor="t">
-            <a:normAutofit/>
-          </a:bodyPr>
-          <a:lstStyle/>
-          <a:p>
-            <a:pPr marL="0" indent="0">
-              <a:buNone/>
-            </a:pPr>
-            <a:r>
-              <a:rPr lang="pt-BR" sz="1800" b="1" dirty="0"/>
-              <a:t>No Movimento Uniforme (MU), a velocidade é constante:</a:t>
-            </a:r>
-          </a:p>
-        </p:txBody>
-      </p:sp>
-      <p:pic>
-        <p:nvPicPr>
-          <p:cNvPr id="4" name="Imagem 3">
-            <a:extLst>
-              <a:ext uri="{FF2B5EF4-FFF2-40B4-BE49-F238E27FC236}">
-                <a16:creationId xmlns:a16="http://schemas.microsoft.com/office/drawing/2014/main" id="{E88D8FF3-B290-F633-7B92-85293CD55829}"/>
-              </a:ext>
-            </a:extLst>
-          </p:cNvPr>
-          <p:cNvPicPr>
-            <a:picLocks noChangeAspect="1"/>
-          </p:cNvPicPr>
-          <p:nvPr/>
-        </p:nvPicPr>
-        <p:blipFill>
-          <a:blip r:embed="rId2"/>
-          <a:stretch>
-            <a:fillRect/>
-          </a:stretch>
-        </p:blipFill>
-        <p:spPr>
-          <a:xfrm>
-            <a:off x="4370651" y="1181423"/>
-            <a:ext cx="1991845" cy="533400"/>
-          </a:xfrm>
-          <a:prstGeom prst="rect">
-            <a:avLst/>
-          </a:prstGeom>
-        </p:spPr>
-      </p:pic>
-      <p:sp>
-        <p:nvSpPr>
-          <p:cNvPr id="5" name="CaixaDeTexto 4">
-            <a:extLst>
-              <a:ext uri="{FF2B5EF4-FFF2-40B4-BE49-F238E27FC236}">
-                <a16:creationId xmlns:a16="http://schemas.microsoft.com/office/drawing/2014/main" id="{7784E896-384C-64E9-ED22-390F9957C2EE}"/>
-              </a:ext>
-            </a:extLst>
-          </p:cNvPr>
-          <p:cNvSpPr txBox="1"/>
-          <p:nvPr/>
-        </p:nvSpPr>
-        <p:spPr>
-          <a:xfrm>
-            <a:off x="666325" y="1719029"/>
-            <a:ext cx="9892552" cy="369332"/>
-          </a:xfrm>
-          <a:prstGeom prst="rect">
-            <a:avLst/>
-          </a:prstGeom>
-          <a:noFill/>
-        </p:spPr>
-        <p:txBody>
-          <a:bodyPr rot="0" spcFirstLastPara="0" vertOverflow="overflow" horzOverflow="overflow" vert="horz" wrap="square" lIns="91440" tIns="45720" rIns="91440" bIns="45720" numCol="1" spcCol="0" rtlCol="0" fromWordArt="0" anchor="t" anchorCtr="0" forceAA="0" compatLnSpc="1">
-            <a:prstTxWarp prst="textNoShape">
-              <a:avLst/>
-            </a:prstTxWarp>
-            <a:spAutoFit/>
-          </a:bodyPr>
-          <a:lstStyle/>
-          <a:p>
-            <a:r>
-              <a:rPr lang="pt-BR" b="1" dirty="0"/>
-              <a:t>Agora, no MUV, a velocidade já não é constante, mas varia ao longo do tempo:</a:t>
-            </a:r>
-          </a:p>
-        </p:txBody>
-      </p:sp>
-      <p:pic>
-        <p:nvPicPr>
-          <p:cNvPr id="6" name="Imagem 5">
-            <a:extLst>
-              <a:ext uri="{FF2B5EF4-FFF2-40B4-BE49-F238E27FC236}">
-                <a16:creationId xmlns:a16="http://schemas.microsoft.com/office/drawing/2014/main" id="{1013FD20-D2EE-80B0-6144-2694BF6D7B20}"/>
-              </a:ext>
-            </a:extLst>
-          </p:cNvPr>
-          <p:cNvPicPr>
-            <a:picLocks noChangeAspect="1"/>
-          </p:cNvPicPr>
-          <p:nvPr/>
-        </p:nvPicPr>
-        <p:blipFill>
-          <a:blip r:embed="rId3"/>
-          <a:stretch>
-            <a:fillRect/>
-          </a:stretch>
-        </p:blipFill>
-        <p:spPr>
-          <a:xfrm>
-            <a:off x="4278686" y="2092138"/>
-            <a:ext cx="2189069" cy="510988"/>
-          </a:xfrm>
-          <a:prstGeom prst="rect">
-            <a:avLst/>
-          </a:prstGeom>
-        </p:spPr>
-      </p:pic>
-      <p:sp>
-        <p:nvSpPr>
-          <p:cNvPr id="7" name="CaixaDeTexto 6">
-            <a:extLst>
-              <a:ext uri="{FF2B5EF4-FFF2-40B4-BE49-F238E27FC236}">
-                <a16:creationId xmlns:a16="http://schemas.microsoft.com/office/drawing/2014/main" id="{BEA2AB51-E243-6DD8-9E8E-D4FCE1A5D11F}"/>
-              </a:ext>
-            </a:extLst>
-          </p:cNvPr>
-          <p:cNvSpPr txBox="1"/>
-          <p:nvPr/>
-        </p:nvSpPr>
-        <p:spPr>
-          <a:xfrm>
-            <a:off x="666309" y="2598265"/>
-            <a:ext cx="10015817" cy="646331"/>
-          </a:xfrm>
-          <a:prstGeom prst="rect">
-            <a:avLst/>
-          </a:prstGeom>
-          <a:noFill/>
-        </p:spPr>
-        <p:txBody>
-          <a:bodyPr rot="0" spcFirstLastPara="0" vertOverflow="overflow" horzOverflow="overflow" vert="horz" wrap="square" lIns="91440" tIns="45720" rIns="91440" bIns="45720" numCol="1" spcCol="0" rtlCol="0" fromWordArt="0" anchor="t" anchorCtr="0" forceAA="0" compatLnSpc="1">
-            <a:prstTxWarp prst="textNoShape">
-              <a:avLst/>
-            </a:prstTxWarp>
-            <a:spAutoFit/>
-          </a:bodyPr>
-          <a:lstStyle/>
-          <a:p>
-            <a:r>
-              <a:rPr lang="pt-BR" b="1" dirty="0"/>
-              <a:t>Se pegar a fórmula do MU e tentar usá-la no MUV, substituindo a velocidade instantânea pela expressão acima, obtém-se:</a:t>
-            </a:r>
-          </a:p>
-        </p:txBody>
-      </p:sp>
-      <p:pic>
-        <p:nvPicPr>
-          <p:cNvPr id="8" name="Imagem 7" descr="Diagrama&#10;&#10;O conteúdo gerado por IA pode estar incorreto.">
-            <a:extLst>
-              <a:ext uri="{FF2B5EF4-FFF2-40B4-BE49-F238E27FC236}">
-                <a16:creationId xmlns:a16="http://schemas.microsoft.com/office/drawing/2014/main" id="{D0A3C1F7-232B-EF01-2F44-3B7E314E3027}"/>
-              </a:ext>
-            </a:extLst>
-          </p:cNvPr>
-          <p:cNvPicPr>
-            <a:picLocks noChangeAspect="1"/>
-          </p:cNvPicPr>
-          <p:nvPr/>
-        </p:nvPicPr>
-        <p:blipFill>
-          <a:blip r:embed="rId4"/>
-          <a:stretch>
-            <a:fillRect/>
-          </a:stretch>
-        </p:blipFill>
-        <p:spPr>
-          <a:xfrm>
-            <a:off x="4097991" y="2925855"/>
-            <a:ext cx="2561664" cy="1420905"/>
-          </a:xfrm>
-          <a:prstGeom prst="rect">
-            <a:avLst/>
-          </a:prstGeom>
-        </p:spPr>
-      </p:pic>
-      <p:sp>
-        <p:nvSpPr>
-          <p:cNvPr id="9" name="CaixaDeTexto 8">
-            <a:extLst>
-              <a:ext uri="{FF2B5EF4-FFF2-40B4-BE49-F238E27FC236}">
-                <a16:creationId xmlns:a16="http://schemas.microsoft.com/office/drawing/2014/main" id="{AED6D401-DA46-7E3D-5610-DDFF6976AB2F}"/>
-              </a:ext>
-            </a:extLst>
-          </p:cNvPr>
-          <p:cNvSpPr txBox="1"/>
-          <p:nvPr/>
-        </p:nvSpPr>
-        <p:spPr>
-          <a:xfrm>
-            <a:off x="666355" y="4345781"/>
-            <a:ext cx="8357347" cy="369332"/>
-          </a:xfrm>
-          <a:prstGeom prst="rect">
-            <a:avLst/>
-          </a:prstGeom>
-          <a:noFill/>
-        </p:spPr>
-        <p:txBody>
-          <a:bodyPr rot="0" spcFirstLastPara="0" vertOverflow="overflow" horzOverflow="overflow" vert="horz" wrap="square" lIns="91440" tIns="45720" rIns="91440" bIns="45720" numCol="1" spcCol="0" rtlCol="0" fromWordArt="0" anchor="t" anchorCtr="0" forceAA="0" compatLnSpc="1">
-            <a:prstTxWarp prst="textNoShape">
-              <a:avLst/>
-            </a:prstTxWarp>
-            <a:spAutoFit/>
-          </a:bodyPr>
-          <a:lstStyle/>
-          <a:p>
-            <a:r>
-              <a:rPr lang="pt-BR" b="1" dirty="0"/>
-              <a:t>Essa expressão se parece muito com a função horária real:</a:t>
-            </a:r>
-          </a:p>
-        </p:txBody>
-      </p:sp>
-      <p:pic>
-        <p:nvPicPr>
-          <p:cNvPr id="10" name="Imagem 9" descr="Diagrama, Gráfico de caixa estreita&#10;&#10;O conteúdo gerado por IA pode estar incorreto.">
-            <a:extLst>
-              <a:ext uri="{FF2B5EF4-FFF2-40B4-BE49-F238E27FC236}">
-                <a16:creationId xmlns:a16="http://schemas.microsoft.com/office/drawing/2014/main" id="{FE949E1A-BC0E-53B5-45FB-DD7AA8287CE7}"/>
-              </a:ext>
-            </a:extLst>
-          </p:cNvPr>
-          <p:cNvPicPr>
-            <a:picLocks noChangeAspect="1"/>
-          </p:cNvPicPr>
-          <p:nvPr/>
-        </p:nvPicPr>
-        <p:blipFill>
-          <a:blip r:embed="rId5"/>
-          <a:stretch>
-            <a:fillRect/>
-          </a:stretch>
-        </p:blipFill>
-        <p:spPr>
-          <a:xfrm>
-            <a:off x="4212012" y="4720197"/>
-            <a:ext cx="2322418" cy="689722"/>
-          </a:xfrm>
-          <a:prstGeom prst="rect">
-            <a:avLst/>
-          </a:prstGeom>
-        </p:spPr>
-      </p:pic>
-      <p:sp>
-        <p:nvSpPr>
-          <p:cNvPr id="11" name="CaixaDeTexto 10">
-            <a:extLst>
-              <a:ext uri="{FF2B5EF4-FFF2-40B4-BE49-F238E27FC236}">
-                <a16:creationId xmlns:a16="http://schemas.microsoft.com/office/drawing/2014/main" id="{D7D4A8A7-8301-CBDC-41C9-66F79DB3235F}"/>
-              </a:ext>
-            </a:extLst>
-          </p:cNvPr>
-          <p:cNvSpPr txBox="1"/>
-          <p:nvPr/>
-        </p:nvSpPr>
-        <p:spPr>
-          <a:xfrm>
-            <a:off x="223576" y="5779561"/>
-            <a:ext cx="10789022" cy="707886"/>
-          </a:xfrm>
-          <a:prstGeom prst="rect">
-            <a:avLst/>
-          </a:prstGeom>
-          <a:noFill/>
-        </p:spPr>
-        <p:txBody>
-          <a:bodyPr rot="0" spcFirstLastPara="0" vertOverflow="overflow" horzOverflow="overflow" vert="horz" wrap="square" lIns="91440" tIns="45720" rIns="91440" bIns="45720" numCol="1" spcCol="0" rtlCol="0" fromWordArt="0" anchor="t" anchorCtr="0" forceAA="0" compatLnSpc="1">
-            <a:prstTxWarp prst="textNoShape">
-              <a:avLst/>
-            </a:prstTxWarp>
-            <a:spAutoFit/>
-          </a:bodyPr>
-          <a:lstStyle/>
-          <a:p>
-            <a:r>
-              <a:rPr lang="pt-BR" sz="2000" b="1" dirty="0"/>
-              <a:t> </a:t>
-            </a:r>
-            <a:r>
-              <a:rPr lang="pt-BR" sz="2000" b="1" dirty="0">
-                <a:solidFill>
-                  <a:srgbClr val="FF0000"/>
-                </a:solidFill>
-              </a:rPr>
-              <a:t>Mas precisa de uma justificativa para o surgimento do fator ½ alinhando a aceleração e o tempo.</a:t>
-            </a:r>
-          </a:p>
-        </p:txBody>
-      </p:sp>
-      <p:sp>
-        <p:nvSpPr>
           <p:cNvPr id="12" name="CaixaDeTexto 11">
             <a:extLst>
               <a:ext uri="{FF2B5EF4-FFF2-40B4-BE49-F238E27FC236}">
@@ -3921,6 +3463,38 @@
           </a:p>
         </p:txBody>
       </p:sp>
+      <p:pic>
+        <p:nvPicPr>
+          <p:cNvPr id="17" name="Espaço Reservado para Conteúdo 16" descr="Tela de celular com aplicativo aberto&#10;&#10;O conteúdo gerado por IA pode estar incorreto.">
+            <a:extLst>
+              <a:ext uri="{FF2B5EF4-FFF2-40B4-BE49-F238E27FC236}">
+                <a16:creationId xmlns:a16="http://schemas.microsoft.com/office/drawing/2014/main" id="{0D46FA8C-7F0D-7465-1362-2600B125632A}"/>
+              </a:ext>
+            </a:extLst>
+          </p:cNvPr>
+          <p:cNvPicPr>
+            <a:picLocks noGrp="1" noChangeAspect="1"/>
+          </p:cNvPicPr>
+          <p:nvPr>
+            <p:ph idx="1"/>
+          </p:nvPr>
+        </p:nvPicPr>
+        <p:blipFill>
+          <a:blip r:embed="rId2"/>
+          <a:stretch>
+            <a:fillRect/>
+          </a:stretch>
+        </p:blipFill>
+        <p:spPr>
+          <a:xfrm>
+            <a:off x="1214034" y="671936"/>
+            <a:ext cx="9763931" cy="5496345"/>
+          </a:xfrm>
+          <a:prstGeom prst="rect">
+            <a:avLst/>
+          </a:prstGeom>
+        </p:spPr>
+      </p:pic>
     </p:spTree>
     <p:extLst>
       <p:ext uri="{BB962C8B-B14F-4D97-AF65-F5344CB8AC3E}">
@@ -3951,186 +3525,86 @@
           <a:chExt cx="0" cy="0"/>
         </a:xfrm>
       </p:grpSpPr>
-      <p:sp>
-        <p:nvSpPr>
-          <p:cNvPr id="2" name="Título 1">
+      <p:pic>
+        <p:nvPicPr>
+          <p:cNvPr id="9" name="Espaço Reservado para Conteúdo 8" descr="Gráfico, Histograma&#10;&#10;O conteúdo gerado por IA pode estar incorreto.">
             <a:extLst>
               <a:ext uri="{FF2B5EF4-FFF2-40B4-BE49-F238E27FC236}">
-                <a16:creationId xmlns:a16="http://schemas.microsoft.com/office/drawing/2014/main" id="{1F9831E8-5FFB-09C1-24F9-2EEB17C487A4}"/>
+                <a16:creationId xmlns:a16="http://schemas.microsoft.com/office/drawing/2014/main" id="{D3272C6B-653D-F769-143C-A19217BEA615}"/>
               </a:ext>
             </a:extLst>
           </p:cNvPr>
-          <p:cNvSpPr>
-            <a:spLocks noGrp="1"/>
-          </p:cNvSpPr>
+          <p:cNvPicPr>
+            <a:picLocks noGrp="1" noChangeAspect="1"/>
+          </p:cNvPicPr>
           <p:nvPr>
-            <p:ph type="title"/>
+            <p:ph idx="1"/>
           </p:nvPr>
-        </p:nvSpPr>
+        </p:nvPicPr>
+        <p:blipFill>
+          <a:blip r:embed="rId2"/>
+          <a:stretch>
+            <a:fillRect/>
+          </a:stretch>
+        </p:blipFill>
         <p:spPr>
           <a:xfrm>
-            <a:off x="2149289" y="-4669"/>
-            <a:ext cx="8722659" cy="574769"/>
+            <a:off x="1821052" y="172934"/>
+            <a:ext cx="8536982" cy="4931603"/>
           </a:xfrm>
+          <a:prstGeom prst="rect">
+            <a:avLst/>
+          </a:prstGeom>
         </p:spPr>
-        <p:txBody>
-          <a:bodyPr>
-            <a:normAutofit/>
+      </p:pic>
+      <p:sp>
+        <p:nvSpPr>
+          <p:cNvPr id="10" name="CaixaDeTexto 9">
+            <a:extLst>
+              <a:ext uri="{FF2B5EF4-FFF2-40B4-BE49-F238E27FC236}">
+                <a16:creationId xmlns:a16="http://schemas.microsoft.com/office/drawing/2014/main" id="{46CD4587-7418-A277-4A20-A58C2BB937DC}"/>
+              </a:ext>
+            </a:extLst>
+          </p:cNvPr>
+          <p:cNvSpPr txBox="1"/>
+          <p:nvPr/>
+        </p:nvSpPr>
+        <p:spPr>
+          <a:xfrm>
+            <a:off x="1017456" y="5315778"/>
+            <a:ext cx="10164151" cy="523220"/>
+          </a:xfrm>
+          <a:prstGeom prst="rect">
+            <a:avLst/>
+          </a:prstGeom>
+          <a:noFill/>
+        </p:spPr>
+        <p:txBody>
+          <a:bodyPr rot="0" spcFirstLastPara="0" vertOverflow="overflow" horzOverflow="overflow" vert="horz" wrap="square" lIns="91440" tIns="45720" rIns="91440" bIns="45720" numCol="1" spcCol="0" rtlCol="0" fromWordArt="0" anchor="t" anchorCtr="0" forceAA="0" compatLnSpc="1">
+            <a:prstTxWarp prst="textNoShape">
+              <a:avLst/>
+            </a:prstTxWarp>
+            <a:spAutoFit/>
           </a:bodyPr>
           <a:lstStyle/>
           <a:p>
             <a:r>
-              <a:rPr lang="pt-BR" sz="3200" b="1" dirty="0">
+              <a:rPr lang="pt-BR" sz="2800" b="1" dirty="0">
                 <a:solidFill>
                   <a:srgbClr val="FF0000"/>
                 </a:solidFill>
-                <a:latin typeface="Aptos"/>
               </a:rPr>
-              <a:t>Por que Surge o Fator ½ na expressão?</a:t>
-            </a:r>
-            <a:endParaRPr lang="pt-BR" sz="3200" dirty="0">
-              <a:solidFill>
-                <a:srgbClr val="FF0000"/>
-              </a:solidFill>
-              <a:latin typeface="Aptos"/>
-            </a:endParaRPr>
-          </a:p>
-        </p:txBody>
-      </p:sp>
-      <p:sp>
-        <p:nvSpPr>
-          <p:cNvPr id="3" name="Espaço Reservado para Conteúdo 2">
+              <a:t>Suponha que dividimos o tempo em intervalos muito curtos:</a:t>
+            </a:r>
+          </a:p>
+        </p:txBody>
+      </p:sp>
+      <p:pic>
+        <p:nvPicPr>
+          <p:cNvPr id="11" name="Imagem 10">
             <a:extLst>
               <a:ext uri="{FF2B5EF4-FFF2-40B4-BE49-F238E27FC236}">
-                <a16:creationId xmlns:a16="http://schemas.microsoft.com/office/drawing/2014/main" id="{286BAB7D-4053-07F9-2221-1F5038CA3946}"/>
-              </a:ext>
-            </a:extLst>
-          </p:cNvPr>
-          <p:cNvSpPr>
-            <a:spLocks noGrp="1"/>
-          </p:cNvSpPr>
-          <p:nvPr>
-            <p:ph idx="1"/>
-          </p:nvPr>
-        </p:nvSpPr>
-        <p:spPr>
-          <a:xfrm>
-            <a:off x="490818" y="873125"/>
-            <a:ext cx="11210364" cy="4261691"/>
-          </a:xfrm>
-        </p:spPr>
-        <p:txBody>
-          <a:bodyPr vert="horz" lIns="91440" tIns="45720" rIns="91440" bIns="45720" rtlCol="0" anchor="t">
-            <a:normAutofit/>
-          </a:bodyPr>
-          <a:lstStyle/>
-          <a:p>
-            <a:pPr>
-              <a:buNone/>
-            </a:pPr>
-            <a:r>
-              <a:rPr lang="pt-BR" b="1" dirty="0">
-                <a:ea typeface="+mn-lt"/>
-                <a:cs typeface="+mn-lt"/>
-              </a:rPr>
-              <a:t>• A velocidade final é assumida ao longo do tempo.</a:t>
-            </a:r>
-            <a:endParaRPr lang="pt-BR" b="1"/>
-          </a:p>
-          <a:p>
-            <a:pPr>
-              <a:buNone/>
-            </a:pPr>
-            <a:r>
-              <a:rPr lang="pt-BR" b="1" dirty="0">
-                <a:ea typeface="+mn-lt"/>
-                <a:cs typeface="+mn-lt"/>
-              </a:rPr>
-              <a:t>• A velocidade cresce gradualmente.</a:t>
-            </a:r>
-            <a:endParaRPr lang="pt-BR" b="1"/>
-          </a:p>
-          <a:p>
-            <a:pPr>
-              <a:buNone/>
-            </a:pPr>
-            <a:r>
-              <a:rPr lang="pt-BR" b="1" dirty="0">
-                <a:ea typeface="+mn-lt"/>
-                <a:cs typeface="+mn-lt"/>
-              </a:rPr>
-              <a:t>• A área correta no gráfico v × t é um trapézio.</a:t>
-            </a:r>
-            <a:endParaRPr lang="pt-BR" b="1"/>
-          </a:p>
-          <a:p>
-            <a:pPr>
-              <a:buNone/>
-            </a:pPr>
-            <a:r>
-              <a:rPr lang="pt-BR" b="1" dirty="0">
-                <a:ea typeface="+mn-lt"/>
-                <a:cs typeface="+mn-lt"/>
-              </a:rPr>
-              <a:t>• O termo adicional corresponde a um triângulo: 1/2 · α · t²</a:t>
-            </a:r>
-            <a:endParaRPr lang="pt-BR" b="1"/>
-          </a:p>
-          <a:p>
-            <a:pPr>
-              <a:buNone/>
-            </a:pPr>
-            <a:r>
-              <a:rPr lang="pt-BR" b="1" dirty="0">
-                <a:ea typeface="+mn-lt"/>
-                <a:cs typeface="+mn-lt"/>
-              </a:rPr>
-              <a:t>• A parte α · t² deve ser reduzida pela metade, porque representa a área de um triângulo.</a:t>
-            </a:r>
-            <a:endParaRPr lang="pt-BR" b="1"/>
-          </a:p>
-          <a:p>
-            <a:pPr>
-              <a:buNone/>
-            </a:pPr>
-            <a:endParaRPr lang="pt-BR" b="1" dirty="0">
-              <a:ea typeface="+mn-lt"/>
-              <a:cs typeface="+mn-lt"/>
-            </a:endParaRPr>
-          </a:p>
-          <a:p>
-            <a:pPr>
-              <a:buNone/>
-            </a:pPr>
-            <a:r>
-              <a:rPr lang="pt-BR" b="1" dirty="0">
-                <a:ea typeface="+mn-lt"/>
-                <a:cs typeface="+mn-lt"/>
-              </a:rPr>
-              <a:t>Portanto:</a:t>
-            </a:r>
-            <a:endParaRPr lang="pt-BR" b="1" dirty="0"/>
-          </a:p>
-          <a:p>
-            <a:pPr>
-              <a:buNone/>
-            </a:pPr>
-            <a:endParaRPr lang="pt-BR" dirty="0"/>
-          </a:p>
-          <a:p>
-            <a:pPr marL="0" indent="0">
-              <a:buNone/>
-            </a:pPr>
-            <a:endParaRPr lang="pt-BR" dirty="0"/>
-          </a:p>
-        </p:txBody>
-      </p:sp>
-      <p:pic>
-        <p:nvPicPr>
-          <p:cNvPr id="4" name="Imagem 3" descr="Diagrama, Gráfico de caixa estreita&#10;&#10;O conteúdo gerado por IA pode estar incorreto.">
-            <a:extLst>
-              <a:ext uri="{FF2B5EF4-FFF2-40B4-BE49-F238E27FC236}">
-                <a16:creationId xmlns:a16="http://schemas.microsoft.com/office/drawing/2014/main" id="{FF075BB3-CDBD-B4EA-B9D1-1272BAFFCA3E}"/>
+                <a16:creationId xmlns:a16="http://schemas.microsoft.com/office/drawing/2014/main" id="{1AF5B863-2A14-AAF5-E6F6-0F4225995872}"/>
               </a:ext>
             </a:extLst>
           </p:cNvPr>
@@ -4140,15 +3614,15 @@
           <p:nvPr/>
         </p:nvPicPr>
         <p:blipFill>
-          <a:blip r:embed="rId2"/>
+          <a:blip r:embed="rId3"/>
           <a:stretch>
             <a:fillRect/>
           </a:stretch>
         </p:blipFill>
         <p:spPr>
           <a:xfrm>
-            <a:off x="3225894" y="4675374"/>
-            <a:ext cx="5258360" cy="1631016"/>
+            <a:off x="4616264" y="6022601"/>
+            <a:ext cx="2959473" cy="606238"/>
           </a:xfrm>
           <a:prstGeom prst="rect">
             <a:avLst/>
@@ -4185,6 +3659,246 @@
           <a:chExt cx="0" cy="0"/>
         </a:xfrm>
       </p:grpSpPr>
+      <p:pic>
+        <p:nvPicPr>
+          <p:cNvPr id="4" name="Imagem 3" descr="Texto, Tabela&#10;&#10;O conteúdo gerado por IA pode estar incorreto.">
+            <a:extLst>
+              <a:ext uri="{FF2B5EF4-FFF2-40B4-BE49-F238E27FC236}">
+                <a16:creationId xmlns:a16="http://schemas.microsoft.com/office/drawing/2014/main" id="{53C1A71B-2341-52E0-968A-999D06C9507D}"/>
+              </a:ext>
+            </a:extLst>
+          </p:cNvPr>
+          <p:cNvPicPr>
+            <a:picLocks noChangeAspect="1"/>
+          </p:cNvPicPr>
+          <p:nvPr/>
+        </p:nvPicPr>
+        <p:blipFill>
+          <a:blip r:embed="rId2"/>
+          <a:stretch>
+            <a:fillRect/>
+          </a:stretch>
+        </p:blipFill>
+        <p:spPr>
+          <a:xfrm>
+            <a:off x="816909" y="412656"/>
+            <a:ext cx="10558181" cy="6043892"/>
+          </a:xfrm>
+          <a:prstGeom prst="rect">
+            <a:avLst/>
+          </a:prstGeom>
+        </p:spPr>
+      </p:pic>
+    </p:spTree>
+    <p:extLst>
+      <p:ext uri="{BB962C8B-B14F-4D97-AF65-F5344CB8AC3E}">
+        <p14:creationId xmlns:p14="http://schemas.microsoft.com/office/powerpoint/2010/main" val="3476188114"/>
+      </p:ext>
+    </p:extLst>
+  </p:cSld>
+  <p:clrMapOvr>
+    <a:masterClrMapping/>
+  </p:clrMapOvr>
+</p:sld>
+</file>
+
+<file path=ppt/slides/slide15.xml><?xml version="1.0" encoding="utf-8"?>
+<p:sld xmlns:a="http://schemas.openxmlformats.org/drawingml/2006/main" xmlns:r="http://schemas.openxmlformats.org/officeDocument/2006/relationships" xmlns:p="http://schemas.openxmlformats.org/presentationml/2006/main">
+  <p:cSld>
+    <p:spTree>
+      <p:nvGrpSpPr>
+        <p:cNvPr id="1" name=""/>
+        <p:cNvGrpSpPr/>
+        <p:nvPr/>
+      </p:nvGrpSpPr>
+      <p:grpSpPr>
+        <a:xfrm>
+          <a:off x="0" y="0"/>
+          <a:ext cx="0" cy="0"/>
+          <a:chOff x="0" y="0"/>
+          <a:chExt cx="0" cy="0"/>
+        </a:xfrm>
+      </p:grpSpPr>
+      <p:pic>
+        <p:nvPicPr>
+          <p:cNvPr id="4" name="Imagem 3" descr="Uma imagem contendo Diagrama&#10;&#10;O conteúdo gerado por IA pode estar incorreto.">
+            <a:extLst>
+              <a:ext uri="{FF2B5EF4-FFF2-40B4-BE49-F238E27FC236}">
+                <a16:creationId xmlns:a16="http://schemas.microsoft.com/office/drawing/2014/main" id="{DBEEF924-753E-7ED0-D35E-E4BF0D14D643}"/>
+              </a:ext>
+            </a:extLst>
+          </p:cNvPr>
+          <p:cNvPicPr>
+            <a:picLocks noChangeAspect="1"/>
+          </p:cNvPicPr>
+          <p:nvPr/>
+        </p:nvPicPr>
+        <p:blipFill>
+          <a:blip r:embed="rId2"/>
+          <a:stretch>
+            <a:fillRect/>
+          </a:stretch>
+        </p:blipFill>
+        <p:spPr>
+          <a:xfrm>
+            <a:off x="900113" y="556092"/>
+            <a:ext cx="10391774" cy="5757021"/>
+          </a:xfrm>
+          <a:prstGeom prst="rect">
+            <a:avLst/>
+          </a:prstGeom>
+        </p:spPr>
+      </p:pic>
+    </p:spTree>
+    <p:extLst>
+      <p:ext uri="{BB962C8B-B14F-4D97-AF65-F5344CB8AC3E}">
+        <p14:creationId xmlns:p14="http://schemas.microsoft.com/office/powerpoint/2010/main" val="688746372"/>
+      </p:ext>
+    </p:extLst>
+  </p:cSld>
+  <p:clrMapOvr>
+    <a:masterClrMapping/>
+  </p:clrMapOvr>
+</p:sld>
+</file>
+
+<file path=ppt/slides/slide16.xml><?xml version="1.0" encoding="utf-8"?>
+<p:sld xmlns:a="http://schemas.openxmlformats.org/drawingml/2006/main" xmlns:r="http://schemas.openxmlformats.org/officeDocument/2006/relationships" xmlns:p="http://schemas.openxmlformats.org/presentationml/2006/main">
+  <p:cSld>
+    <p:spTree>
+      <p:nvGrpSpPr>
+        <p:cNvPr id="1" name=""/>
+        <p:cNvGrpSpPr/>
+        <p:nvPr/>
+      </p:nvGrpSpPr>
+      <p:grpSpPr>
+        <a:xfrm>
+          <a:off x="0" y="0"/>
+          <a:ext cx="0" cy="0"/>
+          <a:chOff x="0" y="0"/>
+          <a:chExt cx="0" cy="0"/>
+        </a:xfrm>
+      </p:grpSpPr>
+      <p:pic>
+        <p:nvPicPr>
+          <p:cNvPr id="4" name="Imagem 3">
+            <a:extLst>
+              <a:ext uri="{FF2B5EF4-FFF2-40B4-BE49-F238E27FC236}">
+                <a16:creationId xmlns:a16="http://schemas.microsoft.com/office/drawing/2014/main" id="{6190FDC2-FD90-8AB1-0932-14E95A41CF12}"/>
+              </a:ext>
+            </a:extLst>
+          </p:cNvPr>
+          <p:cNvPicPr>
+            <a:picLocks noChangeAspect="1"/>
+          </p:cNvPicPr>
+          <p:nvPr/>
+        </p:nvPicPr>
+        <p:blipFill>
+          <a:blip r:embed="rId2"/>
+          <a:stretch>
+            <a:fillRect/>
+          </a:stretch>
+        </p:blipFill>
+        <p:spPr>
+          <a:xfrm>
+            <a:off x="961218" y="226905"/>
+            <a:ext cx="10269564" cy="6404190"/>
+          </a:xfrm>
+          <a:prstGeom prst="rect">
+            <a:avLst/>
+          </a:prstGeom>
+        </p:spPr>
+      </p:pic>
+    </p:spTree>
+    <p:extLst>
+      <p:ext uri="{BB962C8B-B14F-4D97-AF65-F5344CB8AC3E}">
+        <p14:creationId xmlns:p14="http://schemas.microsoft.com/office/powerpoint/2010/main" val="4033611569"/>
+      </p:ext>
+    </p:extLst>
+  </p:cSld>
+  <p:clrMapOvr>
+    <a:masterClrMapping/>
+  </p:clrMapOvr>
+</p:sld>
+</file>
+
+<file path=ppt/slides/slide17.xml><?xml version="1.0" encoding="utf-8"?>
+<p:sld xmlns:a="http://schemas.openxmlformats.org/drawingml/2006/main" xmlns:r="http://schemas.openxmlformats.org/officeDocument/2006/relationships" xmlns:p="http://schemas.openxmlformats.org/presentationml/2006/main">
+  <p:cSld>
+    <p:spTree>
+      <p:nvGrpSpPr>
+        <p:cNvPr id="1" name=""/>
+        <p:cNvGrpSpPr/>
+        <p:nvPr/>
+      </p:nvGrpSpPr>
+      <p:grpSpPr>
+        <a:xfrm>
+          <a:off x="0" y="0"/>
+          <a:ext cx="0" cy="0"/>
+          <a:chOff x="0" y="0"/>
+          <a:chExt cx="0" cy="0"/>
+        </a:xfrm>
+      </p:grpSpPr>
+      <p:pic>
+        <p:nvPicPr>
+          <p:cNvPr id="5" name="Imagem 4" descr="Tela de celular com texto preto sobre fundo branco&#10;&#10;O conteúdo gerado por IA pode estar incorreto.">
+            <a:extLst>
+              <a:ext uri="{FF2B5EF4-FFF2-40B4-BE49-F238E27FC236}">
+                <a16:creationId xmlns:a16="http://schemas.microsoft.com/office/drawing/2014/main" id="{00B8D45E-1EBD-FAD6-22BB-1299EEB2D517}"/>
+              </a:ext>
+            </a:extLst>
+          </p:cNvPr>
+          <p:cNvPicPr>
+            <a:picLocks noChangeAspect="1"/>
+          </p:cNvPicPr>
+          <p:nvPr/>
+        </p:nvPicPr>
+        <p:blipFill>
+          <a:blip r:embed="rId2"/>
+          <a:stretch>
+            <a:fillRect/>
+          </a:stretch>
+        </p:blipFill>
+        <p:spPr>
+          <a:xfrm>
+            <a:off x="564315" y="601205"/>
+            <a:ext cx="11063367" cy="5655588"/>
+          </a:xfrm>
+          <a:prstGeom prst="rect">
+            <a:avLst/>
+          </a:prstGeom>
+        </p:spPr>
+      </p:pic>
+    </p:spTree>
+    <p:extLst>
+      <p:ext uri="{BB962C8B-B14F-4D97-AF65-F5344CB8AC3E}">
+        <p14:creationId xmlns:p14="http://schemas.microsoft.com/office/powerpoint/2010/main" val="2350272116"/>
+      </p:ext>
+    </p:extLst>
+  </p:cSld>
+  <p:clrMapOvr>
+    <a:masterClrMapping/>
+  </p:clrMapOvr>
+</p:sld>
+</file>
+
+<file path=ppt/slides/slide18.xml><?xml version="1.0" encoding="utf-8"?>
+<p:sld xmlns:a="http://schemas.openxmlformats.org/drawingml/2006/main" xmlns:r="http://schemas.openxmlformats.org/officeDocument/2006/relationships" xmlns:p="http://schemas.openxmlformats.org/presentationml/2006/main">
+  <p:cSld>
+    <p:spTree>
+      <p:nvGrpSpPr>
+        <p:cNvPr id="1" name=""/>
+        <p:cNvGrpSpPr/>
+        <p:nvPr/>
+      </p:nvGrpSpPr>
+      <p:grpSpPr>
+        <a:xfrm>
+          <a:off x="0" y="0"/>
+          <a:ext cx="0" cy="0"/>
+          <a:chOff x="0" y="0"/>
+          <a:chExt cx="0" cy="0"/>
+        </a:xfrm>
+      </p:grpSpPr>
       <p:sp>
         <p:nvSpPr>
           <p:cNvPr id="2" name="Título 1">
@@ -4355,7 +4069,7 @@
 </p:sld>
 </file>
 
-<file path=ppt/slides/slide15.xml><?xml version="1.0" encoding="utf-8"?>
+<file path=ppt/slides/slide19.xml><?xml version="1.0" encoding="utf-8"?>
 <p:sld xmlns:a="http://schemas.openxmlformats.org/drawingml/2006/main" xmlns:r="http://schemas.openxmlformats.org/officeDocument/2006/relationships" xmlns:p="http://schemas.openxmlformats.org/presentationml/2006/main">
   <p:cSld>
     <p:spTree>
@@ -4810,592 +4524,6 @@
     <p:extLst>
       <p:ext uri="{BB962C8B-B14F-4D97-AF65-F5344CB8AC3E}">
         <p14:creationId xmlns:p14="http://schemas.microsoft.com/office/powerpoint/2010/main" val="2439332181"/>
-      </p:ext>
-    </p:extLst>
-  </p:cSld>
-  <p:clrMapOvr>
-    <a:masterClrMapping/>
-  </p:clrMapOvr>
-</p:sld>
-</file>
-
-<file path=ppt/slides/slide16.xml><?xml version="1.0" encoding="utf-8"?>
-<p:sld xmlns:a="http://schemas.openxmlformats.org/drawingml/2006/main" xmlns:r="http://schemas.openxmlformats.org/officeDocument/2006/relationships" xmlns:p="http://schemas.openxmlformats.org/presentationml/2006/main">
-  <p:cSld>
-    <p:spTree>
-      <p:nvGrpSpPr>
-        <p:cNvPr id="1" name=""/>
-        <p:cNvGrpSpPr/>
-        <p:nvPr/>
-      </p:nvGrpSpPr>
-      <p:grpSpPr>
-        <a:xfrm>
-          <a:off x="0" y="0"/>
-          <a:ext cx="0" cy="0"/>
-          <a:chOff x="0" y="0"/>
-          <a:chExt cx="0" cy="0"/>
-        </a:xfrm>
-      </p:grpSpPr>
-      <p:sp>
-        <p:nvSpPr>
-          <p:cNvPr id="2" name="Título 1">
-            <a:extLst>
-              <a:ext uri="{FF2B5EF4-FFF2-40B4-BE49-F238E27FC236}">
-                <a16:creationId xmlns:a16="http://schemas.microsoft.com/office/drawing/2014/main" id="{9D39F1E5-FFC9-C6D1-C9F5-86D2A6A8A176}"/>
-              </a:ext>
-            </a:extLst>
-          </p:cNvPr>
-          <p:cNvSpPr>
-            <a:spLocks noGrp="1"/>
-          </p:cNvSpPr>
-          <p:nvPr>
-            <p:ph type="title"/>
-          </p:nvPr>
-        </p:nvSpPr>
-        <p:spPr>
-          <a:xfrm>
-            <a:off x="233083" y="-4669"/>
-            <a:ext cx="2335306" cy="866122"/>
-          </a:xfrm>
-        </p:spPr>
-        <p:txBody>
-          <a:bodyPr/>
-          <a:lstStyle/>
-          <a:p>
-            <a:r>
-              <a:rPr lang="pt-BR" sz="2800" b="1" dirty="0">
-                <a:solidFill>
-                  <a:srgbClr val="FF0000"/>
-                </a:solidFill>
-                <a:latin typeface="Aptos"/>
-              </a:rPr>
-              <a:t>Solução :</a:t>
-            </a:r>
-            <a:endParaRPr lang="pt-BR" dirty="0"/>
-          </a:p>
-        </p:txBody>
-      </p:sp>
-      <p:sp>
-        <p:nvSpPr>
-          <p:cNvPr id="3" name="Espaço Reservado para Conteúdo 2">
-            <a:extLst>
-              <a:ext uri="{FF2B5EF4-FFF2-40B4-BE49-F238E27FC236}">
-                <a16:creationId xmlns:a16="http://schemas.microsoft.com/office/drawing/2014/main" id="{49457BC3-FFAE-7C77-1A95-E15A0899BA24}"/>
-              </a:ext>
-            </a:extLst>
-          </p:cNvPr>
-          <p:cNvSpPr>
-            <a:spLocks noGrp="1"/>
-          </p:cNvSpPr>
-          <p:nvPr>
-            <p:ph idx="1"/>
-          </p:nvPr>
-        </p:nvSpPr>
-        <p:spPr>
-          <a:xfrm>
-            <a:off x="589569" y="897639"/>
-            <a:ext cx="11019864" cy="810981"/>
-          </a:xfrm>
-        </p:spPr>
-        <p:txBody>
-          <a:bodyPr vert="horz" lIns="91440" tIns="45720" rIns="91440" bIns="45720" rtlCol="0" anchor="t">
-            <a:normAutofit fontScale="92500"/>
-          </a:bodyPr>
-          <a:lstStyle/>
-          <a:p>
-            <a:pPr marL="0" indent="0">
-              <a:buNone/>
-            </a:pPr>
-            <a:r>
-              <a:rPr lang="pt-BR" sz="2000" b="1" dirty="0">
-                <a:solidFill>
-                  <a:srgbClr val="FF0000"/>
-                </a:solidFill>
-              </a:rPr>
-              <a:t> b) O móvel passa pela origem de espaços (marco zero) quando seu espaço S=0. Na equação, </a:t>
-            </a:r>
-            <a:r>
-              <a:rPr lang="pt-BR" sz="2000" dirty="0">
-                <a:solidFill>
-                  <a:srgbClr val="FF0000"/>
-                </a:solidFill>
-                <a:latin typeface="Consolas"/>
-              </a:rPr>
-              <a:t>S = 9 + 3t − 2t²</a:t>
-            </a:r>
-            <a:r>
-              <a:rPr lang="pt-BR" sz="1200" b="1" dirty="0">
-                <a:solidFill>
-                  <a:srgbClr val="FF0000"/>
-                </a:solidFill>
-                <a:latin typeface="Aptos"/>
-              </a:rPr>
-              <a:t>, </a:t>
-            </a:r>
-            <a:r>
-              <a:rPr lang="pt-BR" sz="2000" b="1" dirty="0">
-                <a:solidFill>
-                  <a:srgbClr val="FF0000"/>
-                </a:solidFill>
-                <a:latin typeface="Aptos"/>
-              </a:rPr>
-              <a:t>sendo S=0, organizando a equação, teremos: </a:t>
-            </a:r>
-            <a:r>
-              <a:rPr lang="pt-BR" sz="2000" dirty="0">
-                <a:solidFill>
-                  <a:srgbClr val="FF0000"/>
-                </a:solidFill>
-                <a:latin typeface="Consolas"/>
-              </a:rPr>
-              <a:t>2t² − 3t − 9 = 0.</a:t>
-            </a:r>
-            <a:endParaRPr lang="pt-BR" dirty="0"/>
-          </a:p>
-          <a:p>
-            <a:pPr algn="just">
-              <a:buNone/>
-            </a:pPr>
-            <a:endParaRPr lang="pt-BR" sz="2000" dirty="0">
-              <a:solidFill>
-                <a:srgbClr val="FF0000"/>
-              </a:solidFill>
-            </a:endParaRPr>
-          </a:p>
-          <a:p>
-            <a:pPr marL="0" indent="0" algn="just">
-              <a:buNone/>
-            </a:pPr>
-            <a:endParaRPr lang="pt-BR" sz="2000" b="1" dirty="0">
-              <a:solidFill>
-                <a:srgbClr val="FF0000"/>
-              </a:solidFill>
-              <a:latin typeface="Aptos"/>
-            </a:endParaRPr>
-          </a:p>
-          <a:p>
-            <a:pPr marL="0" indent="0">
-              <a:buNone/>
-            </a:pPr>
-            <a:endParaRPr lang="pt-BR" sz="2000" dirty="0">
-              <a:solidFill>
-                <a:srgbClr val="FF0000"/>
-              </a:solidFill>
-              <a:latin typeface="Consolas"/>
-            </a:endParaRPr>
-          </a:p>
-          <a:p>
-            <a:pPr marL="0" indent="0">
-              <a:buNone/>
-            </a:pPr>
-            <a:endParaRPr lang="pt-BR" sz="2000" b="1" dirty="0">
-              <a:solidFill>
-                <a:srgbClr val="FF0000"/>
-              </a:solidFill>
-            </a:endParaRPr>
-          </a:p>
-        </p:txBody>
-      </p:sp>
-      <p:sp>
-        <p:nvSpPr>
-          <p:cNvPr id="4" name="CaixaDeTexto 3">
-            <a:extLst>
-              <a:ext uri="{FF2B5EF4-FFF2-40B4-BE49-F238E27FC236}">
-                <a16:creationId xmlns:a16="http://schemas.microsoft.com/office/drawing/2014/main" id="{5397D842-AF9C-6FE1-E39F-5CC6C5DEFF24}"/>
-              </a:ext>
-            </a:extLst>
-          </p:cNvPr>
-          <p:cNvSpPr txBox="1"/>
-          <p:nvPr/>
-        </p:nvSpPr>
-        <p:spPr>
-          <a:xfrm>
-            <a:off x="587914" y="2043876"/>
-            <a:ext cx="11013141" cy="1631216"/>
-          </a:xfrm>
-          <a:prstGeom prst="rect">
-            <a:avLst/>
-          </a:prstGeom>
-          <a:noFill/>
-        </p:spPr>
-        <p:txBody>
-          <a:bodyPr rot="0" spcFirstLastPara="0" vertOverflow="overflow" horzOverflow="overflow" vert="horz" wrap="square" lIns="91440" tIns="45720" rIns="91440" bIns="45720" numCol="1" spcCol="0" rtlCol="0" fromWordArt="0" anchor="t" anchorCtr="0" forceAA="0" compatLnSpc="1">
-            <a:prstTxWarp prst="textNoShape">
-              <a:avLst/>
-            </a:prstTxWarp>
-            <a:spAutoFit/>
-          </a:bodyPr>
-          <a:lstStyle/>
-          <a:p>
-            <a:pPr algn="just"/>
-            <a:r>
-              <a:rPr lang="pt-BR" sz="2000" b="1" dirty="0">
-                <a:solidFill>
-                  <a:srgbClr val="FF0000"/>
-                </a:solidFill>
-                <a:ea typeface="+mn-lt"/>
-                <a:cs typeface="+mn-lt"/>
-              </a:rPr>
-              <a:t> Tratando-se de uma equação de segundo grau, poderemos achar o valor correspondentes do instante achando as raízes da equação, convém observar que o valor da raiz que procuramos deve ser maior que zero, pois a função horária define apenas instantes posteriores a um evento, nesse caso o tempo igual a zero. </a:t>
-            </a:r>
-            <a:endParaRPr lang="pt-BR" sz="2000" b="1">
-              <a:solidFill>
-                <a:srgbClr val="FF0000"/>
-              </a:solidFill>
-            </a:endParaRPr>
-          </a:p>
-          <a:p>
-            <a:pPr algn="just"/>
-            <a:r>
-              <a:rPr lang="pt-BR" sz="2000" b="1">
-                <a:solidFill>
-                  <a:srgbClr val="FF0000"/>
-                </a:solidFill>
-                <a:ea typeface="+mn-lt"/>
-                <a:cs typeface="+mn-lt"/>
-              </a:rPr>
-              <a:t> </a:t>
-            </a:r>
-            <a:r>
-              <a:rPr lang="pt-BR" sz="2000" b="1" dirty="0">
-                <a:solidFill>
-                  <a:srgbClr val="FF0000"/>
-                </a:solidFill>
-                <a:ea typeface="+mn-lt"/>
-                <a:cs typeface="+mn-lt"/>
-              </a:rPr>
-              <a:t>Prosseguindo o desenvolvimento pela fórmula de Bhaskara teremos:</a:t>
-            </a:r>
-            <a:r>
-              <a:rPr lang="pt-BR" dirty="0">
-                <a:ea typeface="+mn-lt"/>
-                <a:cs typeface="+mn-lt"/>
-              </a:rPr>
-              <a:t> </a:t>
-            </a:r>
-            <a:endParaRPr lang="pt-BR" dirty="0"/>
-          </a:p>
-        </p:txBody>
-      </p:sp>
-      <p:pic>
-        <p:nvPicPr>
-          <p:cNvPr id="5" name="Imagem 4" descr="Uma imagem contendo Diagrama&#10;&#10;O conteúdo gerado por IA pode estar incorreto.">
-            <a:extLst>
-              <a:ext uri="{FF2B5EF4-FFF2-40B4-BE49-F238E27FC236}">
-                <a16:creationId xmlns:a16="http://schemas.microsoft.com/office/drawing/2014/main" id="{FBB79119-94EA-7B46-5AE6-4A5124822E41}"/>
-              </a:ext>
-            </a:extLst>
-          </p:cNvPr>
-          <p:cNvPicPr>
-            <a:picLocks noChangeAspect="1"/>
-          </p:cNvPicPr>
-          <p:nvPr/>
-        </p:nvPicPr>
-        <p:blipFill>
-          <a:blip r:embed="rId2"/>
-          <a:stretch>
-            <a:fillRect/>
-          </a:stretch>
-        </p:blipFill>
-        <p:spPr>
-          <a:xfrm>
-            <a:off x="3248025" y="3957918"/>
-            <a:ext cx="5695950" cy="1295400"/>
-          </a:xfrm>
-          <a:prstGeom prst="rect">
-            <a:avLst/>
-          </a:prstGeom>
-        </p:spPr>
-      </p:pic>
-      <p:sp>
-        <p:nvSpPr>
-          <p:cNvPr id="6" name="CaixaDeTexto 5">
-            <a:extLst>
-              <a:ext uri="{FF2B5EF4-FFF2-40B4-BE49-F238E27FC236}">
-                <a16:creationId xmlns:a16="http://schemas.microsoft.com/office/drawing/2014/main" id="{44C037D8-3730-5B74-4690-FEF266F0EE22}"/>
-              </a:ext>
-            </a:extLst>
-          </p:cNvPr>
-          <p:cNvSpPr txBox="1"/>
-          <p:nvPr/>
-        </p:nvSpPr>
-        <p:spPr>
-          <a:xfrm>
-            <a:off x="1932387" y="5701044"/>
-            <a:ext cx="8783172" cy="400110"/>
-          </a:xfrm>
-          <a:prstGeom prst="rect">
-            <a:avLst/>
-          </a:prstGeom>
-          <a:noFill/>
-        </p:spPr>
-        <p:txBody>
-          <a:bodyPr rot="0" spcFirstLastPara="0" vertOverflow="overflow" horzOverflow="overflow" vert="horz" wrap="square" lIns="91440" tIns="45720" rIns="91440" bIns="45720" numCol="1" spcCol="0" rtlCol="0" fromWordArt="0" anchor="t" anchorCtr="0" forceAA="0" compatLnSpc="1">
-            <a:prstTxWarp prst="textNoShape">
-              <a:avLst/>
-            </a:prstTxWarp>
-            <a:spAutoFit/>
-          </a:bodyPr>
-          <a:lstStyle/>
-          <a:p>
-            <a:pPr algn="just"/>
-            <a:r>
-              <a:rPr lang="pt-BR" sz="2000" b="1" dirty="0">
-                <a:solidFill>
-                  <a:srgbClr val="FF0000"/>
-                </a:solidFill>
-              </a:rPr>
-              <a:t>Resposta: </a:t>
-            </a:r>
-            <a:r>
-              <a:rPr lang="pt-BR" sz="2000" b="1" i="1" dirty="0">
-                <a:solidFill>
-                  <a:srgbClr val="FF0000"/>
-                </a:solidFill>
-              </a:rPr>
-              <a:t>t'=3s</a:t>
-            </a:r>
-            <a:r>
-              <a:rPr lang="pt-BR" sz="2000" b="1" dirty="0">
-                <a:solidFill>
-                  <a:srgbClr val="FF0000"/>
-                </a:solidFill>
-              </a:rPr>
-              <a:t>, o móvel passa pela origem no instante 3s.</a:t>
-            </a:r>
-          </a:p>
-        </p:txBody>
-      </p:sp>
-    </p:spTree>
-    <p:extLst>
-      <p:ext uri="{BB962C8B-B14F-4D97-AF65-F5344CB8AC3E}">
-        <p14:creationId xmlns:p14="http://schemas.microsoft.com/office/powerpoint/2010/main" val="73761084"/>
-      </p:ext>
-    </p:extLst>
-  </p:cSld>
-  <p:clrMapOvr>
-    <a:masterClrMapping/>
-  </p:clrMapOvr>
-</p:sld>
-</file>
-
-<file path=ppt/slides/slide17.xml><?xml version="1.0" encoding="utf-8"?>
-<p:sld xmlns:a="http://schemas.openxmlformats.org/drawingml/2006/main" xmlns:r="http://schemas.openxmlformats.org/officeDocument/2006/relationships" xmlns:p="http://schemas.openxmlformats.org/presentationml/2006/main">
-  <p:cSld>
-    <p:spTree>
-      <p:nvGrpSpPr>
-        <p:cNvPr id="1" name=""/>
-        <p:cNvGrpSpPr/>
-        <p:nvPr/>
-      </p:nvGrpSpPr>
-      <p:grpSpPr>
-        <a:xfrm>
-          <a:off x="0" y="0"/>
-          <a:ext cx="0" cy="0"/>
-          <a:chOff x="0" y="0"/>
-          <a:chExt cx="0" cy="0"/>
-        </a:xfrm>
-      </p:grpSpPr>
-      <p:sp>
-        <p:nvSpPr>
-          <p:cNvPr id="2" name="Título 1">
-            <a:extLst>
-              <a:ext uri="{FF2B5EF4-FFF2-40B4-BE49-F238E27FC236}">
-                <a16:creationId xmlns:a16="http://schemas.microsoft.com/office/drawing/2014/main" id="{4ED26C64-DCF1-0B20-6E28-399DC4EC8450}"/>
-              </a:ext>
-            </a:extLst>
-          </p:cNvPr>
-          <p:cNvSpPr>
-            <a:spLocks noGrp="1"/>
-          </p:cNvSpPr>
-          <p:nvPr>
-            <p:ph type="title"/>
-          </p:nvPr>
-        </p:nvSpPr>
-        <p:spPr/>
-        <p:txBody>
-          <a:bodyPr/>
-          <a:lstStyle/>
-          <a:p>
-            <a:r>
-              <a:rPr lang="pt-BR" dirty="0"/>
-              <a:t>Conclusão</a:t>
-            </a:r>
-          </a:p>
-        </p:txBody>
-      </p:sp>
-      <p:sp>
-        <p:nvSpPr>
-          <p:cNvPr id="3" name="Espaço Reservado para Conteúdo 2">
-            <a:extLst>
-              <a:ext uri="{FF2B5EF4-FFF2-40B4-BE49-F238E27FC236}">
-                <a16:creationId xmlns:a16="http://schemas.microsoft.com/office/drawing/2014/main" id="{B5B67827-D717-9798-7763-C4CBA3B4903C}"/>
-              </a:ext>
-            </a:extLst>
-          </p:cNvPr>
-          <p:cNvSpPr>
-            <a:spLocks noGrp="1"/>
-          </p:cNvSpPr>
-          <p:nvPr>
-            <p:ph idx="1"/>
-          </p:nvPr>
-        </p:nvSpPr>
-        <p:spPr>
-          <a:xfrm>
-            <a:off x="838200" y="2075658"/>
-            <a:ext cx="10515600" cy="3494087"/>
-          </a:xfrm>
-        </p:spPr>
-        <p:txBody>
-          <a:bodyPr vert="horz" lIns="91440" tIns="45720" rIns="91440" bIns="45720" rtlCol="0" anchor="t">
-            <a:normAutofit/>
-          </a:bodyPr>
-          <a:lstStyle/>
-          <a:p>
-            <a:pPr marL="0" indent="0" algn="just">
-              <a:buNone/>
-            </a:pPr>
-            <a:r>
-              <a:rPr lang="pt-BR" dirty="0"/>
-              <a:t> </a:t>
-            </a:r>
-            <a:r>
-              <a:rPr lang="pt-BR" b="1" dirty="0"/>
-              <a:t>As funções de primeiro e segundo grau são ferramentas indispensáveis para os cálculos Físicos, convém observar que a Física procura explicar os eventos em todas as perspectivas, aninhando cálculos e fórmulas muitas vezes de forma complexa, no entanto a Matemática e seus fundamentos são o alicerce de todo o conhecimento, dominar a matemática é dominar a arte do saber.</a:t>
-            </a:r>
-            <a:endParaRPr lang="pt-BR"/>
-          </a:p>
-        </p:txBody>
-      </p:sp>
-    </p:spTree>
-    <p:extLst>
-      <p:ext uri="{BB962C8B-B14F-4D97-AF65-F5344CB8AC3E}">
-        <p14:creationId xmlns:p14="http://schemas.microsoft.com/office/powerpoint/2010/main" val="3558005273"/>
-      </p:ext>
-    </p:extLst>
-  </p:cSld>
-  <p:clrMapOvr>
-    <a:masterClrMapping/>
-  </p:clrMapOvr>
-</p:sld>
-</file>
-
-<file path=ppt/slides/slide18.xml><?xml version="1.0" encoding="utf-8"?>
-<p:sld xmlns:a="http://schemas.openxmlformats.org/drawingml/2006/main" xmlns:r="http://schemas.openxmlformats.org/officeDocument/2006/relationships" xmlns:p="http://schemas.openxmlformats.org/presentationml/2006/main">
-  <p:cSld>
-    <p:spTree>
-      <p:nvGrpSpPr>
-        <p:cNvPr id="1" name=""/>
-        <p:cNvGrpSpPr/>
-        <p:nvPr/>
-      </p:nvGrpSpPr>
-      <p:grpSpPr>
-        <a:xfrm>
-          <a:off x="0" y="0"/>
-          <a:ext cx="0" cy="0"/>
-          <a:chOff x="0" y="0"/>
-          <a:chExt cx="0" cy="0"/>
-        </a:xfrm>
-      </p:grpSpPr>
-      <p:sp>
-        <p:nvSpPr>
-          <p:cNvPr id="2" name="Título 1">
-            <a:extLst>
-              <a:ext uri="{FF2B5EF4-FFF2-40B4-BE49-F238E27FC236}">
-                <a16:creationId xmlns:a16="http://schemas.microsoft.com/office/drawing/2014/main" id="{8D4EF041-2689-DD29-22F1-83FE7A39B02E}"/>
-              </a:ext>
-            </a:extLst>
-          </p:cNvPr>
-          <p:cNvSpPr>
-            <a:spLocks noGrp="1"/>
-          </p:cNvSpPr>
-          <p:nvPr>
-            <p:ph type="title"/>
-          </p:nvPr>
-        </p:nvSpPr>
-        <p:spPr/>
-        <p:txBody>
-          <a:bodyPr/>
-          <a:lstStyle/>
-          <a:p>
-            <a:r>
-              <a:rPr lang="pt-BR" dirty="0"/>
-              <a:t>Referências</a:t>
-            </a:r>
-          </a:p>
-        </p:txBody>
-      </p:sp>
-      <p:sp>
-        <p:nvSpPr>
-          <p:cNvPr id="3" name="Espaço Reservado para Conteúdo 2">
-            <a:extLst>
-              <a:ext uri="{FF2B5EF4-FFF2-40B4-BE49-F238E27FC236}">
-                <a16:creationId xmlns:a16="http://schemas.microsoft.com/office/drawing/2014/main" id="{4306702C-EEB1-E495-8400-3DD2097D7CA0}"/>
-              </a:ext>
-            </a:extLst>
-          </p:cNvPr>
-          <p:cNvSpPr>
-            <a:spLocks noGrp="1"/>
-          </p:cNvSpPr>
-          <p:nvPr>
-            <p:ph idx="1"/>
-          </p:nvPr>
-        </p:nvSpPr>
-        <p:spPr/>
-        <p:txBody>
-          <a:bodyPr vert="horz" lIns="91440" tIns="45720" rIns="91440" bIns="45720" rtlCol="0" anchor="t">
-            <a:normAutofit/>
-          </a:bodyPr>
-          <a:lstStyle/>
-          <a:p>
-            <a:pPr algn="just"/>
-            <a:r>
-              <a:rPr lang="pt-BR" sz="2000" b="1" dirty="0"/>
-              <a:t>ChatGPT,</a:t>
-            </a:r>
-          </a:p>
-          <a:p>
-            <a:pPr algn="just"/>
-            <a:r>
-              <a:rPr lang="pt-BR" sz="2000" b="1" dirty="0"/>
-              <a:t>Microsoft </a:t>
-            </a:r>
-            <a:r>
-              <a:rPr lang="pt-BR" sz="2000" b="1" err="1"/>
-              <a:t>copilot</a:t>
-            </a:r>
-            <a:r>
-              <a:rPr lang="pt-BR" sz="2000" b="1" dirty="0"/>
-              <a:t>,</a:t>
-            </a:r>
-          </a:p>
-          <a:p>
-            <a:pPr algn="just"/>
-            <a:r>
-              <a:rPr lang="pt-BR" sz="2000" b="1" dirty="0"/>
-              <a:t>Google AI,</a:t>
-            </a:r>
-          </a:p>
-          <a:p>
-            <a:pPr algn="just"/>
-            <a:endParaRPr lang="pt-BR" sz="2000" b="1" dirty="0"/>
-          </a:p>
-          <a:p>
-            <a:pPr algn="just"/>
-            <a:r>
-              <a:rPr lang="pt-BR" sz="2000" b="1" dirty="0"/>
-              <a:t>Os fundamentos da Física, Ramalho, Ivan, Nicolau, Toledo. Volume um, mecânica, páginas 44,45. (exercícios resolvidos, R.14).</a:t>
-            </a:r>
-          </a:p>
-          <a:p>
-            <a:endParaRPr lang="pt-BR" dirty="0"/>
-          </a:p>
-        </p:txBody>
-      </p:sp>
-    </p:spTree>
-    <p:extLst>
-      <p:ext uri="{BB962C8B-B14F-4D97-AF65-F5344CB8AC3E}">
-        <p14:creationId xmlns:p14="http://schemas.microsoft.com/office/powerpoint/2010/main" val="1113526587"/>
       </p:ext>
     </p:extLst>
   </p:cSld>
@@ -5671,6 +4799,592 @@
     <p:extLst>
       <p:ext uri="{BB962C8B-B14F-4D97-AF65-F5344CB8AC3E}">
         <p14:creationId xmlns:p14="http://schemas.microsoft.com/office/powerpoint/2010/main" val="187821939"/>
+      </p:ext>
+    </p:extLst>
+  </p:cSld>
+  <p:clrMapOvr>
+    <a:masterClrMapping/>
+  </p:clrMapOvr>
+</p:sld>
+</file>
+
+<file path=ppt/slides/slide20.xml><?xml version="1.0" encoding="utf-8"?>
+<p:sld xmlns:a="http://schemas.openxmlformats.org/drawingml/2006/main" xmlns:r="http://schemas.openxmlformats.org/officeDocument/2006/relationships" xmlns:p="http://schemas.openxmlformats.org/presentationml/2006/main">
+  <p:cSld>
+    <p:spTree>
+      <p:nvGrpSpPr>
+        <p:cNvPr id="1" name=""/>
+        <p:cNvGrpSpPr/>
+        <p:nvPr/>
+      </p:nvGrpSpPr>
+      <p:grpSpPr>
+        <a:xfrm>
+          <a:off x="0" y="0"/>
+          <a:ext cx="0" cy="0"/>
+          <a:chOff x="0" y="0"/>
+          <a:chExt cx="0" cy="0"/>
+        </a:xfrm>
+      </p:grpSpPr>
+      <p:sp>
+        <p:nvSpPr>
+          <p:cNvPr id="2" name="Título 1">
+            <a:extLst>
+              <a:ext uri="{FF2B5EF4-FFF2-40B4-BE49-F238E27FC236}">
+                <a16:creationId xmlns:a16="http://schemas.microsoft.com/office/drawing/2014/main" id="{9D39F1E5-FFC9-C6D1-C9F5-86D2A6A8A176}"/>
+              </a:ext>
+            </a:extLst>
+          </p:cNvPr>
+          <p:cNvSpPr>
+            <a:spLocks noGrp="1"/>
+          </p:cNvSpPr>
+          <p:nvPr>
+            <p:ph type="title"/>
+          </p:nvPr>
+        </p:nvSpPr>
+        <p:spPr>
+          <a:xfrm>
+            <a:off x="233083" y="-4669"/>
+            <a:ext cx="2335306" cy="866122"/>
+          </a:xfrm>
+        </p:spPr>
+        <p:txBody>
+          <a:bodyPr/>
+          <a:lstStyle/>
+          <a:p>
+            <a:r>
+              <a:rPr lang="pt-BR" sz="2800" b="1" dirty="0">
+                <a:solidFill>
+                  <a:srgbClr val="FF0000"/>
+                </a:solidFill>
+                <a:latin typeface="Aptos"/>
+              </a:rPr>
+              <a:t>Solução :</a:t>
+            </a:r>
+            <a:endParaRPr lang="pt-BR" dirty="0"/>
+          </a:p>
+        </p:txBody>
+      </p:sp>
+      <p:sp>
+        <p:nvSpPr>
+          <p:cNvPr id="3" name="Espaço Reservado para Conteúdo 2">
+            <a:extLst>
+              <a:ext uri="{FF2B5EF4-FFF2-40B4-BE49-F238E27FC236}">
+                <a16:creationId xmlns:a16="http://schemas.microsoft.com/office/drawing/2014/main" id="{49457BC3-FFAE-7C77-1A95-E15A0899BA24}"/>
+              </a:ext>
+            </a:extLst>
+          </p:cNvPr>
+          <p:cNvSpPr>
+            <a:spLocks noGrp="1"/>
+          </p:cNvSpPr>
+          <p:nvPr>
+            <p:ph idx="1"/>
+          </p:nvPr>
+        </p:nvSpPr>
+        <p:spPr>
+          <a:xfrm>
+            <a:off x="589569" y="897639"/>
+            <a:ext cx="11019864" cy="810981"/>
+          </a:xfrm>
+        </p:spPr>
+        <p:txBody>
+          <a:bodyPr vert="horz" lIns="91440" tIns="45720" rIns="91440" bIns="45720" rtlCol="0" anchor="t">
+            <a:normAutofit fontScale="92500"/>
+          </a:bodyPr>
+          <a:lstStyle/>
+          <a:p>
+            <a:pPr marL="0" indent="0">
+              <a:buNone/>
+            </a:pPr>
+            <a:r>
+              <a:rPr lang="pt-BR" sz="2000" b="1" dirty="0">
+                <a:solidFill>
+                  <a:srgbClr val="FF0000"/>
+                </a:solidFill>
+              </a:rPr>
+              <a:t> b) O móvel passa pela origem de espaços (marco zero) quando seu espaço S=0. Na equação, </a:t>
+            </a:r>
+            <a:r>
+              <a:rPr lang="pt-BR" sz="2000" dirty="0">
+                <a:solidFill>
+                  <a:srgbClr val="FF0000"/>
+                </a:solidFill>
+                <a:latin typeface="Consolas"/>
+              </a:rPr>
+              <a:t>S = 9 + 3t − 2t²</a:t>
+            </a:r>
+            <a:r>
+              <a:rPr lang="pt-BR" sz="1200" b="1" dirty="0">
+                <a:solidFill>
+                  <a:srgbClr val="FF0000"/>
+                </a:solidFill>
+                <a:latin typeface="Aptos"/>
+              </a:rPr>
+              <a:t>, </a:t>
+            </a:r>
+            <a:r>
+              <a:rPr lang="pt-BR" sz="2000" b="1" dirty="0">
+                <a:solidFill>
+                  <a:srgbClr val="FF0000"/>
+                </a:solidFill>
+                <a:latin typeface="Aptos"/>
+              </a:rPr>
+              <a:t>sendo S=0, organizando a equação, teremos: </a:t>
+            </a:r>
+            <a:r>
+              <a:rPr lang="pt-BR" sz="2000" dirty="0">
+                <a:solidFill>
+                  <a:srgbClr val="FF0000"/>
+                </a:solidFill>
+                <a:latin typeface="Consolas"/>
+              </a:rPr>
+              <a:t>2t² − 3t − 9 = 0.</a:t>
+            </a:r>
+            <a:endParaRPr lang="pt-BR" dirty="0"/>
+          </a:p>
+          <a:p>
+            <a:pPr algn="just">
+              <a:buNone/>
+            </a:pPr>
+            <a:endParaRPr lang="pt-BR" sz="2000" dirty="0">
+              <a:solidFill>
+                <a:srgbClr val="FF0000"/>
+              </a:solidFill>
+            </a:endParaRPr>
+          </a:p>
+          <a:p>
+            <a:pPr marL="0" indent="0" algn="just">
+              <a:buNone/>
+            </a:pPr>
+            <a:endParaRPr lang="pt-BR" sz="2000" b="1" dirty="0">
+              <a:solidFill>
+                <a:srgbClr val="FF0000"/>
+              </a:solidFill>
+              <a:latin typeface="Aptos"/>
+            </a:endParaRPr>
+          </a:p>
+          <a:p>
+            <a:pPr marL="0" indent="0">
+              <a:buNone/>
+            </a:pPr>
+            <a:endParaRPr lang="pt-BR" sz="2000" dirty="0">
+              <a:solidFill>
+                <a:srgbClr val="FF0000"/>
+              </a:solidFill>
+              <a:latin typeface="Consolas"/>
+            </a:endParaRPr>
+          </a:p>
+          <a:p>
+            <a:pPr marL="0" indent="0">
+              <a:buNone/>
+            </a:pPr>
+            <a:endParaRPr lang="pt-BR" sz="2000" b="1" dirty="0">
+              <a:solidFill>
+                <a:srgbClr val="FF0000"/>
+              </a:solidFill>
+            </a:endParaRPr>
+          </a:p>
+        </p:txBody>
+      </p:sp>
+      <p:sp>
+        <p:nvSpPr>
+          <p:cNvPr id="4" name="CaixaDeTexto 3">
+            <a:extLst>
+              <a:ext uri="{FF2B5EF4-FFF2-40B4-BE49-F238E27FC236}">
+                <a16:creationId xmlns:a16="http://schemas.microsoft.com/office/drawing/2014/main" id="{5397D842-AF9C-6FE1-E39F-5CC6C5DEFF24}"/>
+              </a:ext>
+            </a:extLst>
+          </p:cNvPr>
+          <p:cNvSpPr txBox="1"/>
+          <p:nvPr/>
+        </p:nvSpPr>
+        <p:spPr>
+          <a:xfrm>
+            <a:off x="587914" y="2043876"/>
+            <a:ext cx="11013141" cy="1631216"/>
+          </a:xfrm>
+          <a:prstGeom prst="rect">
+            <a:avLst/>
+          </a:prstGeom>
+          <a:noFill/>
+        </p:spPr>
+        <p:txBody>
+          <a:bodyPr rot="0" spcFirstLastPara="0" vertOverflow="overflow" horzOverflow="overflow" vert="horz" wrap="square" lIns="91440" tIns="45720" rIns="91440" bIns="45720" numCol="1" spcCol="0" rtlCol="0" fromWordArt="0" anchor="t" anchorCtr="0" forceAA="0" compatLnSpc="1">
+            <a:prstTxWarp prst="textNoShape">
+              <a:avLst/>
+            </a:prstTxWarp>
+            <a:spAutoFit/>
+          </a:bodyPr>
+          <a:lstStyle/>
+          <a:p>
+            <a:pPr algn="just"/>
+            <a:r>
+              <a:rPr lang="pt-BR" sz="2000" b="1" dirty="0">
+                <a:solidFill>
+                  <a:srgbClr val="FF0000"/>
+                </a:solidFill>
+                <a:ea typeface="+mn-lt"/>
+                <a:cs typeface="+mn-lt"/>
+              </a:rPr>
+              <a:t> Tratando-se de uma equação de segundo grau, poderemos achar o valor correspondentes do instante achando as raízes da equação, convém observar que o valor da raiz que procuramos deve ser maior que zero, pois a função horária define apenas instantes posteriores a um evento, nesse caso o tempo igual a zero. </a:t>
+            </a:r>
+            <a:endParaRPr lang="pt-BR" sz="2000" b="1">
+              <a:solidFill>
+                <a:srgbClr val="FF0000"/>
+              </a:solidFill>
+            </a:endParaRPr>
+          </a:p>
+          <a:p>
+            <a:pPr algn="just"/>
+            <a:r>
+              <a:rPr lang="pt-BR" sz="2000" b="1">
+                <a:solidFill>
+                  <a:srgbClr val="FF0000"/>
+                </a:solidFill>
+                <a:ea typeface="+mn-lt"/>
+                <a:cs typeface="+mn-lt"/>
+              </a:rPr>
+              <a:t> </a:t>
+            </a:r>
+            <a:r>
+              <a:rPr lang="pt-BR" sz="2000" b="1" dirty="0">
+                <a:solidFill>
+                  <a:srgbClr val="FF0000"/>
+                </a:solidFill>
+                <a:ea typeface="+mn-lt"/>
+                <a:cs typeface="+mn-lt"/>
+              </a:rPr>
+              <a:t>Prosseguindo o desenvolvimento pela fórmula de Bhaskara teremos:</a:t>
+            </a:r>
+            <a:r>
+              <a:rPr lang="pt-BR" dirty="0">
+                <a:ea typeface="+mn-lt"/>
+                <a:cs typeface="+mn-lt"/>
+              </a:rPr>
+              <a:t> </a:t>
+            </a:r>
+            <a:endParaRPr lang="pt-BR" dirty="0"/>
+          </a:p>
+        </p:txBody>
+      </p:sp>
+      <p:pic>
+        <p:nvPicPr>
+          <p:cNvPr id="5" name="Imagem 4" descr="Uma imagem contendo Diagrama&#10;&#10;O conteúdo gerado por IA pode estar incorreto.">
+            <a:extLst>
+              <a:ext uri="{FF2B5EF4-FFF2-40B4-BE49-F238E27FC236}">
+                <a16:creationId xmlns:a16="http://schemas.microsoft.com/office/drawing/2014/main" id="{FBB79119-94EA-7B46-5AE6-4A5124822E41}"/>
+              </a:ext>
+            </a:extLst>
+          </p:cNvPr>
+          <p:cNvPicPr>
+            <a:picLocks noChangeAspect="1"/>
+          </p:cNvPicPr>
+          <p:nvPr/>
+        </p:nvPicPr>
+        <p:blipFill>
+          <a:blip r:embed="rId2"/>
+          <a:stretch>
+            <a:fillRect/>
+          </a:stretch>
+        </p:blipFill>
+        <p:spPr>
+          <a:xfrm>
+            <a:off x="3248025" y="3957918"/>
+            <a:ext cx="5695950" cy="1295400"/>
+          </a:xfrm>
+          <a:prstGeom prst="rect">
+            <a:avLst/>
+          </a:prstGeom>
+        </p:spPr>
+      </p:pic>
+      <p:sp>
+        <p:nvSpPr>
+          <p:cNvPr id="6" name="CaixaDeTexto 5">
+            <a:extLst>
+              <a:ext uri="{FF2B5EF4-FFF2-40B4-BE49-F238E27FC236}">
+                <a16:creationId xmlns:a16="http://schemas.microsoft.com/office/drawing/2014/main" id="{44C037D8-3730-5B74-4690-FEF266F0EE22}"/>
+              </a:ext>
+            </a:extLst>
+          </p:cNvPr>
+          <p:cNvSpPr txBox="1"/>
+          <p:nvPr/>
+        </p:nvSpPr>
+        <p:spPr>
+          <a:xfrm>
+            <a:off x="1932387" y="5701044"/>
+            <a:ext cx="8783172" cy="400110"/>
+          </a:xfrm>
+          <a:prstGeom prst="rect">
+            <a:avLst/>
+          </a:prstGeom>
+          <a:noFill/>
+        </p:spPr>
+        <p:txBody>
+          <a:bodyPr rot="0" spcFirstLastPara="0" vertOverflow="overflow" horzOverflow="overflow" vert="horz" wrap="square" lIns="91440" tIns="45720" rIns="91440" bIns="45720" numCol="1" spcCol="0" rtlCol="0" fromWordArt="0" anchor="t" anchorCtr="0" forceAA="0" compatLnSpc="1">
+            <a:prstTxWarp prst="textNoShape">
+              <a:avLst/>
+            </a:prstTxWarp>
+            <a:spAutoFit/>
+          </a:bodyPr>
+          <a:lstStyle/>
+          <a:p>
+            <a:pPr algn="just"/>
+            <a:r>
+              <a:rPr lang="pt-BR" sz="2000" b="1" dirty="0">
+                <a:solidFill>
+                  <a:srgbClr val="FF0000"/>
+                </a:solidFill>
+              </a:rPr>
+              <a:t>Resposta: </a:t>
+            </a:r>
+            <a:r>
+              <a:rPr lang="pt-BR" sz="2000" b="1" i="1" dirty="0">
+                <a:solidFill>
+                  <a:srgbClr val="FF0000"/>
+                </a:solidFill>
+              </a:rPr>
+              <a:t>t'=3s</a:t>
+            </a:r>
+            <a:r>
+              <a:rPr lang="pt-BR" sz="2000" b="1" dirty="0">
+                <a:solidFill>
+                  <a:srgbClr val="FF0000"/>
+                </a:solidFill>
+              </a:rPr>
+              <a:t>, o móvel passa pela origem no instante 3s.</a:t>
+            </a:r>
+          </a:p>
+        </p:txBody>
+      </p:sp>
+    </p:spTree>
+    <p:extLst>
+      <p:ext uri="{BB962C8B-B14F-4D97-AF65-F5344CB8AC3E}">
+        <p14:creationId xmlns:p14="http://schemas.microsoft.com/office/powerpoint/2010/main" val="73761084"/>
+      </p:ext>
+    </p:extLst>
+  </p:cSld>
+  <p:clrMapOvr>
+    <a:masterClrMapping/>
+  </p:clrMapOvr>
+</p:sld>
+</file>
+
+<file path=ppt/slides/slide21.xml><?xml version="1.0" encoding="utf-8"?>
+<p:sld xmlns:a="http://schemas.openxmlformats.org/drawingml/2006/main" xmlns:r="http://schemas.openxmlformats.org/officeDocument/2006/relationships" xmlns:p="http://schemas.openxmlformats.org/presentationml/2006/main">
+  <p:cSld>
+    <p:spTree>
+      <p:nvGrpSpPr>
+        <p:cNvPr id="1" name=""/>
+        <p:cNvGrpSpPr/>
+        <p:nvPr/>
+      </p:nvGrpSpPr>
+      <p:grpSpPr>
+        <a:xfrm>
+          <a:off x="0" y="0"/>
+          <a:ext cx="0" cy="0"/>
+          <a:chOff x="0" y="0"/>
+          <a:chExt cx="0" cy="0"/>
+        </a:xfrm>
+      </p:grpSpPr>
+      <p:sp>
+        <p:nvSpPr>
+          <p:cNvPr id="2" name="Título 1">
+            <a:extLst>
+              <a:ext uri="{FF2B5EF4-FFF2-40B4-BE49-F238E27FC236}">
+                <a16:creationId xmlns:a16="http://schemas.microsoft.com/office/drawing/2014/main" id="{4ED26C64-DCF1-0B20-6E28-399DC4EC8450}"/>
+              </a:ext>
+            </a:extLst>
+          </p:cNvPr>
+          <p:cNvSpPr>
+            <a:spLocks noGrp="1"/>
+          </p:cNvSpPr>
+          <p:nvPr>
+            <p:ph type="title"/>
+          </p:nvPr>
+        </p:nvSpPr>
+        <p:spPr/>
+        <p:txBody>
+          <a:bodyPr/>
+          <a:lstStyle/>
+          <a:p>
+            <a:r>
+              <a:rPr lang="pt-BR" dirty="0"/>
+              <a:t>Conclusão</a:t>
+            </a:r>
+          </a:p>
+        </p:txBody>
+      </p:sp>
+      <p:sp>
+        <p:nvSpPr>
+          <p:cNvPr id="3" name="Espaço Reservado para Conteúdo 2">
+            <a:extLst>
+              <a:ext uri="{FF2B5EF4-FFF2-40B4-BE49-F238E27FC236}">
+                <a16:creationId xmlns:a16="http://schemas.microsoft.com/office/drawing/2014/main" id="{B5B67827-D717-9798-7763-C4CBA3B4903C}"/>
+              </a:ext>
+            </a:extLst>
+          </p:cNvPr>
+          <p:cNvSpPr>
+            <a:spLocks noGrp="1"/>
+          </p:cNvSpPr>
+          <p:nvPr>
+            <p:ph idx="1"/>
+          </p:nvPr>
+        </p:nvSpPr>
+        <p:spPr>
+          <a:xfrm>
+            <a:off x="838200" y="2075658"/>
+            <a:ext cx="10515600" cy="3494087"/>
+          </a:xfrm>
+        </p:spPr>
+        <p:txBody>
+          <a:bodyPr vert="horz" lIns="91440" tIns="45720" rIns="91440" bIns="45720" rtlCol="0" anchor="t">
+            <a:normAutofit/>
+          </a:bodyPr>
+          <a:lstStyle/>
+          <a:p>
+            <a:pPr marL="0" indent="0" algn="just">
+              <a:buNone/>
+            </a:pPr>
+            <a:r>
+              <a:rPr lang="pt-BR" dirty="0"/>
+              <a:t> </a:t>
+            </a:r>
+            <a:r>
+              <a:rPr lang="pt-BR" b="1" dirty="0"/>
+              <a:t>As funções de primeiro e segundo grau são ferramentas indispensáveis para os cálculos Físicos, convém observar que a Física procura explicar os eventos em todas as perspectivas, aninhando cálculos e fórmulas muitas vezes de forma complexa, no entanto a Matemática e seus fundamentos são o alicerce de todo o conhecimento, dominar a matemática é dominar a arte do saber.</a:t>
+            </a:r>
+            <a:endParaRPr lang="pt-BR"/>
+          </a:p>
+        </p:txBody>
+      </p:sp>
+    </p:spTree>
+    <p:extLst>
+      <p:ext uri="{BB962C8B-B14F-4D97-AF65-F5344CB8AC3E}">
+        <p14:creationId xmlns:p14="http://schemas.microsoft.com/office/powerpoint/2010/main" val="3558005273"/>
+      </p:ext>
+    </p:extLst>
+  </p:cSld>
+  <p:clrMapOvr>
+    <a:masterClrMapping/>
+  </p:clrMapOvr>
+</p:sld>
+</file>
+
+<file path=ppt/slides/slide22.xml><?xml version="1.0" encoding="utf-8"?>
+<p:sld xmlns:a="http://schemas.openxmlformats.org/drawingml/2006/main" xmlns:r="http://schemas.openxmlformats.org/officeDocument/2006/relationships" xmlns:p="http://schemas.openxmlformats.org/presentationml/2006/main">
+  <p:cSld>
+    <p:spTree>
+      <p:nvGrpSpPr>
+        <p:cNvPr id="1" name=""/>
+        <p:cNvGrpSpPr/>
+        <p:nvPr/>
+      </p:nvGrpSpPr>
+      <p:grpSpPr>
+        <a:xfrm>
+          <a:off x="0" y="0"/>
+          <a:ext cx="0" cy="0"/>
+          <a:chOff x="0" y="0"/>
+          <a:chExt cx="0" cy="0"/>
+        </a:xfrm>
+      </p:grpSpPr>
+      <p:sp>
+        <p:nvSpPr>
+          <p:cNvPr id="2" name="Título 1">
+            <a:extLst>
+              <a:ext uri="{FF2B5EF4-FFF2-40B4-BE49-F238E27FC236}">
+                <a16:creationId xmlns:a16="http://schemas.microsoft.com/office/drawing/2014/main" id="{8D4EF041-2689-DD29-22F1-83FE7A39B02E}"/>
+              </a:ext>
+            </a:extLst>
+          </p:cNvPr>
+          <p:cNvSpPr>
+            <a:spLocks noGrp="1"/>
+          </p:cNvSpPr>
+          <p:nvPr>
+            <p:ph type="title"/>
+          </p:nvPr>
+        </p:nvSpPr>
+        <p:spPr/>
+        <p:txBody>
+          <a:bodyPr/>
+          <a:lstStyle/>
+          <a:p>
+            <a:r>
+              <a:rPr lang="pt-BR" dirty="0"/>
+              <a:t>Referências</a:t>
+            </a:r>
+          </a:p>
+        </p:txBody>
+      </p:sp>
+      <p:sp>
+        <p:nvSpPr>
+          <p:cNvPr id="3" name="Espaço Reservado para Conteúdo 2">
+            <a:extLst>
+              <a:ext uri="{FF2B5EF4-FFF2-40B4-BE49-F238E27FC236}">
+                <a16:creationId xmlns:a16="http://schemas.microsoft.com/office/drawing/2014/main" id="{4306702C-EEB1-E495-8400-3DD2097D7CA0}"/>
+              </a:ext>
+            </a:extLst>
+          </p:cNvPr>
+          <p:cNvSpPr>
+            <a:spLocks noGrp="1"/>
+          </p:cNvSpPr>
+          <p:nvPr>
+            <p:ph idx="1"/>
+          </p:nvPr>
+        </p:nvSpPr>
+        <p:spPr/>
+        <p:txBody>
+          <a:bodyPr vert="horz" lIns="91440" tIns="45720" rIns="91440" bIns="45720" rtlCol="0" anchor="t">
+            <a:normAutofit/>
+          </a:bodyPr>
+          <a:lstStyle/>
+          <a:p>
+            <a:pPr algn="just"/>
+            <a:r>
+              <a:rPr lang="pt-BR" sz="2000" b="1" dirty="0"/>
+              <a:t>ChatGPT,</a:t>
+            </a:r>
+          </a:p>
+          <a:p>
+            <a:pPr algn="just"/>
+            <a:r>
+              <a:rPr lang="pt-BR" sz="2000" b="1" dirty="0"/>
+              <a:t>Microsoft </a:t>
+            </a:r>
+            <a:r>
+              <a:rPr lang="pt-BR" sz="2000" b="1" err="1"/>
+              <a:t>copilot</a:t>
+            </a:r>
+            <a:r>
+              <a:rPr lang="pt-BR" sz="2000" b="1" dirty="0"/>
+              <a:t>,</a:t>
+            </a:r>
+          </a:p>
+          <a:p>
+            <a:pPr algn="just"/>
+            <a:r>
+              <a:rPr lang="pt-BR" sz="2000" b="1" dirty="0"/>
+              <a:t>Google AI,</a:t>
+            </a:r>
+          </a:p>
+          <a:p>
+            <a:pPr algn="just"/>
+            <a:endParaRPr lang="pt-BR" sz="2000" b="1" dirty="0"/>
+          </a:p>
+          <a:p>
+            <a:pPr algn="just"/>
+            <a:r>
+              <a:rPr lang="pt-BR" sz="2000" b="1" dirty="0"/>
+              <a:t>Os fundamentos da Física, Ramalho, Ivan, Nicolau, Toledo. Volume um, mecânica, páginas 44,45. (exercícios resolvidos, R.14).</a:t>
+            </a:r>
+          </a:p>
+          <a:p>
+            <a:endParaRPr lang="pt-BR" dirty="0"/>
+          </a:p>
+        </p:txBody>
+      </p:sp>
+    </p:spTree>
+    <p:extLst>
+      <p:ext uri="{BB962C8B-B14F-4D97-AF65-F5344CB8AC3E}">
+        <p14:creationId xmlns:p14="http://schemas.microsoft.com/office/powerpoint/2010/main" val="1113526587"/>
       </p:ext>
     </p:extLst>
   </p:cSld>

</xml_diff>

<commit_message>
commit Finalizacao Do trabalho de matemática
</commit_message>
<xml_diff>
--- a/Downloads/Matematica Fundamental.pptx
+++ b/Downloads/Matematica Fundamental.pptx
@@ -24,9 +24,11 @@
     <p:sldId id="277" r:id="rId18"/>
     <p:sldId id="269" r:id="rId19"/>
     <p:sldId id="270" r:id="rId20"/>
-    <p:sldId id="271" r:id="rId21"/>
-    <p:sldId id="272" r:id="rId22"/>
-    <p:sldId id="273" r:id="rId23"/>
+    <p:sldId id="278" r:id="rId21"/>
+    <p:sldId id="271" r:id="rId22"/>
+    <p:sldId id="279" r:id="rId23"/>
+    <p:sldId id="272" r:id="rId24"/>
+    <p:sldId id="273" r:id="rId25"/>
   </p:sldIdLst>
   <p:sldSz cx="12192000" cy="6858000"/>
   <p:notesSz cx="6858000" cy="9144000"/>
@@ -137,6 +139,8 @@
 <p1510:revInfo xmlns:a="http://schemas.openxmlformats.org/drawingml/2006/main" xmlns:r="http://schemas.openxmlformats.org/officeDocument/2006/relationships" xmlns:p1510="http://schemas.microsoft.com/office/powerpoint/2015/10/main">
   <p1510:revLst>
     <p1510:client id="{6E2347CC-3A19-4E5C-B610-004F2E4A0D56}" v="126" dt="2025-11-26T09:21:21.397"/>
+    <p1510:client id="{CF99255D-5809-4BC2-9D89-5BE2FC3D6CA6}" v="38" dt="2025-11-28T05:09:15.579"/>
+    <p1510:client id="{D6662D95-27E0-49F2-BDDD-C19C0C9D094A}" v="41" dt="2025-11-28T05:03:49.372"/>
   </p1510:revLst>
 </p1510:revInfo>
 </file>
@@ -272,7 +276,7 @@
           <a:p>
             <a:fld id="{F0E51C7C-CEA3-4CAA-BE4B-344879E7C377}" type="datetimeFigureOut">
               <a:rPr lang="de-DE" smtClean="0"/>
-              <a:t>26.11.2025</a:t>
+              <a:t>27.11.2025</a:t>
             </a:fld>
             <a:endParaRPr lang="de-DE"/>
           </a:p>
@@ -442,7 +446,7 @@
           <a:p>
             <a:fld id="{F0E51C7C-CEA3-4CAA-BE4B-344879E7C377}" type="datetimeFigureOut">
               <a:rPr lang="de-DE" smtClean="0"/>
-              <a:t>26.11.2025</a:t>
+              <a:t>27.11.2025</a:t>
             </a:fld>
             <a:endParaRPr lang="de-DE"/>
           </a:p>
@@ -622,7 +626,7 @@
           <a:p>
             <a:fld id="{F0E51C7C-CEA3-4CAA-BE4B-344879E7C377}" type="datetimeFigureOut">
               <a:rPr lang="de-DE" smtClean="0"/>
-              <a:t>26.11.2025</a:t>
+              <a:t>27.11.2025</a:t>
             </a:fld>
             <a:endParaRPr lang="de-DE"/>
           </a:p>
@@ -792,7 +796,7 @@
           <a:p>
             <a:fld id="{F0E51C7C-CEA3-4CAA-BE4B-344879E7C377}" type="datetimeFigureOut">
               <a:rPr lang="de-DE" smtClean="0"/>
-              <a:t>26.11.2025</a:t>
+              <a:t>27.11.2025</a:t>
             </a:fld>
             <a:endParaRPr lang="de-DE"/>
           </a:p>
@@ -1038,7 +1042,7 @@
           <a:p>
             <a:fld id="{F0E51C7C-CEA3-4CAA-BE4B-344879E7C377}" type="datetimeFigureOut">
               <a:rPr lang="de-DE" smtClean="0"/>
-              <a:t>26.11.2025</a:t>
+              <a:t>27.11.2025</a:t>
             </a:fld>
             <a:endParaRPr lang="de-DE"/>
           </a:p>
@@ -1270,7 +1274,7 @@
           <a:p>
             <a:fld id="{F0E51C7C-CEA3-4CAA-BE4B-344879E7C377}" type="datetimeFigureOut">
               <a:rPr lang="de-DE" smtClean="0"/>
-              <a:t>26.11.2025</a:t>
+              <a:t>27.11.2025</a:t>
             </a:fld>
             <a:endParaRPr lang="de-DE"/>
           </a:p>
@@ -1637,7 +1641,7 @@
           <a:p>
             <a:fld id="{F0E51C7C-CEA3-4CAA-BE4B-344879E7C377}" type="datetimeFigureOut">
               <a:rPr lang="de-DE" smtClean="0"/>
-              <a:t>26.11.2025</a:t>
+              <a:t>27.11.2025</a:t>
             </a:fld>
             <a:endParaRPr lang="de-DE"/>
           </a:p>
@@ -1755,7 +1759,7 @@
           <a:p>
             <a:fld id="{F0E51C7C-CEA3-4CAA-BE4B-344879E7C377}" type="datetimeFigureOut">
               <a:rPr lang="de-DE" smtClean="0"/>
-              <a:t>26.11.2025</a:t>
+              <a:t>27.11.2025</a:t>
             </a:fld>
             <a:endParaRPr lang="de-DE"/>
           </a:p>
@@ -1850,7 +1854,7 @@
           <a:p>
             <a:fld id="{F0E51C7C-CEA3-4CAA-BE4B-344879E7C377}" type="datetimeFigureOut">
               <a:rPr lang="de-DE" smtClean="0"/>
-              <a:t>26.11.2025</a:t>
+              <a:t>27.11.2025</a:t>
             </a:fld>
             <a:endParaRPr lang="de-DE"/>
           </a:p>
@@ -2127,7 +2131,7 @@
           <a:p>
             <a:fld id="{F0E51C7C-CEA3-4CAA-BE4B-344879E7C377}" type="datetimeFigureOut">
               <a:rPr lang="de-DE" smtClean="0"/>
-              <a:t>26.11.2025</a:t>
+              <a:t>27.11.2025</a:t>
             </a:fld>
             <a:endParaRPr lang="de-DE"/>
           </a:p>
@@ -2380,7 +2384,7 @@
           <a:p>
             <a:fld id="{F0E51C7C-CEA3-4CAA-BE4B-344879E7C377}" type="datetimeFigureOut">
               <a:rPr lang="de-DE" smtClean="0"/>
-              <a:t>26.11.2025</a:t>
+              <a:t>27.11.2025</a:t>
             </a:fld>
             <a:endParaRPr lang="de-DE"/>
           </a:p>
@@ -2599,7 +2603,7 @@
           <a:p>
             <a:fld id="{F0E51C7C-CEA3-4CAA-BE4B-344879E7C377}" type="datetimeFigureOut">
               <a:rPr lang="de-DE" smtClean="0"/>
-              <a:t>26.11.2025</a:t>
+              <a:t>27.11.2025</a:t>
             </a:fld>
             <a:endParaRPr lang="de-DE"/>
           </a:p>
@@ -4830,6 +4834,105 @@
           <p:cNvPr id="2" name="Título 1">
             <a:extLst>
               <a:ext uri="{FF2B5EF4-FFF2-40B4-BE49-F238E27FC236}">
+                <a16:creationId xmlns:a16="http://schemas.microsoft.com/office/drawing/2014/main" id="{E94E2F16-43D0-E607-009E-944AA205BBDC}"/>
+              </a:ext>
+            </a:extLst>
+          </p:cNvPr>
+          <p:cNvSpPr>
+            <a:spLocks noGrp="1"/>
+          </p:cNvSpPr>
+          <p:nvPr>
+            <p:ph type="title"/>
+          </p:nvPr>
+        </p:nvSpPr>
+        <p:spPr>
+          <a:xfrm>
+            <a:off x="3779044" y="246063"/>
+            <a:ext cx="4645819" cy="801689"/>
+          </a:xfrm>
+        </p:spPr>
+        <p:txBody>
+          <a:bodyPr>
+            <a:normAutofit/>
+          </a:bodyPr>
+          <a:lstStyle/>
+          <a:p>
+            <a:r>
+              <a:rPr lang="pt-BR" sz="3200" b="1" dirty="0">
+                <a:solidFill>
+                  <a:srgbClr val="FF0000"/>
+                </a:solidFill>
+              </a:rPr>
+              <a:t>O gráfico da função será: </a:t>
+            </a:r>
+          </a:p>
+        </p:txBody>
+      </p:sp>
+      <p:pic>
+        <p:nvPicPr>
+          <p:cNvPr id="4" name="Imagem 3" descr="Gráfico, Gráfico de linhas&#10;&#10;O conteúdo gerado por IA pode estar incorreto.">
+            <a:extLst>
+              <a:ext uri="{FF2B5EF4-FFF2-40B4-BE49-F238E27FC236}">
+                <a16:creationId xmlns:a16="http://schemas.microsoft.com/office/drawing/2014/main" id="{0D11BEC1-B8AE-8560-F121-CC3A3F7C5E43}"/>
+              </a:ext>
+            </a:extLst>
+          </p:cNvPr>
+          <p:cNvPicPr>
+            <a:picLocks noChangeAspect="1"/>
+          </p:cNvPicPr>
+          <p:nvPr/>
+        </p:nvPicPr>
+        <p:blipFill>
+          <a:blip r:embed="rId2"/>
+          <a:stretch>
+            <a:fillRect/>
+          </a:stretch>
+        </p:blipFill>
+        <p:spPr>
+          <a:xfrm>
+            <a:off x="2076046" y="1051140"/>
+            <a:ext cx="7729941" cy="5382109"/>
+          </a:xfrm>
+          <a:prstGeom prst="rect">
+            <a:avLst/>
+          </a:prstGeom>
+        </p:spPr>
+      </p:pic>
+    </p:spTree>
+    <p:extLst>
+      <p:ext uri="{BB962C8B-B14F-4D97-AF65-F5344CB8AC3E}">
+        <p14:creationId xmlns:p14="http://schemas.microsoft.com/office/powerpoint/2010/main" val="1931583805"/>
+      </p:ext>
+    </p:extLst>
+  </p:cSld>
+  <p:clrMapOvr>
+    <a:masterClrMapping/>
+  </p:clrMapOvr>
+</p:sld>
+</file>
+
+<file path=ppt/slides/slide21.xml><?xml version="1.0" encoding="utf-8"?>
+<p:sld xmlns:a="http://schemas.openxmlformats.org/drawingml/2006/main" xmlns:r="http://schemas.openxmlformats.org/officeDocument/2006/relationships" xmlns:p="http://schemas.openxmlformats.org/presentationml/2006/main">
+  <p:cSld>
+    <p:spTree>
+      <p:nvGrpSpPr>
+        <p:cNvPr id="1" name=""/>
+        <p:cNvGrpSpPr/>
+        <p:nvPr/>
+      </p:nvGrpSpPr>
+      <p:grpSpPr>
+        <a:xfrm>
+          <a:off x="0" y="0"/>
+          <a:ext cx="0" cy="0"/>
+          <a:chOff x="0" y="0"/>
+          <a:chExt cx="0" cy="0"/>
+        </a:xfrm>
+      </p:grpSpPr>
+      <p:sp>
+        <p:nvSpPr>
+          <p:cNvPr id="2" name="Título 1">
+            <a:extLst>
+              <a:ext uri="{FF2B5EF4-FFF2-40B4-BE49-F238E27FC236}">
                 <a16:creationId xmlns:a16="http://schemas.microsoft.com/office/drawing/2014/main" id="{9D39F1E5-FFC9-C6D1-C9F5-86D2A6A8A176}"/>
               </a:ext>
             </a:extLst>
@@ -5168,7 +5271,7 @@
 </p:sld>
 </file>
 
-<file path=ppt/slides/slide21.xml><?xml version="1.0" encoding="utf-8"?>
+<file path=ppt/slides/slide22.xml><?xml version="1.0" encoding="utf-8"?>
 <p:sld xmlns:a="http://schemas.openxmlformats.org/drawingml/2006/main" xmlns:r="http://schemas.openxmlformats.org/officeDocument/2006/relationships" xmlns:p="http://schemas.openxmlformats.org/presentationml/2006/main">
   <p:cSld>
     <p:spTree>
@@ -5190,6 +5293,152 @@
           <p:cNvPr id="2" name="Título 1">
             <a:extLst>
               <a:ext uri="{FF2B5EF4-FFF2-40B4-BE49-F238E27FC236}">
+                <a16:creationId xmlns:a16="http://schemas.microsoft.com/office/drawing/2014/main" id="{031C0F50-B4CF-8C1B-FC4E-7D82EA7DD454}"/>
+              </a:ext>
+            </a:extLst>
+          </p:cNvPr>
+          <p:cNvSpPr>
+            <a:spLocks noGrp="1"/>
+          </p:cNvSpPr>
+          <p:nvPr>
+            <p:ph type="title"/>
+          </p:nvPr>
+        </p:nvSpPr>
+        <p:spPr>
+          <a:xfrm>
+            <a:off x="3830171" y="-5471"/>
+            <a:ext cx="4531659" cy="899739"/>
+          </a:xfrm>
+        </p:spPr>
+        <p:txBody>
+          <a:bodyPr/>
+          <a:lstStyle/>
+          <a:p>
+            <a:r>
+              <a:rPr lang="pt-BR" sz="3200" b="1" dirty="0">
+                <a:solidFill>
+                  <a:srgbClr val="FF0000"/>
+                </a:solidFill>
+              </a:rPr>
+              <a:t>O gráfico da função será:</a:t>
+            </a:r>
+            <a:endParaRPr lang="pt-BR" dirty="0"/>
+          </a:p>
+        </p:txBody>
+      </p:sp>
+      <p:pic>
+        <p:nvPicPr>
+          <p:cNvPr id="3" name="Imagem 2" descr="Gráfico, Gráfico de linhas&#10;&#10;O conteúdo gerado por IA pode estar incorreto.">
+            <a:extLst>
+              <a:ext uri="{FF2B5EF4-FFF2-40B4-BE49-F238E27FC236}">
+                <a16:creationId xmlns:a16="http://schemas.microsoft.com/office/drawing/2014/main" id="{80948616-0D45-4015-2ECF-059BD507AEEE}"/>
+              </a:ext>
+            </a:extLst>
+          </p:cNvPr>
+          <p:cNvPicPr>
+            <a:picLocks noChangeAspect="1"/>
+          </p:cNvPicPr>
+          <p:nvPr/>
+        </p:nvPicPr>
+        <p:blipFill>
+          <a:blip r:embed="rId2"/>
+          <a:stretch>
+            <a:fillRect/>
+          </a:stretch>
+        </p:blipFill>
+        <p:spPr>
+          <a:xfrm>
+            <a:off x="2019841" y="897062"/>
+            <a:ext cx="8157246" cy="4513479"/>
+          </a:xfrm>
+          <a:prstGeom prst="rect">
+            <a:avLst/>
+          </a:prstGeom>
+        </p:spPr>
+      </p:pic>
+      <p:sp>
+        <p:nvSpPr>
+          <p:cNvPr id="4" name="CaixaDeTexto 3">
+            <a:extLst>
+              <a:ext uri="{FF2B5EF4-FFF2-40B4-BE49-F238E27FC236}">
+                <a16:creationId xmlns:a16="http://schemas.microsoft.com/office/drawing/2014/main" id="{4925E413-0C51-834F-2D09-0B1865FCA40E}"/>
+              </a:ext>
+            </a:extLst>
+          </p:cNvPr>
+          <p:cNvSpPr txBox="1"/>
+          <p:nvPr/>
+        </p:nvSpPr>
+        <p:spPr>
+          <a:xfrm>
+            <a:off x="322413" y="5618025"/>
+            <a:ext cx="11547021" cy="1077218"/>
+          </a:xfrm>
+          <a:prstGeom prst="rect">
+            <a:avLst/>
+          </a:prstGeom>
+          <a:noFill/>
+        </p:spPr>
+        <p:txBody>
+          <a:bodyPr rot="0" spcFirstLastPara="0" vertOverflow="overflow" horzOverflow="overflow" vert="horz" wrap="square" lIns="91440" tIns="45720" rIns="91440" bIns="45720" numCol="1" spcCol="0" rtlCol="0" fromWordArt="0" anchor="t" anchorCtr="0" forceAA="0" compatLnSpc="1">
+            <a:prstTxWarp prst="textNoShape">
+              <a:avLst/>
+            </a:prstTxWarp>
+            <a:spAutoFit/>
+          </a:bodyPr>
+          <a:lstStyle/>
+          <a:p>
+            <a:pPr algn="just"/>
+            <a:r>
+              <a:rPr lang="pt-BR" sz="1600" b="1" dirty="0">
+                <a:solidFill>
+                  <a:schemeClr val="accent2"/>
+                </a:solidFill>
+              </a:rPr>
+              <a:t>Observação: A função horária é uma equação do 2° grau, no entanto, a análise do seu gráfico nem sempre atende aos requisitos de uma questão, na resolução do problema proposto destaca-se que, uma das raízes da equação não faz sentido como resposta, pela problemática proposta as razões matemáticas analisadas foram submetidas a condições físicas relativas.</a:t>
+            </a:r>
+            <a:endParaRPr lang="pt-BR">
+              <a:solidFill>
+                <a:schemeClr val="accent2"/>
+              </a:solidFill>
+            </a:endParaRPr>
+          </a:p>
+        </p:txBody>
+      </p:sp>
+    </p:spTree>
+    <p:extLst>
+      <p:ext uri="{BB962C8B-B14F-4D97-AF65-F5344CB8AC3E}">
+        <p14:creationId xmlns:p14="http://schemas.microsoft.com/office/powerpoint/2010/main" val="4106589359"/>
+      </p:ext>
+    </p:extLst>
+  </p:cSld>
+  <p:clrMapOvr>
+    <a:masterClrMapping/>
+  </p:clrMapOvr>
+</p:sld>
+</file>
+
+<file path=ppt/slides/slide23.xml><?xml version="1.0" encoding="utf-8"?>
+<p:sld xmlns:a="http://schemas.openxmlformats.org/drawingml/2006/main" xmlns:r="http://schemas.openxmlformats.org/officeDocument/2006/relationships" xmlns:p="http://schemas.openxmlformats.org/presentationml/2006/main">
+  <p:cSld>
+    <p:spTree>
+      <p:nvGrpSpPr>
+        <p:cNvPr id="1" name=""/>
+        <p:cNvGrpSpPr/>
+        <p:nvPr/>
+      </p:nvGrpSpPr>
+      <p:grpSpPr>
+        <a:xfrm>
+          <a:off x="0" y="0"/>
+          <a:ext cx="0" cy="0"/>
+          <a:chOff x="0" y="0"/>
+          <a:chExt cx="0" cy="0"/>
+        </a:xfrm>
+      </p:grpSpPr>
+      <p:sp>
+        <p:nvSpPr>
+          <p:cNvPr id="2" name="Título 1">
+            <a:extLst>
+              <a:ext uri="{FF2B5EF4-FFF2-40B4-BE49-F238E27FC236}">
                 <a16:creationId xmlns:a16="http://schemas.microsoft.com/office/drawing/2014/main" id="{4ED26C64-DCF1-0B20-6E28-399DC4EC8450}"/>
               </a:ext>
             </a:extLst>
@@ -5269,7 +5518,7 @@
 </p:sld>
 </file>
 
-<file path=ppt/slides/slide22.xml><?xml version="1.0" encoding="utf-8"?>
+<file path=ppt/slides/slide24.xml><?xml version="1.0" encoding="utf-8"?>
 <p:sld xmlns:a="http://schemas.openxmlformats.org/drawingml/2006/main" xmlns:r="http://schemas.openxmlformats.org/officeDocument/2006/relationships" xmlns:p="http://schemas.openxmlformats.org/presentationml/2006/main">
   <p:cSld>
     <p:spTree>

</xml_diff>

<commit_message>
commit Matematica Finalizações finais
</commit_message>
<xml_diff>
--- a/Downloads/Matematica Fundamental.pptx
+++ b/Downloads/Matematica Fundamental.pptx
@@ -29,6 +29,7 @@
     <p:sldId id="279" r:id="rId23"/>
     <p:sldId id="272" r:id="rId24"/>
     <p:sldId id="273" r:id="rId25"/>
+    <p:sldId id="280" r:id="rId26"/>
   </p:sldIdLst>
   <p:sldSz cx="12192000" cy="6858000"/>
   <p:notesSz cx="6858000" cy="9144000"/>
@@ -138,9 +139,7 @@
 <file path=ppt/revisionInfo.xml><?xml version="1.0" encoding="utf-8"?>
 <p1510:revInfo xmlns:a="http://schemas.openxmlformats.org/drawingml/2006/main" xmlns:r="http://schemas.openxmlformats.org/officeDocument/2006/relationships" xmlns:p1510="http://schemas.microsoft.com/office/powerpoint/2015/10/main">
   <p1510:revLst>
-    <p1510:client id="{6E2347CC-3A19-4E5C-B610-004F2E4A0D56}" v="126" dt="2025-11-26T09:21:21.397"/>
-    <p1510:client id="{CF99255D-5809-4BC2-9D89-5BE2FC3D6CA6}" v="38" dt="2025-11-28T05:09:15.579"/>
-    <p1510:client id="{D6662D95-27E0-49F2-BDDD-C19C0C9D094A}" v="41" dt="2025-11-28T05:03:49.372"/>
+    <p1510:client id="{288CA8DA-3342-482D-A8EE-7E0B0115A974}" v="21" dt="2025-12-18T00:59:51.694"/>
   </p1510:revLst>
 </p1510:revInfo>
 </file>
@@ -276,7 +275,7 @@
           <a:p>
             <a:fld id="{F0E51C7C-CEA3-4CAA-BE4B-344879E7C377}" type="datetimeFigureOut">
               <a:rPr lang="de-DE" smtClean="0"/>
-              <a:t>27.11.2025</a:t>
+              <a:t>17.12.2025</a:t>
             </a:fld>
             <a:endParaRPr lang="de-DE"/>
           </a:p>
@@ -446,7 +445,7 @@
           <a:p>
             <a:fld id="{F0E51C7C-CEA3-4CAA-BE4B-344879E7C377}" type="datetimeFigureOut">
               <a:rPr lang="de-DE" smtClean="0"/>
-              <a:t>27.11.2025</a:t>
+              <a:t>17.12.2025</a:t>
             </a:fld>
             <a:endParaRPr lang="de-DE"/>
           </a:p>
@@ -626,7 +625,7 @@
           <a:p>
             <a:fld id="{F0E51C7C-CEA3-4CAA-BE4B-344879E7C377}" type="datetimeFigureOut">
               <a:rPr lang="de-DE" smtClean="0"/>
-              <a:t>27.11.2025</a:t>
+              <a:t>17.12.2025</a:t>
             </a:fld>
             <a:endParaRPr lang="de-DE"/>
           </a:p>
@@ -796,7 +795,7 @@
           <a:p>
             <a:fld id="{F0E51C7C-CEA3-4CAA-BE4B-344879E7C377}" type="datetimeFigureOut">
               <a:rPr lang="de-DE" smtClean="0"/>
-              <a:t>27.11.2025</a:t>
+              <a:t>17.12.2025</a:t>
             </a:fld>
             <a:endParaRPr lang="de-DE"/>
           </a:p>
@@ -1042,7 +1041,7 @@
           <a:p>
             <a:fld id="{F0E51C7C-CEA3-4CAA-BE4B-344879E7C377}" type="datetimeFigureOut">
               <a:rPr lang="de-DE" smtClean="0"/>
-              <a:t>27.11.2025</a:t>
+              <a:t>17.12.2025</a:t>
             </a:fld>
             <a:endParaRPr lang="de-DE"/>
           </a:p>
@@ -1274,7 +1273,7 @@
           <a:p>
             <a:fld id="{F0E51C7C-CEA3-4CAA-BE4B-344879E7C377}" type="datetimeFigureOut">
               <a:rPr lang="de-DE" smtClean="0"/>
-              <a:t>27.11.2025</a:t>
+              <a:t>17.12.2025</a:t>
             </a:fld>
             <a:endParaRPr lang="de-DE"/>
           </a:p>
@@ -1641,7 +1640,7 @@
           <a:p>
             <a:fld id="{F0E51C7C-CEA3-4CAA-BE4B-344879E7C377}" type="datetimeFigureOut">
               <a:rPr lang="de-DE" smtClean="0"/>
-              <a:t>27.11.2025</a:t>
+              <a:t>17.12.2025</a:t>
             </a:fld>
             <a:endParaRPr lang="de-DE"/>
           </a:p>
@@ -1759,7 +1758,7 @@
           <a:p>
             <a:fld id="{F0E51C7C-CEA3-4CAA-BE4B-344879E7C377}" type="datetimeFigureOut">
               <a:rPr lang="de-DE" smtClean="0"/>
-              <a:t>27.11.2025</a:t>
+              <a:t>17.12.2025</a:t>
             </a:fld>
             <a:endParaRPr lang="de-DE"/>
           </a:p>
@@ -1854,7 +1853,7 @@
           <a:p>
             <a:fld id="{F0E51C7C-CEA3-4CAA-BE4B-344879E7C377}" type="datetimeFigureOut">
               <a:rPr lang="de-DE" smtClean="0"/>
-              <a:t>27.11.2025</a:t>
+              <a:t>17.12.2025</a:t>
             </a:fld>
             <a:endParaRPr lang="de-DE"/>
           </a:p>
@@ -2131,7 +2130,7 @@
           <a:p>
             <a:fld id="{F0E51C7C-CEA3-4CAA-BE4B-344879E7C377}" type="datetimeFigureOut">
               <a:rPr lang="de-DE" smtClean="0"/>
-              <a:t>27.11.2025</a:t>
+              <a:t>17.12.2025</a:t>
             </a:fld>
             <a:endParaRPr lang="de-DE"/>
           </a:p>
@@ -2384,7 +2383,7 @@
           <a:p>
             <a:fld id="{F0E51C7C-CEA3-4CAA-BE4B-344879E7C377}" type="datetimeFigureOut">
               <a:rPr lang="de-DE" smtClean="0"/>
-              <a:t>27.11.2025</a:t>
+              <a:t>17.12.2025</a:t>
             </a:fld>
             <a:endParaRPr lang="de-DE"/>
           </a:p>
@@ -2603,7 +2602,7 @@
           <a:p>
             <a:fld id="{F0E51C7C-CEA3-4CAA-BE4B-344879E7C377}" type="datetimeFigureOut">
               <a:rPr lang="de-DE" smtClean="0"/>
-              <a:t>27.11.2025</a:t>
+              <a:t>17.12.2025</a:t>
             </a:fld>
             <a:endParaRPr lang="de-DE"/>
           </a:p>
@@ -5634,6 +5633,101 @@
     <p:extLst>
       <p:ext uri="{BB962C8B-B14F-4D97-AF65-F5344CB8AC3E}">
         <p14:creationId xmlns:p14="http://schemas.microsoft.com/office/powerpoint/2010/main" val="1113526587"/>
+      </p:ext>
+    </p:extLst>
+  </p:cSld>
+  <p:clrMapOvr>
+    <a:masterClrMapping/>
+  </p:clrMapOvr>
+</p:sld>
+</file>
+
+<file path=ppt/slides/slide25.xml><?xml version="1.0" encoding="utf-8"?>
+<p:sld xmlns:a="http://schemas.openxmlformats.org/drawingml/2006/main" xmlns:r="http://schemas.openxmlformats.org/officeDocument/2006/relationships" xmlns:p="http://schemas.openxmlformats.org/presentationml/2006/main">
+  <p:cSld>
+    <p:spTree>
+      <p:nvGrpSpPr>
+        <p:cNvPr id="1" name=""/>
+        <p:cNvGrpSpPr/>
+        <p:nvPr/>
+      </p:nvGrpSpPr>
+      <p:grpSpPr>
+        <a:xfrm>
+          <a:off x="0" y="0"/>
+          <a:ext cx="0" cy="0"/>
+          <a:chOff x="0" y="0"/>
+          <a:chExt cx="0" cy="0"/>
+        </a:xfrm>
+      </p:grpSpPr>
+      <p:sp>
+        <p:nvSpPr>
+          <p:cNvPr id="2" name="Título 1">
+            <a:extLst>
+              <a:ext uri="{FF2B5EF4-FFF2-40B4-BE49-F238E27FC236}">
+                <a16:creationId xmlns:a16="http://schemas.microsoft.com/office/drawing/2014/main" id="{E8E54657-1E17-489E-F829-EEDA04AE0552}"/>
+              </a:ext>
+            </a:extLst>
+          </p:cNvPr>
+          <p:cNvSpPr>
+            <a:spLocks noGrp="1"/>
+          </p:cNvSpPr>
+          <p:nvPr>
+            <p:ph type="title"/>
+          </p:nvPr>
+        </p:nvSpPr>
+        <p:spPr>
+          <a:xfrm>
+            <a:off x="5088731" y="365125"/>
+            <a:ext cx="2014538" cy="873126"/>
+          </a:xfrm>
+        </p:spPr>
+        <p:txBody>
+          <a:bodyPr>
+            <a:normAutofit/>
+          </a:bodyPr>
+          <a:lstStyle/>
+          <a:p>
+            <a:r>
+              <a:rPr lang="pt-BR" sz="2000" b="1" dirty="0"/>
+              <a:t>Interatividade</a:t>
+            </a:r>
+          </a:p>
+        </p:txBody>
+      </p:sp>
+      <p:pic>
+        <p:nvPicPr>
+          <p:cNvPr id="4" name="Imagem 3" descr="Código QR&#10;&#10;O conteúdo gerado por IA pode estar incorreto.">
+            <a:extLst>
+              <a:ext uri="{FF2B5EF4-FFF2-40B4-BE49-F238E27FC236}">
+                <a16:creationId xmlns:a16="http://schemas.microsoft.com/office/drawing/2014/main" id="{0EE23786-9A3E-0BF6-266C-771738BA0B0F}"/>
+              </a:ext>
+            </a:extLst>
+          </p:cNvPr>
+          <p:cNvPicPr>
+            <a:picLocks noChangeAspect="1"/>
+          </p:cNvPicPr>
+          <p:nvPr/>
+        </p:nvPicPr>
+        <p:blipFill>
+          <a:blip r:embed="rId2"/>
+          <a:stretch>
+            <a:fillRect/>
+          </a:stretch>
+        </p:blipFill>
+        <p:spPr>
+          <a:xfrm>
+            <a:off x="3952875" y="1285875"/>
+            <a:ext cx="4286250" cy="4286250"/>
+          </a:xfrm>
+          <a:prstGeom prst="rect">
+            <a:avLst/>
+          </a:prstGeom>
+        </p:spPr>
+      </p:pic>
+    </p:spTree>
+    <p:extLst>
+      <p:ext uri="{BB962C8B-B14F-4D97-AF65-F5344CB8AC3E}">
+        <p14:creationId xmlns:p14="http://schemas.microsoft.com/office/powerpoint/2010/main" val="1372514761"/>
       </p:ext>
     </p:extLst>
   </p:cSld>

</xml_diff>

<commit_message>
commit Modificações de arquivo
</commit_message>
<xml_diff>
--- a/Downloads/Matematica Fundamental.pptx
+++ b/Downloads/Matematica Fundamental.pptx
@@ -11,25 +11,14 @@
     <p:sldId id="259" r:id="rId5"/>
     <p:sldId id="260" r:id="rId6"/>
     <p:sldId id="261" r:id="rId7"/>
-    <p:sldId id="262" r:id="rId8"/>
-    <p:sldId id="263" r:id="rId9"/>
-    <p:sldId id="264" r:id="rId10"/>
-    <p:sldId id="265" r:id="rId11"/>
-    <p:sldId id="266" r:id="rId12"/>
-    <p:sldId id="267" r:id="rId13"/>
-    <p:sldId id="268" r:id="rId14"/>
-    <p:sldId id="274" r:id="rId15"/>
-    <p:sldId id="275" r:id="rId16"/>
-    <p:sldId id="276" r:id="rId17"/>
-    <p:sldId id="277" r:id="rId18"/>
-    <p:sldId id="269" r:id="rId19"/>
-    <p:sldId id="270" r:id="rId20"/>
-    <p:sldId id="278" r:id="rId21"/>
-    <p:sldId id="271" r:id="rId22"/>
-    <p:sldId id="279" r:id="rId23"/>
-    <p:sldId id="272" r:id="rId24"/>
-    <p:sldId id="273" r:id="rId25"/>
-    <p:sldId id="280" r:id="rId26"/>
+    <p:sldId id="263" r:id="rId8"/>
+    <p:sldId id="264" r:id="rId9"/>
+    <p:sldId id="281" r:id="rId10"/>
+    <p:sldId id="282" r:id="rId11"/>
+    <p:sldId id="283" r:id="rId12"/>
+    <p:sldId id="272" r:id="rId13"/>
+    <p:sldId id="273" r:id="rId14"/>
+    <p:sldId id="280" r:id="rId15"/>
   </p:sldIdLst>
   <p:sldSz cx="12192000" cy="6858000"/>
   <p:notesSz cx="6858000" cy="9144000"/>
@@ -139,7 +128,8 @@
 <file path=ppt/revisionInfo.xml><?xml version="1.0" encoding="utf-8"?>
 <p1510:revInfo xmlns:a="http://schemas.openxmlformats.org/drawingml/2006/main" xmlns:r="http://schemas.openxmlformats.org/officeDocument/2006/relationships" xmlns:p1510="http://schemas.microsoft.com/office/powerpoint/2015/10/main">
   <p1510:revLst>
-    <p1510:client id="{288CA8DA-3342-482D-A8EE-7E0B0115A974}" v="21" dt="2025-12-18T00:59:51.694"/>
+    <p1510:client id="{CC1728B4-74BD-4154-8B22-A35B5AD85633}" v="12" dt="2026-01-26T03:58:03.920"/>
+    <p1510:client id="{D97FA67A-8680-443E-8DD1-C2509C07BADA}" v="142" dt="2026-01-26T05:06:49.409"/>
   </p1510:revLst>
 </p1510:revInfo>
 </file>
@@ -275,7 +265,7 @@
           <a:p>
             <a:fld id="{F0E51C7C-CEA3-4CAA-BE4B-344879E7C377}" type="datetimeFigureOut">
               <a:rPr lang="de-DE" smtClean="0"/>
-              <a:t>17.12.2025</a:t>
+              <a:t>25.01.2026</a:t>
             </a:fld>
             <a:endParaRPr lang="de-DE"/>
           </a:p>
@@ -445,7 +435,7 @@
           <a:p>
             <a:fld id="{F0E51C7C-CEA3-4CAA-BE4B-344879E7C377}" type="datetimeFigureOut">
               <a:rPr lang="de-DE" smtClean="0"/>
-              <a:t>17.12.2025</a:t>
+              <a:t>25.01.2026</a:t>
             </a:fld>
             <a:endParaRPr lang="de-DE"/>
           </a:p>
@@ -625,7 +615,7 @@
           <a:p>
             <a:fld id="{F0E51C7C-CEA3-4CAA-BE4B-344879E7C377}" type="datetimeFigureOut">
               <a:rPr lang="de-DE" smtClean="0"/>
-              <a:t>17.12.2025</a:t>
+              <a:t>25.01.2026</a:t>
             </a:fld>
             <a:endParaRPr lang="de-DE"/>
           </a:p>
@@ -795,7 +785,7 @@
           <a:p>
             <a:fld id="{F0E51C7C-CEA3-4CAA-BE4B-344879E7C377}" type="datetimeFigureOut">
               <a:rPr lang="de-DE" smtClean="0"/>
-              <a:t>17.12.2025</a:t>
+              <a:t>25.01.2026</a:t>
             </a:fld>
             <a:endParaRPr lang="de-DE"/>
           </a:p>
@@ -1041,7 +1031,7 @@
           <a:p>
             <a:fld id="{F0E51C7C-CEA3-4CAA-BE4B-344879E7C377}" type="datetimeFigureOut">
               <a:rPr lang="de-DE" smtClean="0"/>
-              <a:t>17.12.2025</a:t>
+              <a:t>25.01.2026</a:t>
             </a:fld>
             <a:endParaRPr lang="de-DE"/>
           </a:p>
@@ -1273,7 +1263,7 @@
           <a:p>
             <a:fld id="{F0E51C7C-CEA3-4CAA-BE4B-344879E7C377}" type="datetimeFigureOut">
               <a:rPr lang="de-DE" smtClean="0"/>
-              <a:t>17.12.2025</a:t>
+              <a:t>25.01.2026</a:t>
             </a:fld>
             <a:endParaRPr lang="de-DE"/>
           </a:p>
@@ -1640,7 +1630,7 @@
           <a:p>
             <a:fld id="{F0E51C7C-CEA3-4CAA-BE4B-344879E7C377}" type="datetimeFigureOut">
               <a:rPr lang="de-DE" smtClean="0"/>
-              <a:t>17.12.2025</a:t>
+              <a:t>25.01.2026</a:t>
             </a:fld>
             <a:endParaRPr lang="de-DE"/>
           </a:p>
@@ -1758,7 +1748,7 @@
           <a:p>
             <a:fld id="{F0E51C7C-CEA3-4CAA-BE4B-344879E7C377}" type="datetimeFigureOut">
               <a:rPr lang="de-DE" smtClean="0"/>
-              <a:t>17.12.2025</a:t>
+              <a:t>25.01.2026</a:t>
             </a:fld>
             <a:endParaRPr lang="de-DE"/>
           </a:p>
@@ -1853,7 +1843,7 @@
           <a:p>
             <a:fld id="{F0E51C7C-CEA3-4CAA-BE4B-344879E7C377}" type="datetimeFigureOut">
               <a:rPr lang="de-DE" smtClean="0"/>
-              <a:t>17.12.2025</a:t>
+              <a:t>25.01.2026</a:t>
             </a:fld>
             <a:endParaRPr lang="de-DE"/>
           </a:p>
@@ -2130,7 +2120,7 @@
           <a:p>
             <a:fld id="{F0E51C7C-CEA3-4CAA-BE4B-344879E7C377}" type="datetimeFigureOut">
               <a:rPr lang="de-DE" smtClean="0"/>
-              <a:t>17.12.2025</a:t>
+              <a:t>25.01.2026</a:t>
             </a:fld>
             <a:endParaRPr lang="de-DE"/>
           </a:p>
@@ -2383,7 +2373,7 @@
           <a:p>
             <a:fld id="{F0E51C7C-CEA3-4CAA-BE4B-344879E7C377}" type="datetimeFigureOut">
               <a:rPr lang="de-DE" smtClean="0"/>
-              <a:t>17.12.2025</a:t>
+              <a:t>25.01.2026</a:t>
             </a:fld>
             <a:endParaRPr lang="de-DE"/>
           </a:p>
@@ -2602,7 +2592,7 @@
           <a:p>
             <a:fld id="{F0E51C7C-CEA3-4CAA-BE4B-344879E7C377}" type="datetimeFigureOut">
               <a:rPr lang="de-DE" smtClean="0"/>
-              <a:t>17.12.2025</a:t>
+              <a:t>25.01.2026</a:t>
             </a:fld>
             <a:endParaRPr lang="de-DE"/>
           </a:p>
@@ -3067,199 +3057,12 @@
           <a:chExt cx="0" cy="0"/>
         </a:xfrm>
       </p:grpSpPr>
-      <p:sp>
-        <p:nvSpPr>
-          <p:cNvPr id="2" name="Título 1">
+      <p:pic>
+        <p:nvPicPr>
+          <p:cNvPr id="4" name="Imagem 3" descr="Tabela&#10;&#10;O conteúdo gerado por IA pode estar incorreto.">
             <a:extLst>
               <a:ext uri="{FF2B5EF4-FFF2-40B4-BE49-F238E27FC236}">
-                <a16:creationId xmlns:a16="http://schemas.microsoft.com/office/drawing/2014/main" id="{2E915EFB-4CC1-6A30-8C6F-22BA034E735D}"/>
-              </a:ext>
-            </a:extLst>
-          </p:cNvPr>
-          <p:cNvSpPr>
-            <a:spLocks noGrp="1"/>
-          </p:cNvSpPr>
-          <p:nvPr>
-            <p:ph type="title"/>
-          </p:nvPr>
-        </p:nvSpPr>
-        <p:spPr>
-          <a:xfrm>
-            <a:off x="838200" y="129803"/>
-            <a:ext cx="10515600" cy="1291945"/>
-          </a:xfrm>
-        </p:spPr>
-        <p:txBody>
-          <a:bodyPr>
-            <a:normAutofit/>
-          </a:bodyPr>
-          <a:lstStyle/>
-          <a:p>
-            <a:pPr algn="just"/>
-            <a:r>
-              <a:rPr lang="pt-BR" sz="2800" b="1" dirty="0">
-                <a:solidFill>
-                  <a:schemeClr val="accent2">
-                    <a:lumMod val="76000"/>
-                  </a:schemeClr>
-                </a:solidFill>
-                <a:latin typeface="Aptos"/>
-              </a:rPr>
-              <a:t>Função horária, contextualizando cálculos Físicos </a:t>
-            </a:r>
-            <a:endParaRPr lang="pt-BR" sz="2800">
-              <a:solidFill>
-                <a:schemeClr val="accent2">
-                  <a:lumMod val="76000"/>
-                </a:schemeClr>
-              </a:solidFill>
-              <a:latin typeface="Aptos"/>
-            </a:endParaRPr>
-          </a:p>
-          <a:p>
-            <a:pPr algn="just"/>
-            <a:r>
-              <a:rPr lang="pt-BR" sz="2800" b="1" dirty="0">
-                <a:solidFill>
-                  <a:schemeClr val="accent2">
-                    <a:lumMod val="76000"/>
-                  </a:schemeClr>
-                </a:solidFill>
-                <a:latin typeface="Aptos"/>
-              </a:rPr>
-              <a:t>(Equação de 2° grau).</a:t>
-            </a:r>
-            <a:endParaRPr lang="pt-BR" sz="2800" dirty="0">
-              <a:solidFill>
-                <a:schemeClr val="accent2">
-                  <a:lumMod val="76000"/>
-                </a:schemeClr>
-              </a:solidFill>
-              <a:latin typeface="Aptos"/>
-            </a:endParaRPr>
-          </a:p>
-          <a:p>
-            <a:endParaRPr lang="pt-BR" dirty="0"/>
-          </a:p>
-        </p:txBody>
-      </p:sp>
-      <p:sp>
-        <p:nvSpPr>
-          <p:cNvPr id="3" name="Espaço Reservado para Conteúdo 2">
-            <a:extLst>
-              <a:ext uri="{FF2B5EF4-FFF2-40B4-BE49-F238E27FC236}">
-                <a16:creationId xmlns:a16="http://schemas.microsoft.com/office/drawing/2014/main" id="{CC083A42-BDE8-8BD4-7C1C-C83A8D079B7D}"/>
-              </a:ext>
-            </a:extLst>
-          </p:cNvPr>
-          <p:cNvSpPr>
-            <a:spLocks noGrp="1"/>
-          </p:cNvSpPr>
-          <p:nvPr>
-            <p:ph idx="1"/>
-          </p:nvPr>
-        </p:nvSpPr>
-        <p:spPr>
-          <a:xfrm>
-            <a:off x="838201" y="985184"/>
-            <a:ext cx="10515600" cy="574956"/>
-          </a:xfrm>
-        </p:spPr>
-        <p:txBody>
-          <a:bodyPr vert="horz" lIns="91440" tIns="45720" rIns="91440" bIns="45720" rtlCol="0" anchor="t">
-            <a:normAutofit/>
-          </a:bodyPr>
-          <a:lstStyle/>
-          <a:p>
-            <a:pPr marL="0" indent="0">
-              <a:buNone/>
-            </a:pPr>
-            <a:r>
-              <a:rPr lang="pt-BR" sz="2400" b="1" dirty="0"/>
-              <a:t>Como chegamos à função horária do movimento? (equação de 2º grau)</a:t>
-            </a:r>
-          </a:p>
-        </p:txBody>
-      </p:sp>
-      <p:sp>
-        <p:nvSpPr>
-          <p:cNvPr id="4" name="CaixaDeTexto 3">
-            <a:extLst>
-              <a:ext uri="{FF2B5EF4-FFF2-40B4-BE49-F238E27FC236}">
-                <a16:creationId xmlns:a16="http://schemas.microsoft.com/office/drawing/2014/main" id="{BE156324-77AC-C878-DD5B-F36EA000B23B}"/>
-              </a:ext>
-            </a:extLst>
-          </p:cNvPr>
-          <p:cNvSpPr txBox="1"/>
-          <p:nvPr/>
-        </p:nvSpPr>
-        <p:spPr>
-          <a:xfrm>
-            <a:off x="622170" y="1952405"/>
-            <a:ext cx="10732292" cy="3416320"/>
-          </a:xfrm>
-          <a:prstGeom prst="rect">
-            <a:avLst/>
-          </a:prstGeom>
-          <a:noFill/>
-        </p:spPr>
-        <p:txBody>
-          <a:bodyPr rot="0" spcFirstLastPara="0" vertOverflow="overflow" horzOverflow="overflow" vert="horz" wrap="square" lIns="91440" tIns="45720" rIns="91440" bIns="45720" numCol="1" spcCol="0" rtlCol="0" fromWordArt="0" anchor="t" anchorCtr="0" forceAA="0" compatLnSpc="1">
-            <a:prstTxWarp prst="textNoShape">
-              <a:avLst/>
-            </a:prstTxWarp>
-            <a:spAutoFit/>
-          </a:bodyPr>
-          <a:lstStyle/>
-          <a:p>
-            <a:pPr algn="just"/>
-            <a:r>
-              <a:rPr lang="pt-BR" sz="2000" dirty="0"/>
-              <a:t> </a:t>
-            </a:r>
-            <a:r>
-              <a:rPr lang="pt-BR" sz="2400" dirty="0"/>
-              <a:t>Existem várias formas de explicar a origem da função horária, por derivação, integração, encadeamento, análise matemática, análises geométricas, entre ouros métodos, para evitar complexidades desnecessárias será abordado a forma mais simples de compreender a função horária do movimento.</a:t>
-            </a:r>
-          </a:p>
-          <a:p>
-            <a:pPr algn="just"/>
-            <a:r>
-              <a:rPr lang="pt-BR" sz="2400" dirty="0"/>
-              <a:t> A função horária da posição no movimento uniformemente variado (MUV) pode ser deduzida </a:t>
-            </a:r>
-            <a:r>
-              <a:rPr lang="pt-BR" sz="2400" b="1" dirty="0"/>
-              <a:t>pela análise das áreas nos gráficos de velocidade × tempo</a:t>
-            </a:r>
-            <a:r>
-              <a:rPr lang="pt-BR" sz="2400" dirty="0"/>
-              <a:t>. A ideia central é que a área sob a curva </a:t>
-            </a:r>
-            <a:r>
-              <a:rPr lang="pt-BR" sz="2400" i="1" dirty="0">
-                <a:latin typeface="Cambria Math"/>
-                <a:ea typeface="Cambria Math"/>
-              </a:rPr>
-              <a:t>v(t)</a:t>
-            </a:r>
-            <a:r>
-              <a:rPr lang="pt-BR" sz="2400" dirty="0"/>
-              <a:t> representa o deslocamento, e somando essas áreas conseguimos chegar à fórmula:</a:t>
-            </a:r>
-          </a:p>
-          <a:p>
-            <a:pPr algn="l"/>
-            <a:endParaRPr lang="pt-BR" sz="2400" dirty="0"/>
-          </a:p>
-        </p:txBody>
-      </p:sp>
-      <p:pic>
-        <p:nvPicPr>
-          <p:cNvPr id="5" name="Imagem 4" descr="Diagrama, Gráfico de caixa estreita&#10;&#10;O conteúdo gerado por IA pode estar incorreto.">
-            <a:extLst>
-              <a:ext uri="{FF2B5EF4-FFF2-40B4-BE49-F238E27FC236}">
-                <a16:creationId xmlns:a16="http://schemas.microsoft.com/office/drawing/2014/main" id="{86AA436B-7F6A-159E-E0EF-00E1D759619A}"/>
+                <a16:creationId xmlns:a16="http://schemas.microsoft.com/office/drawing/2014/main" id="{2CA342D7-6456-2FAA-9669-FCF35EFB1680}"/>
               </a:ext>
             </a:extLst>
           </p:cNvPr>
@@ -3276,8 +3079,8 @@
         </p:blipFill>
         <p:spPr>
           <a:xfrm>
-            <a:off x="3959712" y="5364821"/>
-            <a:ext cx="4262437" cy="1302543"/>
+            <a:off x="384362" y="361670"/>
+            <a:ext cx="11154335" cy="5988983"/>
           </a:xfrm>
           <a:prstGeom prst="rect">
             <a:avLst/>
@@ -3287,7 +3090,7 @@
     </p:spTree>
     <p:extLst>
       <p:ext uri="{BB962C8B-B14F-4D97-AF65-F5344CB8AC3E}">
-        <p14:creationId xmlns:p14="http://schemas.microsoft.com/office/powerpoint/2010/main" val="3251663144"/>
+        <p14:creationId xmlns:p14="http://schemas.microsoft.com/office/powerpoint/2010/main" val="4028154003"/>
       </p:ext>
     </p:extLst>
   </p:cSld>
@@ -3316,19 +3119,17 @@
       </p:grpSpPr>
       <p:pic>
         <p:nvPicPr>
-          <p:cNvPr id="7" name="Espaço Reservado para Conteúdo 6" descr="Gráfico&#10;&#10;O conteúdo gerado por IA pode estar incorreto.">
+          <p:cNvPr id="4" name="Imagem 3" descr="Gráfico, Gráfico de linhas&#10;&#10;O conteúdo gerado por IA pode estar incorreto.">
             <a:extLst>
               <a:ext uri="{FF2B5EF4-FFF2-40B4-BE49-F238E27FC236}">
-                <a16:creationId xmlns:a16="http://schemas.microsoft.com/office/drawing/2014/main" id="{E0B41975-C2EB-FDF4-7A89-B57010BA112C}"/>
+                <a16:creationId xmlns:a16="http://schemas.microsoft.com/office/drawing/2014/main" id="{4B11C21A-B276-AEEF-0D0D-AFE6E773E999}"/>
               </a:ext>
             </a:extLst>
           </p:cNvPr>
           <p:cNvPicPr>
-            <a:picLocks noGrp="1" noChangeAspect="1"/>
+            <a:picLocks noChangeAspect="1"/>
           </p:cNvPicPr>
-          <p:nvPr>
-            <p:ph idx="1"/>
-          </p:nvPr>
+          <p:nvPr/>
         </p:nvPicPr>
         <p:blipFill>
           <a:blip r:embed="rId2"/>
@@ -3338,65 +3139,48 @@
         </p:blipFill>
         <p:spPr>
           <a:xfrm>
-            <a:off x="1439363" y="1297882"/>
-            <a:ext cx="9312182" cy="5258263"/>
+            <a:off x="4010445" y="163326"/>
+            <a:ext cx="7825627" cy="6363260"/>
           </a:xfrm>
           <a:prstGeom prst="rect">
             <a:avLst/>
           </a:prstGeom>
         </p:spPr>
       </p:pic>
-      <p:sp>
-        <p:nvSpPr>
-          <p:cNvPr id="4" name="CaixaDeTexto 3">
+      <p:pic>
+        <p:nvPicPr>
+          <p:cNvPr id="5" name="Imagem 4" descr="Uma imagem contendo Texto&#10;&#10;O conteúdo gerado por IA pode estar incorreto.">
             <a:extLst>
               <a:ext uri="{FF2B5EF4-FFF2-40B4-BE49-F238E27FC236}">
-                <a16:creationId xmlns:a16="http://schemas.microsoft.com/office/drawing/2014/main" id="{1E58274C-5A19-D822-88D5-3B93A58195D7}"/>
+                <a16:creationId xmlns:a16="http://schemas.microsoft.com/office/drawing/2014/main" id="{C20D6EA9-FAB6-7818-84F0-C218840F9D1E}"/>
               </a:ext>
             </a:extLst>
           </p:cNvPr>
-          <p:cNvSpPr txBox="1"/>
+          <p:cNvPicPr>
+            <a:picLocks noChangeAspect="1"/>
+          </p:cNvPicPr>
           <p:nvPr/>
-        </p:nvSpPr>
+        </p:nvPicPr>
+        <p:blipFill>
+          <a:blip r:embed="rId3"/>
+          <a:stretch>
+            <a:fillRect/>
+          </a:stretch>
+        </p:blipFill>
         <p:spPr>
           <a:xfrm>
-            <a:off x="3653769" y="297393"/>
-            <a:ext cx="5183980" cy="646331"/>
+            <a:off x="119902" y="3430400"/>
+            <a:ext cx="7200900" cy="1095375"/>
           </a:xfrm>
           <a:prstGeom prst="rect">
             <a:avLst/>
           </a:prstGeom>
-          <a:noFill/>
         </p:spPr>
-        <p:txBody>
-          <a:bodyPr rot="0" spcFirstLastPara="0" vertOverflow="overflow" horzOverflow="overflow" vert="horz" wrap="square" lIns="91440" tIns="45720" rIns="91440" bIns="45720" numCol="1" spcCol="0" rtlCol="0" fromWordArt="0" anchor="t" anchorCtr="0" forceAA="0" compatLnSpc="1">
-            <a:prstTxWarp prst="textNoShape">
-              <a:avLst/>
-            </a:prstTxWarp>
-            <a:spAutoFit/>
-          </a:bodyPr>
-          <a:lstStyle/>
-          <a:p>
-            <a:r>
-              <a:rPr lang="pt-BR" sz="3600" b="1" dirty="0">
-                <a:solidFill>
-                  <a:srgbClr val="FF0000"/>
-                </a:solidFill>
-              </a:rPr>
-              <a:t>Simplificando o cálculo</a:t>
-            </a:r>
-            <a:endParaRPr lang="pt-BR" sz="3600" dirty="0">
-              <a:solidFill>
-                <a:srgbClr val="FF0000"/>
-              </a:solidFill>
-            </a:endParaRPr>
-          </a:p>
-        </p:txBody>
-      </p:sp>
+      </p:pic>
     </p:spTree>
     <p:extLst>
       <p:ext uri="{BB962C8B-B14F-4D97-AF65-F5344CB8AC3E}">
-        <p14:creationId xmlns:p14="http://schemas.microsoft.com/office/powerpoint/2010/main" val="3974030240"/>
+        <p14:creationId xmlns:p14="http://schemas.microsoft.com/office/powerpoint/2010/main" val="2463438643"/>
       </p:ext>
     </p:extLst>
   </p:cSld>
@@ -3425,83 +3209,79 @@
       </p:grpSpPr>
       <p:sp>
         <p:nvSpPr>
-          <p:cNvPr id="12" name="CaixaDeTexto 11">
+          <p:cNvPr id="2" name="Título 1">
             <a:extLst>
               <a:ext uri="{FF2B5EF4-FFF2-40B4-BE49-F238E27FC236}">
-                <a16:creationId xmlns:a16="http://schemas.microsoft.com/office/drawing/2014/main" id="{0DE82C35-D0AA-2376-1129-8E1BC303EEE9}"/>
+                <a16:creationId xmlns:a16="http://schemas.microsoft.com/office/drawing/2014/main" id="{4ED26C64-DCF1-0B20-6E28-399DC4EC8450}"/>
               </a:ext>
             </a:extLst>
           </p:cNvPr>
-          <p:cNvSpPr txBox="1"/>
-          <p:nvPr/>
-        </p:nvSpPr>
-        <p:spPr>
-          <a:xfrm>
-            <a:off x="10422121" y="6222449"/>
-            <a:ext cx="2743200" cy="523220"/>
-          </a:xfrm>
-          <a:prstGeom prst="rect">
-            <a:avLst/>
-          </a:prstGeom>
-          <a:noFill/>
-        </p:spPr>
-        <p:txBody>
-          <a:bodyPr rot="0" spcFirstLastPara="0" vertOverflow="overflow" horzOverflow="overflow" vert="horz" wrap="square" lIns="91440" tIns="45720" rIns="91440" bIns="45720" numCol="1" spcCol="0" rtlCol="0" fromWordArt="0" anchor="t" anchorCtr="0" forceAA="0" compatLnSpc="1">
-            <a:prstTxWarp prst="textNoShape">
-              <a:avLst/>
-            </a:prstTxWarp>
-            <a:spAutoFit/>
-          </a:bodyPr>
-          <a:lstStyle/>
-          <a:p>
-            <a:pPr algn="l"/>
-            <a:r>
-              <a:rPr lang="pt-BR" sz="2800" b="1" dirty="0">
-                <a:solidFill>
-                  <a:srgbClr val="FF0000"/>
-                </a:solidFill>
-              </a:rPr>
-              <a:t>(Quadro)</a:t>
-            </a:r>
-          </a:p>
-        </p:txBody>
-      </p:sp>
-      <p:pic>
-        <p:nvPicPr>
-          <p:cNvPr id="17" name="Espaço Reservado para Conteúdo 16" descr="Tela de celular com aplicativo aberto&#10;&#10;O conteúdo gerado por IA pode estar incorreto.">
+          <p:cNvSpPr>
+            <a:spLocks noGrp="1"/>
+          </p:cNvSpPr>
+          <p:nvPr>
+            <p:ph type="title"/>
+          </p:nvPr>
+        </p:nvSpPr>
+        <p:spPr/>
+        <p:txBody>
+          <a:bodyPr/>
+          <a:lstStyle/>
+          <a:p>
+            <a:r>
+              <a:rPr lang="pt-BR" dirty="0"/>
+              <a:t>Conclusão</a:t>
+            </a:r>
+          </a:p>
+        </p:txBody>
+      </p:sp>
+      <p:sp>
+        <p:nvSpPr>
+          <p:cNvPr id="3" name="Espaço Reservado para Conteúdo 2">
             <a:extLst>
               <a:ext uri="{FF2B5EF4-FFF2-40B4-BE49-F238E27FC236}">
-                <a16:creationId xmlns:a16="http://schemas.microsoft.com/office/drawing/2014/main" id="{0D46FA8C-7F0D-7465-1362-2600B125632A}"/>
+                <a16:creationId xmlns:a16="http://schemas.microsoft.com/office/drawing/2014/main" id="{B5B67827-D717-9798-7763-C4CBA3B4903C}"/>
               </a:ext>
             </a:extLst>
           </p:cNvPr>
-          <p:cNvPicPr>
-            <a:picLocks noGrp="1" noChangeAspect="1"/>
-          </p:cNvPicPr>
+          <p:cNvSpPr>
+            <a:spLocks noGrp="1"/>
+          </p:cNvSpPr>
           <p:nvPr>
             <p:ph idx="1"/>
           </p:nvPr>
-        </p:nvPicPr>
-        <p:blipFill>
-          <a:blip r:embed="rId2"/>
-          <a:stretch>
-            <a:fillRect/>
-          </a:stretch>
-        </p:blipFill>
+        </p:nvSpPr>
         <p:spPr>
           <a:xfrm>
-            <a:off x="1214034" y="671936"/>
-            <a:ext cx="9763931" cy="5496345"/>
+            <a:off x="838200" y="2075658"/>
+            <a:ext cx="10515600" cy="3494087"/>
           </a:xfrm>
-          <a:prstGeom prst="rect">
-            <a:avLst/>
-          </a:prstGeom>
         </p:spPr>
-      </p:pic>
+        <p:txBody>
+          <a:bodyPr vert="horz" lIns="91440" tIns="45720" rIns="91440" bIns="45720" rtlCol="0" anchor="t">
+            <a:normAutofit/>
+          </a:bodyPr>
+          <a:lstStyle/>
+          <a:p>
+            <a:pPr marL="0" indent="0" algn="just">
+              <a:buNone/>
+            </a:pPr>
+            <a:r>
+              <a:rPr lang="pt-BR" dirty="0"/>
+              <a:t> </a:t>
+            </a:r>
+            <a:r>
+              <a:rPr lang="pt-BR" b="1" dirty="0"/>
+              <a:t>As funções de primeiro e segundo grau são ferramentas indispensáveis para os cálculos Físicos, convém observar que a Física procura explicar os eventos em todas as perspectivas, aninhando cálculos e fórmulas muitas vezes de forma complexa, no entanto a Matemática e seus fundamentos são o alicerce de todo o conhecimento, dominar a matemática é dominar a arte do saber.</a:t>
+            </a:r>
+            <a:endParaRPr lang="pt-BR"/>
+          </a:p>
+        </p:txBody>
+      </p:sp>
     </p:spTree>
     <p:extLst>
       <p:ext uri="{BB962C8B-B14F-4D97-AF65-F5344CB8AC3E}">
-        <p14:creationId xmlns:p14="http://schemas.microsoft.com/office/powerpoint/2010/main" val="3943872998"/>
+        <p14:creationId xmlns:p14="http://schemas.microsoft.com/office/powerpoint/2010/main" val="3558005273"/>
       </p:ext>
     </p:extLst>
   </p:cSld>
@@ -3528,114 +3308,105 @@
           <a:chExt cx="0" cy="0"/>
         </a:xfrm>
       </p:grpSpPr>
-      <p:pic>
-        <p:nvPicPr>
-          <p:cNvPr id="9" name="Espaço Reservado para Conteúdo 8" descr="Gráfico, Histograma&#10;&#10;O conteúdo gerado por IA pode estar incorreto.">
+      <p:sp>
+        <p:nvSpPr>
+          <p:cNvPr id="2" name="Título 1">
             <a:extLst>
               <a:ext uri="{FF2B5EF4-FFF2-40B4-BE49-F238E27FC236}">
-                <a16:creationId xmlns:a16="http://schemas.microsoft.com/office/drawing/2014/main" id="{D3272C6B-653D-F769-143C-A19217BEA615}"/>
+                <a16:creationId xmlns:a16="http://schemas.microsoft.com/office/drawing/2014/main" id="{8D4EF041-2689-DD29-22F1-83FE7A39B02E}"/>
               </a:ext>
             </a:extLst>
           </p:cNvPr>
-          <p:cNvPicPr>
-            <a:picLocks noGrp="1" noChangeAspect="1"/>
-          </p:cNvPicPr>
-          <p:nvPr>
-            <p:ph idx="1"/>
-          </p:nvPr>
-        </p:nvPicPr>
-        <p:blipFill>
-          <a:blip r:embed="rId2"/>
-          <a:stretch>
-            <a:fillRect/>
-          </a:stretch>
-        </p:blipFill>
-        <p:spPr>
-          <a:xfrm>
-            <a:off x="1821052" y="172934"/>
-            <a:ext cx="8536982" cy="4931603"/>
-          </a:xfrm>
-          <a:prstGeom prst="rect">
-            <a:avLst/>
-          </a:prstGeom>
-        </p:spPr>
-      </p:pic>
-      <p:sp>
-        <p:nvSpPr>
-          <p:cNvPr id="10" name="CaixaDeTexto 9">
+          <p:cNvSpPr>
+            <a:spLocks noGrp="1"/>
+          </p:cNvSpPr>
+          <p:nvPr>
+            <p:ph type="title"/>
+          </p:nvPr>
+        </p:nvSpPr>
+        <p:spPr/>
+        <p:txBody>
+          <a:bodyPr/>
+          <a:lstStyle/>
+          <a:p>
+            <a:r>
+              <a:rPr lang="pt-BR" dirty="0"/>
+              <a:t>Referências</a:t>
+            </a:r>
+          </a:p>
+        </p:txBody>
+      </p:sp>
+      <p:sp>
+        <p:nvSpPr>
+          <p:cNvPr id="3" name="Espaço Reservado para Conteúdo 2">
             <a:extLst>
               <a:ext uri="{FF2B5EF4-FFF2-40B4-BE49-F238E27FC236}">
-                <a16:creationId xmlns:a16="http://schemas.microsoft.com/office/drawing/2014/main" id="{46CD4587-7418-A277-4A20-A58C2BB937DC}"/>
+                <a16:creationId xmlns:a16="http://schemas.microsoft.com/office/drawing/2014/main" id="{4306702C-EEB1-E495-8400-3DD2097D7CA0}"/>
               </a:ext>
             </a:extLst>
           </p:cNvPr>
-          <p:cNvSpPr txBox="1"/>
-          <p:nvPr/>
-        </p:nvSpPr>
-        <p:spPr>
-          <a:xfrm>
-            <a:off x="1017456" y="5315778"/>
-            <a:ext cx="10164151" cy="523220"/>
-          </a:xfrm>
-          <a:prstGeom prst="rect">
-            <a:avLst/>
-          </a:prstGeom>
-          <a:noFill/>
-        </p:spPr>
-        <p:txBody>
-          <a:bodyPr rot="0" spcFirstLastPara="0" vertOverflow="overflow" horzOverflow="overflow" vert="horz" wrap="square" lIns="91440" tIns="45720" rIns="91440" bIns="45720" numCol="1" spcCol="0" rtlCol="0" fromWordArt="0" anchor="t" anchorCtr="0" forceAA="0" compatLnSpc="1">
-            <a:prstTxWarp prst="textNoShape">
-              <a:avLst/>
-            </a:prstTxWarp>
-            <a:spAutoFit/>
+          <p:cNvSpPr>
+            <a:spLocks noGrp="1"/>
+          </p:cNvSpPr>
+          <p:nvPr>
+            <p:ph idx="1"/>
+          </p:nvPr>
+        </p:nvSpPr>
+        <p:spPr/>
+        <p:txBody>
+          <a:bodyPr vert="horz" lIns="91440" tIns="45720" rIns="91440" bIns="45720" rtlCol="0" anchor="t">
+            <a:normAutofit/>
           </a:bodyPr>
           <a:lstStyle/>
           <a:p>
-            <a:r>
-              <a:rPr lang="pt-BR" sz="2800" b="1" dirty="0">
-                <a:solidFill>
-                  <a:srgbClr val="FF0000"/>
-                </a:solidFill>
-              </a:rPr>
-              <a:t>Suponha que dividimos o tempo em intervalos muito curtos:</a:t>
-            </a:r>
-          </a:p>
-        </p:txBody>
-      </p:sp>
-      <p:pic>
-        <p:nvPicPr>
-          <p:cNvPr id="11" name="Imagem 10">
-            <a:extLst>
-              <a:ext uri="{FF2B5EF4-FFF2-40B4-BE49-F238E27FC236}">
-                <a16:creationId xmlns:a16="http://schemas.microsoft.com/office/drawing/2014/main" id="{1AF5B863-2A14-AAF5-E6F6-0F4225995872}"/>
-              </a:ext>
-            </a:extLst>
-          </p:cNvPr>
-          <p:cNvPicPr>
-            <a:picLocks noChangeAspect="1"/>
-          </p:cNvPicPr>
-          <p:nvPr/>
-        </p:nvPicPr>
-        <p:blipFill>
-          <a:blip r:embed="rId3"/>
-          <a:stretch>
-            <a:fillRect/>
-          </a:stretch>
-        </p:blipFill>
-        <p:spPr>
-          <a:xfrm>
-            <a:off x="4616264" y="6022601"/>
-            <a:ext cx="2959473" cy="606238"/>
-          </a:xfrm>
-          <a:prstGeom prst="rect">
-            <a:avLst/>
-          </a:prstGeom>
-        </p:spPr>
-      </p:pic>
+            <a:pPr algn="just"/>
+            <a:r>
+              <a:rPr lang="pt-BR" sz="2000" b="1" dirty="0"/>
+              <a:t>ChatGPT,</a:t>
+            </a:r>
+          </a:p>
+          <a:p>
+            <a:pPr algn="just"/>
+            <a:r>
+              <a:rPr lang="pt-BR" sz="2000" b="1" dirty="0"/>
+              <a:t>Microsoft </a:t>
+            </a:r>
+            <a:r>
+              <a:rPr lang="pt-BR" sz="2000" b="1" err="1"/>
+              <a:t>copilot</a:t>
+            </a:r>
+            <a:r>
+              <a:rPr lang="pt-BR" sz="2000" b="1" dirty="0"/>
+              <a:t>,</a:t>
+            </a:r>
+          </a:p>
+          <a:p>
+            <a:pPr algn="just"/>
+            <a:r>
+              <a:rPr lang="pt-BR" sz="2000" b="1" dirty="0"/>
+              <a:t>Google AI,</a:t>
+            </a:r>
+          </a:p>
+          <a:p>
+            <a:pPr algn="just"/>
+            <a:endParaRPr lang="pt-BR" sz="2000" b="1" dirty="0"/>
+          </a:p>
+          <a:p>
+            <a:pPr algn="just"/>
+            <a:r>
+              <a:rPr lang="pt-BR" sz="2000" b="1" dirty="0"/>
+              <a:t>Os fundamentos da Física, Ramalho, Ivan, Nicolau, Toledo. Volume um, mecânica, páginas 97,98. (exercícios resolvidos, R.30).</a:t>
+            </a:r>
+          </a:p>
+          <a:p>
+            <a:endParaRPr lang="pt-BR" dirty="0"/>
+          </a:p>
+        </p:txBody>
+      </p:sp>
     </p:spTree>
     <p:extLst>
       <p:ext uri="{BB962C8B-B14F-4D97-AF65-F5344CB8AC3E}">
-        <p14:creationId xmlns:p14="http://schemas.microsoft.com/office/powerpoint/2010/main" val="2199550546"/>
+        <p14:creationId xmlns:p14="http://schemas.microsoft.com/office/powerpoint/2010/main" val="1113526587"/>
       </p:ext>
     </p:extLst>
   </p:cSld>
@@ -3662,12 +3433,47 @@
           <a:chExt cx="0" cy="0"/>
         </a:xfrm>
       </p:grpSpPr>
+      <p:sp>
+        <p:nvSpPr>
+          <p:cNvPr id="2" name="Título 1">
+            <a:extLst>
+              <a:ext uri="{FF2B5EF4-FFF2-40B4-BE49-F238E27FC236}">
+                <a16:creationId xmlns:a16="http://schemas.microsoft.com/office/drawing/2014/main" id="{E8E54657-1E17-489E-F829-EEDA04AE0552}"/>
+              </a:ext>
+            </a:extLst>
+          </p:cNvPr>
+          <p:cNvSpPr>
+            <a:spLocks noGrp="1"/>
+          </p:cNvSpPr>
+          <p:nvPr>
+            <p:ph type="title"/>
+          </p:nvPr>
+        </p:nvSpPr>
+        <p:spPr>
+          <a:xfrm>
+            <a:off x="5088731" y="365125"/>
+            <a:ext cx="2014538" cy="873126"/>
+          </a:xfrm>
+        </p:spPr>
+        <p:txBody>
+          <a:bodyPr>
+            <a:normAutofit/>
+          </a:bodyPr>
+          <a:lstStyle/>
+          <a:p>
+            <a:r>
+              <a:rPr lang="pt-BR" sz="2000" b="1" dirty="0"/>
+              <a:t>Interatividade</a:t>
+            </a:r>
+          </a:p>
+        </p:txBody>
+      </p:sp>
       <p:pic>
         <p:nvPicPr>
-          <p:cNvPr id="4" name="Imagem 3" descr="Texto, Tabela&#10;&#10;O conteúdo gerado por IA pode estar incorreto.">
+          <p:cNvPr id="4" name="Imagem 3" descr="Código QR&#10;&#10;O conteúdo gerado por IA pode estar incorreto.">
             <a:extLst>
               <a:ext uri="{FF2B5EF4-FFF2-40B4-BE49-F238E27FC236}">
-                <a16:creationId xmlns:a16="http://schemas.microsoft.com/office/drawing/2014/main" id="{53C1A71B-2341-52E0-968A-999D06C9507D}"/>
+                <a16:creationId xmlns:a16="http://schemas.microsoft.com/office/drawing/2014/main" id="{0EE23786-9A3E-0BF6-266C-771738BA0B0F}"/>
               </a:ext>
             </a:extLst>
           </p:cNvPr>
@@ -3684,8 +3490,8 @@
         </p:blipFill>
         <p:spPr>
           <a:xfrm>
-            <a:off x="816909" y="412656"/>
-            <a:ext cx="10558181" cy="6043892"/>
+            <a:off x="3952875" y="1285875"/>
+            <a:ext cx="4286250" cy="4286250"/>
           </a:xfrm>
           <a:prstGeom prst="rect">
             <a:avLst/>
@@ -3695,838 +3501,7 @@
     </p:spTree>
     <p:extLst>
       <p:ext uri="{BB962C8B-B14F-4D97-AF65-F5344CB8AC3E}">
-        <p14:creationId xmlns:p14="http://schemas.microsoft.com/office/powerpoint/2010/main" val="3476188114"/>
-      </p:ext>
-    </p:extLst>
-  </p:cSld>
-  <p:clrMapOvr>
-    <a:masterClrMapping/>
-  </p:clrMapOvr>
-</p:sld>
-</file>
-
-<file path=ppt/slides/slide15.xml><?xml version="1.0" encoding="utf-8"?>
-<p:sld xmlns:a="http://schemas.openxmlformats.org/drawingml/2006/main" xmlns:r="http://schemas.openxmlformats.org/officeDocument/2006/relationships" xmlns:p="http://schemas.openxmlformats.org/presentationml/2006/main">
-  <p:cSld>
-    <p:spTree>
-      <p:nvGrpSpPr>
-        <p:cNvPr id="1" name=""/>
-        <p:cNvGrpSpPr/>
-        <p:nvPr/>
-      </p:nvGrpSpPr>
-      <p:grpSpPr>
-        <a:xfrm>
-          <a:off x="0" y="0"/>
-          <a:ext cx="0" cy="0"/>
-          <a:chOff x="0" y="0"/>
-          <a:chExt cx="0" cy="0"/>
-        </a:xfrm>
-      </p:grpSpPr>
-      <p:pic>
-        <p:nvPicPr>
-          <p:cNvPr id="4" name="Imagem 3" descr="Uma imagem contendo Diagrama&#10;&#10;O conteúdo gerado por IA pode estar incorreto.">
-            <a:extLst>
-              <a:ext uri="{FF2B5EF4-FFF2-40B4-BE49-F238E27FC236}">
-                <a16:creationId xmlns:a16="http://schemas.microsoft.com/office/drawing/2014/main" id="{DBEEF924-753E-7ED0-D35E-E4BF0D14D643}"/>
-              </a:ext>
-            </a:extLst>
-          </p:cNvPr>
-          <p:cNvPicPr>
-            <a:picLocks noChangeAspect="1"/>
-          </p:cNvPicPr>
-          <p:nvPr/>
-        </p:nvPicPr>
-        <p:blipFill>
-          <a:blip r:embed="rId2"/>
-          <a:stretch>
-            <a:fillRect/>
-          </a:stretch>
-        </p:blipFill>
-        <p:spPr>
-          <a:xfrm>
-            <a:off x="900113" y="556092"/>
-            <a:ext cx="10391774" cy="5757021"/>
-          </a:xfrm>
-          <a:prstGeom prst="rect">
-            <a:avLst/>
-          </a:prstGeom>
-        </p:spPr>
-      </p:pic>
-    </p:spTree>
-    <p:extLst>
-      <p:ext uri="{BB962C8B-B14F-4D97-AF65-F5344CB8AC3E}">
-        <p14:creationId xmlns:p14="http://schemas.microsoft.com/office/powerpoint/2010/main" val="688746372"/>
-      </p:ext>
-    </p:extLst>
-  </p:cSld>
-  <p:clrMapOvr>
-    <a:masterClrMapping/>
-  </p:clrMapOvr>
-</p:sld>
-</file>
-
-<file path=ppt/slides/slide16.xml><?xml version="1.0" encoding="utf-8"?>
-<p:sld xmlns:a="http://schemas.openxmlformats.org/drawingml/2006/main" xmlns:r="http://schemas.openxmlformats.org/officeDocument/2006/relationships" xmlns:p="http://schemas.openxmlformats.org/presentationml/2006/main">
-  <p:cSld>
-    <p:spTree>
-      <p:nvGrpSpPr>
-        <p:cNvPr id="1" name=""/>
-        <p:cNvGrpSpPr/>
-        <p:nvPr/>
-      </p:nvGrpSpPr>
-      <p:grpSpPr>
-        <a:xfrm>
-          <a:off x="0" y="0"/>
-          <a:ext cx="0" cy="0"/>
-          <a:chOff x="0" y="0"/>
-          <a:chExt cx="0" cy="0"/>
-        </a:xfrm>
-      </p:grpSpPr>
-      <p:pic>
-        <p:nvPicPr>
-          <p:cNvPr id="4" name="Imagem 3">
-            <a:extLst>
-              <a:ext uri="{FF2B5EF4-FFF2-40B4-BE49-F238E27FC236}">
-                <a16:creationId xmlns:a16="http://schemas.microsoft.com/office/drawing/2014/main" id="{6190FDC2-FD90-8AB1-0932-14E95A41CF12}"/>
-              </a:ext>
-            </a:extLst>
-          </p:cNvPr>
-          <p:cNvPicPr>
-            <a:picLocks noChangeAspect="1"/>
-          </p:cNvPicPr>
-          <p:nvPr/>
-        </p:nvPicPr>
-        <p:blipFill>
-          <a:blip r:embed="rId2"/>
-          <a:stretch>
-            <a:fillRect/>
-          </a:stretch>
-        </p:blipFill>
-        <p:spPr>
-          <a:xfrm>
-            <a:off x="961218" y="226905"/>
-            <a:ext cx="10269564" cy="6404190"/>
-          </a:xfrm>
-          <a:prstGeom prst="rect">
-            <a:avLst/>
-          </a:prstGeom>
-        </p:spPr>
-      </p:pic>
-    </p:spTree>
-    <p:extLst>
-      <p:ext uri="{BB962C8B-B14F-4D97-AF65-F5344CB8AC3E}">
-        <p14:creationId xmlns:p14="http://schemas.microsoft.com/office/powerpoint/2010/main" val="4033611569"/>
-      </p:ext>
-    </p:extLst>
-  </p:cSld>
-  <p:clrMapOvr>
-    <a:masterClrMapping/>
-  </p:clrMapOvr>
-</p:sld>
-</file>
-
-<file path=ppt/slides/slide17.xml><?xml version="1.0" encoding="utf-8"?>
-<p:sld xmlns:a="http://schemas.openxmlformats.org/drawingml/2006/main" xmlns:r="http://schemas.openxmlformats.org/officeDocument/2006/relationships" xmlns:p="http://schemas.openxmlformats.org/presentationml/2006/main">
-  <p:cSld>
-    <p:spTree>
-      <p:nvGrpSpPr>
-        <p:cNvPr id="1" name=""/>
-        <p:cNvGrpSpPr/>
-        <p:nvPr/>
-      </p:nvGrpSpPr>
-      <p:grpSpPr>
-        <a:xfrm>
-          <a:off x="0" y="0"/>
-          <a:ext cx="0" cy="0"/>
-          <a:chOff x="0" y="0"/>
-          <a:chExt cx="0" cy="0"/>
-        </a:xfrm>
-      </p:grpSpPr>
-      <p:pic>
-        <p:nvPicPr>
-          <p:cNvPr id="5" name="Imagem 4" descr="Tela de celular com texto preto sobre fundo branco&#10;&#10;O conteúdo gerado por IA pode estar incorreto.">
-            <a:extLst>
-              <a:ext uri="{FF2B5EF4-FFF2-40B4-BE49-F238E27FC236}">
-                <a16:creationId xmlns:a16="http://schemas.microsoft.com/office/drawing/2014/main" id="{00B8D45E-1EBD-FAD6-22BB-1299EEB2D517}"/>
-              </a:ext>
-            </a:extLst>
-          </p:cNvPr>
-          <p:cNvPicPr>
-            <a:picLocks noChangeAspect="1"/>
-          </p:cNvPicPr>
-          <p:nvPr/>
-        </p:nvPicPr>
-        <p:blipFill>
-          <a:blip r:embed="rId2"/>
-          <a:stretch>
-            <a:fillRect/>
-          </a:stretch>
-        </p:blipFill>
-        <p:spPr>
-          <a:xfrm>
-            <a:off x="564315" y="601205"/>
-            <a:ext cx="11063367" cy="5655588"/>
-          </a:xfrm>
-          <a:prstGeom prst="rect">
-            <a:avLst/>
-          </a:prstGeom>
-        </p:spPr>
-      </p:pic>
-    </p:spTree>
-    <p:extLst>
-      <p:ext uri="{BB962C8B-B14F-4D97-AF65-F5344CB8AC3E}">
-        <p14:creationId xmlns:p14="http://schemas.microsoft.com/office/powerpoint/2010/main" val="2350272116"/>
-      </p:ext>
-    </p:extLst>
-  </p:cSld>
-  <p:clrMapOvr>
-    <a:masterClrMapping/>
-  </p:clrMapOvr>
-</p:sld>
-</file>
-
-<file path=ppt/slides/slide18.xml><?xml version="1.0" encoding="utf-8"?>
-<p:sld xmlns:a="http://schemas.openxmlformats.org/drawingml/2006/main" xmlns:r="http://schemas.openxmlformats.org/officeDocument/2006/relationships" xmlns:p="http://schemas.openxmlformats.org/presentationml/2006/main">
-  <p:cSld>
-    <p:spTree>
-      <p:nvGrpSpPr>
-        <p:cNvPr id="1" name=""/>
-        <p:cNvGrpSpPr/>
-        <p:nvPr/>
-      </p:nvGrpSpPr>
-      <p:grpSpPr>
-        <a:xfrm>
-          <a:off x="0" y="0"/>
-          <a:ext cx="0" cy="0"/>
-          <a:chOff x="0" y="0"/>
-          <a:chExt cx="0" cy="0"/>
-        </a:xfrm>
-      </p:grpSpPr>
-      <p:sp>
-        <p:nvSpPr>
-          <p:cNvPr id="2" name="Título 1">
-            <a:extLst>
-              <a:ext uri="{FF2B5EF4-FFF2-40B4-BE49-F238E27FC236}">
-                <a16:creationId xmlns:a16="http://schemas.microsoft.com/office/drawing/2014/main" id="{6DBC1ABA-BF1D-D41B-306B-2B703A6294CB}"/>
-              </a:ext>
-            </a:extLst>
-          </p:cNvPr>
-          <p:cNvSpPr>
-            <a:spLocks noGrp="1"/>
-          </p:cNvSpPr>
-          <p:nvPr>
-            <p:ph type="title"/>
-          </p:nvPr>
-        </p:nvSpPr>
-        <p:spPr>
-          <a:xfrm>
-            <a:off x="1443318" y="219449"/>
-            <a:ext cx="9294159" cy="686829"/>
-          </a:xfrm>
-        </p:spPr>
-        <p:txBody>
-          <a:bodyPr>
-            <a:normAutofit/>
-          </a:bodyPr>
-          <a:lstStyle/>
-          <a:p>
-            <a:r>
-              <a:rPr lang="pt-BR" sz="3200" b="1" dirty="0">
-                <a:solidFill>
-                  <a:schemeClr val="accent2">
-                    <a:lumMod val="76000"/>
-                  </a:schemeClr>
-                </a:solidFill>
-                <a:latin typeface="Aptos"/>
-              </a:rPr>
-              <a:t>Problema matemático contextualizado na Física.</a:t>
-            </a:r>
-            <a:endParaRPr lang="pt-BR" sz="3200" b="1">
-              <a:solidFill>
-                <a:schemeClr val="accent2">
-                  <a:lumMod val="76000"/>
-                </a:schemeClr>
-              </a:solidFill>
-              <a:latin typeface="Aptos"/>
-            </a:endParaRPr>
-          </a:p>
-        </p:txBody>
-      </p:sp>
-      <p:sp>
-        <p:nvSpPr>
-          <p:cNvPr id="3" name="Espaço Reservado para Conteúdo 2">
-            <a:extLst>
-              <a:ext uri="{FF2B5EF4-FFF2-40B4-BE49-F238E27FC236}">
-                <a16:creationId xmlns:a16="http://schemas.microsoft.com/office/drawing/2014/main" id="{745148AE-CDAB-512E-5C44-2B6C60F2F433}"/>
-              </a:ext>
-            </a:extLst>
-          </p:cNvPr>
-          <p:cNvSpPr>
-            <a:spLocks noGrp="1"/>
-          </p:cNvSpPr>
-          <p:nvPr>
-            <p:ph idx="1"/>
-          </p:nvPr>
-        </p:nvSpPr>
-        <p:spPr>
-          <a:xfrm>
-            <a:off x="838200" y="1455831"/>
-            <a:ext cx="10515600" cy="4351338"/>
-          </a:xfrm>
-        </p:spPr>
-        <p:txBody>
-          <a:bodyPr vert="horz" lIns="91440" tIns="45720" rIns="91440" bIns="45720" rtlCol="0" anchor="t">
-            <a:normAutofit/>
-          </a:bodyPr>
-          <a:lstStyle/>
-          <a:p>
-            <a:pPr marL="0" indent="0" algn="just">
-              <a:buNone/>
-            </a:pPr>
-            <a:r>
-              <a:rPr lang="pt-BR" sz="3600" b="1" dirty="0"/>
-              <a:t> </a:t>
-            </a:r>
-            <a:r>
-              <a:rPr lang="pt-BR" b="1" dirty="0"/>
-              <a:t>Um móvel descreve um MUV numa trajetória retilínea e os seus espaços variam no tempo de acordo com a expressão:</a:t>
-            </a:r>
-            <a:r>
-              <a:rPr lang="pt-BR" b="1" dirty="0">
-                <a:latin typeface="Aptos"/>
-              </a:rPr>
-              <a:t> </a:t>
-            </a:r>
-            <a:r>
-              <a:rPr lang="pt-BR" dirty="0">
-                <a:latin typeface="Consolas"/>
-              </a:rPr>
-              <a:t>S = 9 + 3t − 2t² </a:t>
-            </a:r>
-            <a:r>
-              <a:rPr lang="pt-BR" b="1" dirty="0">
-                <a:latin typeface="Aptos"/>
-              </a:rPr>
-              <a:t>, onde o tempo é expresso em segundos e o espaço em metros.</a:t>
-            </a:r>
-            <a:endParaRPr lang="pt-BR"/>
-          </a:p>
-          <a:p>
-            <a:pPr marL="0" indent="0">
-              <a:buNone/>
-            </a:pPr>
-            <a:endParaRPr lang="pt-BR" sz="1200" b="1" dirty="0"/>
-          </a:p>
-          <a:p>
-            <a:pPr marL="0" indent="0">
-              <a:buNone/>
-            </a:pPr>
-            <a:endParaRPr lang="pt-BR" sz="1200" b="1" dirty="0"/>
-          </a:p>
-          <a:p>
-            <a:pPr algn="just">
-              <a:buNone/>
-            </a:pPr>
-            <a:r>
-              <a:rPr lang="pt-BR" b="1"/>
-              <a:t>Determinar:</a:t>
-            </a:r>
-            <a:endParaRPr lang="pt-BR" b="1" dirty="0"/>
-          </a:p>
-          <a:p>
-            <a:pPr marL="0" indent="0" algn="just">
-              <a:buNone/>
-            </a:pPr>
-            <a:r>
-              <a:rPr lang="pt-BR" b="1" dirty="0"/>
-              <a:t>a) A função da velocidade;</a:t>
-            </a:r>
-          </a:p>
-          <a:p>
-            <a:pPr marL="0" indent="0" algn="just">
-              <a:buNone/>
-            </a:pPr>
-            <a:r>
-              <a:rPr lang="pt-BR" b="1" dirty="0"/>
-              <a:t>b) O instante em que o móvel passa pela origem dos espaços.</a:t>
-            </a:r>
-          </a:p>
-          <a:p>
-            <a:pPr marL="0" indent="0">
-              <a:buNone/>
-            </a:pPr>
-            <a:endParaRPr lang="pt-BR" sz="1200" b="1" dirty="0"/>
-          </a:p>
-        </p:txBody>
-      </p:sp>
-    </p:spTree>
-    <p:extLst>
-      <p:ext uri="{BB962C8B-B14F-4D97-AF65-F5344CB8AC3E}">
-        <p14:creationId xmlns:p14="http://schemas.microsoft.com/office/powerpoint/2010/main" val="187554354"/>
-      </p:ext>
-    </p:extLst>
-  </p:cSld>
-  <p:clrMapOvr>
-    <a:masterClrMapping/>
-  </p:clrMapOvr>
-</p:sld>
-</file>
-
-<file path=ppt/slides/slide19.xml><?xml version="1.0" encoding="utf-8"?>
-<p:sld xmlns:a="http://schemas.openxmlformats.org/drawingml/2006/main" xmlns:r="http://schemas.openxmlformats.org/officeDocument/2006/relationships" xmlns:p="http://schemas.openxmlformats.org/presentationml/2006/main">
-  <p:cSld>
-    <p:spTree>
-      <p:nvGrpSpPr>
-        <p:cNvPr id="1" name=""/>
-        <p:cNvGrpSpPr/>
-        <p:nvPr/>
-      </p:nvGrpSpPr>
-      <p:grpSpPr>
-        <a:xfrm>
-          <a:off x="0" y="0"/>
-          <a:ext cx="0" cy="0"/>
-          <a:chOff x="0" y="0"/>
-          <a:chExt cx="0" cy="0"/>
-        </a:xfrm>
-      </p:grpSpPr>
-      <p:sp>
-        <p:nvSpPr>
-          <p:cNvPr id="2" name="Título 1">
-            <a:extLst>
-              <a:ext uri="{FF2B5EF4-FFF2-40B4-BE49-F238E27FC236}">
-                <a16:creationId xmlns:a16="http://schemas.microsoft.com/office/drawing/2014/main" id="{6131CF0C-FD8A-7D4B-7890-5E8301862104}"/>
-              </a:ext>
-            </a:extLst>
-          </p:cNvPr>
-          <p:cNvSpPr>
-            <a:spLocks noGrp="1"/>
-          </p:cNvSpPr>
-          <p:nvPr>
-            <p:ph type="title"/>
-          </p:nvPr>
-        </p:nvSpPr>
-        <p:spPr>
-          <a:xfrm>
-            <a:off x="707231" y="329406"/>
-            <a:ext cx="1907382" cy="480220"/>
-          </a:xfrm>
-        </p:spPr>
-        <p:txBody>
-          <a:bodyPr>
-            <a:normAutofit/>
-          </a:bodyPr>
-          <a:lstStyle/>
-          <a:p>
-            <a:r>
-              <a:rPr lang="pt-BR" sz="2800" b="1" dirty="0">
-                <a:solidFill>
-                  <a:srgbClr val="FF0000"/>
-                </a:solidFill>
-                <a:latin typeface="Aptos"/>
-              </a:rPr>
-              <a:t>Solução :</a:t>
-            </a:r>
-            <a:endParaRPr lang="pt-BR" sz="2800" dirty="0">
-              <a:solidFill>
-                <a:srgbClr val="FF0000"/>
-              </a:solidFill>
-              <a:latin typeface="Aptos"/>
-            </a:endParaRPr>
-          </a:p>
-        </p:txBody>
-      </p:sp>
-      <p:sp>
-        <p:nvSpPr>
-          <p:cNvPr id="3" name="Espaço Reservado para Conteúdo 2">
-            <a:extLst>
-              <a:ext uri="{FF2B5EF4-FFF2-40B4-BE49-F238E27FC236}">
-                <a16:creationId xmlns:a16="http://schemas.microsoft.com/office/drawing/2014/main" id="{286BEDDF-8BCE-50F9-220C-D35485A16C65}"/>
-              </a:ext>
-            </a:extLst>
-          </p:cNvPr>
-          <p:cNvSpPr>
-            <a:spLocks noGrp="1"/>
-          </p:cNvSpPr>
-          <p:nvPr>
-            <p:ph idx="1"/>
-          </p:nvPr>
-        </p:nvSpPr>
-        <p:spPr>
-          <a:xfrm>
-            <a:off x="1659731" y="5230814"/>
-            <a:ext cx="4157664" cy="469901"/>
-          </a:xfrm>
-        </p:spPr>
-        <p:txBody>
-          <a:bodyPr vert="horz" lIns="91440" tIns="45720" rIns="91440" bIns="45720" rtlCol="0" anchor="t">
-            <a:noAutofit/>
-          </a:bodyPr>
-          <a:lstStyle/>
-          <a:p>
-            <a:pPr marL="0" indent="0">
-              <a:buNone/>
-            </a:pPr>
-            <a:r>
-              <a:rPr lang="pt-BR" b="1" dirty="0">
-                <a:solidFill>
-                  <a:srgbClr val="FF0000"/>
-                </a:solidFill>
-                <a:latin typeface="Aptos"/>
-              </a:rPr>
-              <a:t>podemos concluir que:</a:t>
-            </a:r>
-            <a:endParaRPr lang="pt-BR" dirty="0">
-              <a:solidFill>
-                <a:srgbClr val="FF0000"/>
-              </a:solidFill>
-            </a:endParaRPr>
-          </a:p>
-          <a:p>
-            <a:pPr marL="0" indent="0">
-              <a:buNone/>
-            </a:pPr>
-            <a:endParaRPr lang="pt-BR" sz="2000" b="1" dirty="0">
-              <a:solidFill>
-                <a:srgbClr val="FF0000"/>
-              </a:solidFill>
-            </a:endParaRPr>
-          </a:p>
-        </p:txBody>
-      </p:sp>
-      <p:sp>
-        <p:nvSpPr>
-          <p:cNvPr id="5" name="CaixaDeTexto 4">
-            <a:extLst>
-              <a:ext uri="{FF2B5EF4-FFF2-40B4-BE49-F238E27FC236}">
-                <a16:creationId xmlns:a16="http://schemas.microsoft.com/office/drawing/2014/main" id="{6608B93A-23B0-052F-52DF-F21BED52246B}"/>
-              </a:ext>
-            </a:extLst>
-          </p:cNvPr>
-          <p:cNvSpPr txBox="1"/>
-          <p:nvPr/>
-        </p:nvSpPr>
-        <p:spPr>
-          <a:xfrm>
-            <a:off x="1544509" y="806982"/>
-            <a:ext cx="7934323" cy="523220"/>
-          </a:xfrm>
-          <a:prstGeom prst="rect">
-            <a:avLst/>
-          </a:prstGeom>
-          <a:noFill/>
-        </p:spPr>
-        <p:txBody>
-          <a:bodyPr rot="0" spcFirstLastPara="0" vertOverflow="overflow" horzOverflow="overflow" vert="horz" wrap="square" lIns="91440" tIns="45720" rIns="91440" bIns="45720" numCol="1" spcCol="0" rtlCol="0" fromWordArt="0" anchor="t" anchorCtr="0" forceAA="0" compatLnSpc="1">
-            <a:prstTxWarp prst="textNoShape">
-              <a:avLst/>
-            </a:prstTxWarp>
-            <a:spAutoFit/>
-          </a:bodyPr>
-          <a:lstStyle/>
-          <a:p>
-            <a:r>
-              <a:rPr lang="pt-BR" sz="2800" b="1" dirty="0">
-                <a:solidFill>
-                  <a:srgbClr val="FF0000"/>
-                </a:solidFill>
-              </a:rPr>
-              <a:t>a) Comparando a </a:t>
-            </a:r>
-            <a:r>
-              <a:rPr lang="pt-BR" sz="2800" b="1">
-                <a:solidFill>
-                  <a:srgbClr val="FF0000"/>
-                </a:solidFill>
-              </a:rPr>
-              <a:t>expressão dada</a:t>
-            </a:r>
-            <a:endParaRPr lang="pt-BR"/>
-          </a:p>
-        </p:txBody>
-      </p:sp>
-      <p:pic>
-        <p:nvPicPr>
-          <p:cNvPr id="6" name="Imagem 5">
-            <a:extLst>
-              <a:ext uri="{FF2B5EF4-FFF2-40B4-BE49-F238E27FC236}">
-                <a16:creationId xmlns:a16="http://schemas.microsoft.com/office/drawing/2014/main" id="{32F32101-6BA5-5FC6-C705-DBFB18B61EBB}"/>
-              </a:ext>
-            </a:extLst>
-          </p:cNvPr>
-          <p:cNvPicPr>
-            <a:picLocks noChangeAspect="1"/>
-          </p:cNvPicPr>
-          <p:nvPr/>
-        </p:nvPicPr>
-        <p:blipFill>
-          <a:blip r:embed="rId2"/>
-          <a:stretch>
-            <a:fillRect/>
-          </a:stretch>
-        </p:blipFill>
-        <p:spPr>
-          <a:xfrm>
-            <a:off x="4169569" y="1331118"/>
-            <a:ext cx="1924050" cy="409575"/>
-          </a:xfrm>
-          <a:prstGeom prst="rect">
-            <a:avLst/>
-          </a:prstGeom>
-        </p:spPr>
-      </p:pic>
-      <p:sp>
-        <p:nvSpPr>
-          <p:cNvPr id="8" name="CaixaDeTexto 7">
-            <a:extLst>
-              <a:ext uri="{FF2B5EF4-FFF2-40B4-BE49-F238E27FC236}">
-                <a16:creationId xmlns:a16="http://schemas.microsoft.com/office/drawing/2014/main" id="{CBEB960A-9369-DB03-6F9E-CB4CA5D078C6}"/>
-              </a:ext>
-            </a:extLst>
-          </p:cNvPr>
-          <p:cNvSpPr txBox="1"/>
-          <p:nvPr/>
-        </p:nvSpPr>
-        <p:spPr>
-          <a:xfrm>
-            <a:off x="1545170" y="1736468"/>
-            <a:ext cx="2743199" cy="523220"/>
-          </a:xfrm>
-          <a:prstGeom prst="rect">
-            <a:avLst/>
-          </a:prstGeom>
-          <a:noFill/>
-        </p:spPr>
-        <p:txBody>
-          <a:bodyPr rot="0" spcFirstLastPara="0" vertOverflow="overflow" horzOverflow="overflow" vert="horz" wrap="square" lIns="91440" tIns="45720" rIns="91440" bIns="45720" numCol="1" spcCol="0" rtlCol="0" fromWordArt="0" anchor="t" anchorCtr="0" forceAA="0" compatLnSpc="1">
-            <a:prstTxWarp prst="textNoShape">
-              <a:avLst/>
-            </a:prstTxWarp>
-            <a:spAutoFit/>
-          </a:bodyPr>
-          <a:lstStyle/>
-          <a:p>
-            <a:r>
-              <a:rPr lang="pt-BR" sz="2800" b="1" dirty="0">
-                <a:solidFill>
-                  <a:srgbClr val="FF0000"/>
-                </a:solidFill>
-              </a:rPr>
-              <a:t>com a função</a:t>
-            </a:r>
-            <a:endParaRPr lang="pt-BR" dirty="0"/>
-          </a:p>
-        </p:txBody>
-      </p:sp>
-      <p:pic>
-        <p:nvPicPr>
-          <p:cNvPr id="4" name="Imagem 3">
-            <a:extLst>
-              <a:ext uri="{FF2B5EF4-FFF2-40B4-BE49-F238E27FC236}">
-                <a16:creationId xmlns:a16="http://schemas.microsoft.com/office/drawing/2014/main" id="{82199B4D-F181-9272-1BBD-599FEF792378}"/>
-              </a:ext>
-            </a:extLst>
-          </p:cNvPr>
-          <p:cNvPicPr>
-            <a:picLocks noChangeAspect="1"/>
-          </p:cNvPicPr>
-          <p:nvPr/>
-        </p:nvPicPr>
-        <p:blipFill>
-          <a:blip r:embed="rId3"/>
-          <a:stretch>
-            <a:fillRect/>
-          </a:stretch>
-        </p:blipFill>
-        <p:spPr>
-          <a:xfrm>
-            <a:off x="4069556" y="2264569"/>
-            <a:ext cx="2266950" cy="495300"/>
-          </a:xfrm>
-          <a:prstGeom prst="rect">
-            <a:avLst/>
-          </a:prstGeom>
-        </p:spPr>
-      </p:pic>
-      <p:sp>
-        <p:nvSpPr>
-          <p:cNvPr id="7" name="CaixaDeTexto 6">
-            <a:extLst>
-              <a:ext uri="{FF2B5EF4-FFF2-40B4-BE49-F238E27FC236}">
-                <a16:creationId xmlns:a16="http://schemas.microsoft.com/office/drawing/2014/main" id="{69A1F6BF-10F1-6992-4C13-E7D2E6727840}"/>
-              </a:ext>
-            </a:extLst>
-          </p:cNvPr>
-          <p:cNvSpPr txBox="1"/>
-          <p:nvPr/>
-        </p:nvSpPr>
-        <p:spPr>
-          <a:xfrm>
-            <a:off x="1657753" y="2766493"/>
-            <a:ext cx="6993729" cy="523220"/>
-          </a:xfrm>
-          <a:prstGeom prst="rect">
-            <a:avLst/>
-          </a:prstGeom>
-          <a:noFill/>
-        </p:spPr>
-        <p:txBody>
-          <a:bodyPr rot="0" spcFirstLastPara="0" vertOverflow="overflow" horzOverflow="overflow" vert="horz" wrap="square" lIns="91440" tIns="45720" rIns="91440" bIns="45720" numCol="1" spcCol="0" rtlCol="0" fromWordArt="0" anchor="t" anchorCtr="0" forceAA="0" compatLnSpc="1">
-            <a:prstTxWarp prst="textNoShape">
-              <a:avLst/>
-            </a:prstTxWarp>
-            <a:spAutoFit/>
-          </a:bodyPr>
-          <a:lstStyle/>
-          <a:p>
-            <a:r>
-              <a:rPr lang="pt-BR" sz="2800" b="1" dirty="0">
-                <a:solidFill>
-                  <a:srgbClr val="FF0000"/>
-                </a:solidFill>
-              </a:rPr>
-              <a:t>Podemos observar no enunciado que</a:t>
-            </a:r>
-            <a:endParaRPr lang="pt-BR" dirty="0"/>
-          </a:p>
-        </p:txBody>
-      </p:sp>
-      <p:pic>
-        <p:nvPicPr>
-          <p:cNvPr id="9" name="Imagem 8" descr="Gráfico, Gráfico de caixa estreita&#10;&#10;O conteúdo gerado por IA pode estar incorreto.">
-            <a:extLst>
-              <a:ext uri="{FF2B5EF4-FFF2-40B4-BE49-F238E27FC236}">
-                <a16:creationId xmlns:a16="http://schemas.microsoft.com/office/drawing/2014/main" id="{FA635B70-EF88-72CE-C5A4-291738C48233}"/>
-              </a:ext>
-            </a:extLst>
-          </p:cNvPr>
-          <p:cNvPicPr>
-            <a:picLocks noChangeAspect="1"/>
-          </p:cNvPicPr>
-          <p:nvPr/>
-        </p:nvPicPr>
-        <p:blipFill>
-          <a:blip r:embed="rId4"/>
-          <a:stretch>
-            <a:fillRect/>
-          </a:stretch>
-        </p:blipFill>
-        <p:spPr>
-          <a:xfrm>
-            <a:off x="3743325" y="3286125"/>
-            <a:ext cx="3514725" cy="666750"/>
-          </a:xfrm>
-          <a:prstGeom prst="rect">
-            <a:avLst/>
-          </a:prstGeom>
-        </p:spPr>
-      </p:pic>
-      <p:sp>
-        <p:nvSpPr>
-          <p:cNvPr id="10" name="CaixaDeTexto 9">
-            <a:extLst>
-              <a:ext uri="{FF2B5EF4-FFF2-40B4-BE49-F238E27FC236}">
-                <a16:creationId xmlns:a16="http://schemas.microsoft.com/office/drawing/2014/main" id="{AAE7C4C2-6D3F-6D29-0B0B-04C32C5E6EFE}"/>
-              </a:ext>
-            </a:extLst>
-          </p:cNvPr>
-          <p:cNvSpPr txBox="1"/>
-          <p:nvPr/>
-        </p:nvSpPr>
-        <p:spPr>
-          <a:xfrm>
-            <a:off x="1669526" y="3953683"/>
-            <a:ext cx="6469855" cy="523220"/>
-          </a:xfrm>
-          <a:prstGeom prst="rect">
-            <a:avLst/>
-          </a:prstGeom>
-          <a:noFill/>
-        </p:spPr>
-        <p:txBody>
-          <a:bodyPr rot="0" spcFirstLastPara="0" vertOverflow="overflow" horzOverflow="overflow" vert="horz" wrap="square" lIns="91440" tIns="45720" rIns="91440" bIns="45720" numCol="1" spcCol="0" rtlCol="0" fromWordArt="0" anchor="t" anchorCtr="0" forceAA="0" compatLnSpc="1">
-            <a:prstTxWarp prst="textNoShape">
-              <a:avLst/>
-            </a:prstTxWarp>
-            <a:spAutoFit/>
-          </a:bodyPr>
-          <a:lstStyle/>
-          <a:p>
-            <a:r>
-              <a:rPr lang="pt-BR" sz="2800" b="1" dirty="0">
-                <a:solidFill>
-                  <a:srgbClr val="FF0000"/>
-                </a:solidFill>
-              </a:rPr>
-              <a:t>Sendo a função da velocidade </a:t>
-            </a:r>
-            <a:endParaRPr lang="pt-BR" dirty="0"/>
-          </a:p>
-        </p:txBody>
-      </p:sp>
-      <p:pic>
-        <p:nvPicPr>
-          <p:cNvPr id="11" name="Imagem 10">
-            <a:extLst>
-              <a:ext uri="{FF2B5EF4-FFF2-40B4-BE49-F238E27FC236}">
-                <a16:creationId xmlns:a16="http://schemas.microsoft.com/office/drawing/2014/main" id="{6CE0EFFA-AC1B-CF47-894A-9D8856150B69}"/>
-              </a:ext>
-            </a:extLst>
-          </p:cNvPr>
-          <p:cNvPicPr>
-            <a:picLocks noChangeAspect="1"/>
-          </p:cNvPicPr>
-          <p:nvPr/>
-        </p:nvPicPr>
-        <p:blipFill>
-          <a:blip r:embed="rId5"/>
-          <a:stretch>
-            <a:fillRect/>
-          </a:stretch>
-        </p:blipFill>
-        <p:spPr>
-          <a:xfrm>
-            <a:off x="3907631" y="4481512"/>
-            <a:ext cx="2269331" cy="514349"/>
-          </a:xfrm>
-          <a:prstGeom prst="rect">
-            <a:avLst/>
-          </a:prstGeom>
-        </p:spPr>
-      </p:pic>
-      <p:pic>
-        <p:nvPicPr>
-          <p:cNvPr id="12" name="Imagem 11" descr="Uma imagem contendo Texto&#10;&#10;O conteúdo gerado por IA pode estar incorreto.">
-            <a:extLst>
-              <a:ext uri="{FF2B5EF4-FFF2-40B4-BE49-F238E27FC236}">
-                <a16:creationId xmlns:a16="http://schemas.microsoft.com/office/drawing/2014/main" id="{2620A330-D2A4-A689-7930-77ADC1061706}"/>
-              </a:ext>
-            </a:extLst>
-          </p:cNvPr>
-          <p:cNvPicPr>
-            <a:picLocks noChangeAspect="1"/>
-          </p:cNvPicPr>
-          <p:nvPr/>
-        </p:nvPicPr>
-        <p:blipFill>
-          <a:blip r:embed="rId6"/>
-          <a:stretch>
-            <a:fillRect/>
-          </a:stretch>
-        </p:blipFill>
-        <p:spPr>
-          <a:xfrm>
-            <a:off x="3228975" y="5705475"/>
-            <a:ext cx="3638550" cy="638175"/>
-          </a:xfrm>
-          <a:prstGeom prst="rect">
-            <a:avLst/>
-          </a:prstGeom>
-        </p:spPr>
-      </p:pic>
-    </p:spTree>
-    <p:extLst>
-      <p:ext uri="{BB962C8B-B14F-4D97-AF65-F5344CB8AC3E}">
-        <p14:creationId xmlns:p14="http://schemas.microsoft.com/office/powerpoint/2010/main" val="2439332181"/>
+        <p14:creationId xmlns:p14="http://schemas.microsoft.com/office/powerpoint/2010/main" val="1372514761"/>
       </p:ext>
     </p:extLst>
   </p:cSld>
@@ -4811,939 +3786,13 @@
 </p:sld>
 </file>
 
-<file path=ppt/slides/slide20.xml><?xml version="1.0" encoding="utf-8"?>
-<p:sld xmlns:a="http://schemas.openxmlformats.org/drawingml/2006/main" xmlns:r="http://schemas.openxmlformats.org/officeDocument/2006/relationships" xmlns:p="http://schemas.openxmlformats.org/presentationml/2006/main">
-  <p:cSld>
-    <p:spTree>
-      <p:nvGrpSpPr>
-        <p:cNvPr id="1" name=""/>
-        <p:cNvGrpSpPr/>
-        <p:nvPr/>
-      </p:nvGrpSpPr>
-      <p:grpSpPr>
-        <a:xfrm>
-          <a:off x="0" y="0"/>
-          <a:ext cx="0" cy="0"/>
-          <a:chOff x="0" y="0"/>
-          <a:chExt cx="0" cy="0"/>
-        </a:xfrm>
-      </p:grpSpPr>
-      <p:sp>
-        <p:nvSpPr>
-          <p:cNvPr id="2" name="Título 1">
-            <a:extLst>
-              <a:ext uri="{FF2B5EF4-FFF2-40B4-BE49-F238E27FC236}">
-                <a16:creationId xmlns:a16="http://schemas.microsoft.com/office/drawing/2014/main" id="{E94E2F16-43D0-E607-009E-944AA205BBDC}"/>
-              </a:ext>
-            </a:extLst>
-          </p:cNvPr>
-          <p:cNvSpPr>
-            <a:spLocks noGrp="1"/>
-          </p:cNvSpPr>
-          <p:nvPr>
-            <p:ph type="title"/>
-          </p:nvPr>
-        </p:nvSpPr>
-        <p:spPr>
-          <a:xfrm>
-            <a:off x="3779044" y="246063"/>
-            <a:ext cx="4645819" cy="801689"/>
-          </a:xfrm>
-        </p:spPr>
-        <p:txBody>
-          <a:bodyPr>
-            <a:normAutofit/>
-          </a:bodyPr>
-          <a:lstStyle/>
-          <a:p>
-            <a:r>
-              <a:rPr lang="pt-BR" sz="3200" b="1" dirty="0">
-                <a:solidFill>
-                  <a:srgbClr val="FF0000"/>
-                </a:solidFill>
-              </a:rPr>
-              <a:t>O gráfico da função será: </a:t>
-            </a:r>
-          </a:p>
-        </p:txBody>
-      </p:sp>
-      <p:pic>
-        <p:nvPicPr>
-          <p:cNvPr id="4" name="Imagem 3" descr="Gráfico, Gráfico de linhas&#10;&#10;O conteúdo gerado por IA pode estar incorreto.">
-            <a:extLst>
-              <a:ext uri="{FF2B5EF4-FFF2-40B4-BE49-F238E27FC236}">
-                <a16:creationId xmlns:a16="http://schemas.microsoft.com/office/drawing/2014/main" id="{0D11BEC1-B8AE-8560-F121-CC3A3F7C5E43}"/>
-              </a:ext>
-            </a:extLst>
-          </p:cNvPr>
-          <p:cNvPicPr>
-            <a:picLocks noChangeAspect="1"/>
-          </p:cNvPicPr>
-          <p:nvPr/>
-        </p:nvPicPr>
-        <p:blipFill>
-          <a:blip r:embed="rId2"/>
-          <a:stretch>
-            <a:fillRect/>
-          </a:stretch>
-        </p:blipFill>
-        <p:spPr>
-          <a:xfrm>
-            <a:off x="2076046" y="1051140"/>
-            <a:ext cx="7729941" cy="5382109"/>
-          </a:xfrm>
-          <a:prstGeom prst="rect">
-            <a:avLst/>
-          </a:prstGeom>
-        </p:spPr>
-      </p:pic>
-    </p:spTree>
-    <p:extLst>
-      <p:ext uri="{BB962C8B-B14F-4D97-AF65-F5344CB8AC3E}">
-        <p14:creationId xmlns:p14="http://schemas.microsoft.com/office/powerpoint/2010/main" val="1931583805"/>
-      </p:ext>
-    </p:extLst>
-  </p:cSld>
-  <p:clrMapOvr>
-    <a:masterClrMapping/>
-  </p:clrMapOvr>
-</p:sld>
-</file>
-
-<file path=ppt/slides/slide21.xml><?xml version="1.0" encoding="utf-8"?>
-<p:sld xmlns:a="http://schemas.openxmlformats.org/drawingml/2006/main" xmlns:r="http://schemas.openxmlformats.org/officeDocument/2006/relationships" xmlns:p="http://schemas.openxmlformats.org/presentationml/2006/main">
-  <p:cSld>
-    <p:spTree>
-      <p:nvGrpSpPr>
-        <p:cNvPr id="1" name=""/>
-        <p:cNvGrpSpPr/>
-        <p:nvPr/>
-      </p:nvGrpSpPr>
-      <p:grpSpPr>
-        <a:xfrm>
-          <a:off x="0" y="0"/>
-          <a:ext cx="0" cy="0"/>
-          <a:chOff x="0" y="0"/>
-          <a:chExt cx="0" cy="0"/>
-        </a:xfrm>
-      </p:grpSpPr>
-      <p:sp>
-        <p:nvSpPr>
-          <p:cNvPr id="2" name="Título 1">
-            <a:extLst>
-              <a:ext uri="{FF2B5EF4-FFF2-40B4-BE49-F238E27FC236}">
-                <a16:creationId xmlns:a16="http://schemas.microsoft.com/office/drawing/2014/main" id="{9D39F1E5-FFC9-C6D1-C9F5-86D2A6A8A176}"/>
-              </a:ext>
-            </a:extLst>
-          </p:cNvPr>
-          <p:cNvSpPr>
-            <a:spLocks noGrp="1"/>
-          </p:cNvSpPr>
-          <p:nvPr>
-            <p:ph type="title"/>
-          </p:nvPr>
-        </p:nvSpPr>
-        <p:spPr>
-          <a:xfrm>
-            <a:off x="233083" y="-4669"/>
-            <a:ext cx="2335306" cy="866122"/>
-          </a:xfrm>
-        </p:spPr>
-        <p:txBody>
-          <a:bodyPr/>
-          <a:lstStyle/>
-          <a:p>
-            <a:r>
-              <a:rPr lang="pt-BR" sz="2800" b="1" dirty="0">
-                <a:solidFill>
-                  <a:srgbClr val="FF0000"/>
-                </a:solidFill>
-                <a:latin typeface="Aptos"/>
-              </a:rPr>
-              <a:t>Solução :</a:t>
-            </a:r>
-            <a:endParaRPr lang="pt-BR" dirty="0"/>
-          </a:p>
-        </p:txBody>
-      </p:sp>
-      <p:sp>
-        <p:nvSpPr>
-          <p:cNvPr id="3" name="Espaço Reservado para Conteúdo 2">
-            <a:extLst>
-              <a:ext uri="{FF2B5EF4-FFF2-40B4-BE49-F238E27FC236}">
-                <a16:creationId xmlns:a16="http://schemas.microsoft.com/office/drawing/2014/main" id="{49457BC3-FFAE-7C77-1A95-E15A0899BA24}"/>
-              </a:ext>
-            </a:extLst>
-          </p:cNvPr>
-          <p:cNvSpPr>
-            <a:spLocks noGrp="1"/>
-          </p:cNvSpPr>
-          <p:nvPr>
-            <p:ph idx="1"/>
-          </p:nvPr>
-        </p:nvSpPr>
-        <p:spPr>
-          <a:xfrm>
-            <a:off x="589569" y="897639"/>
-            <a:ext cx="11019864" cy="810981"/>
-          </a:xfrm>
-        </p:spPr>
-        <p:txBody>
-          <a:bodyPr vert="horz" lIns="91440" tIns="45720" rIns="91440" bIns="45720" rtlCol="0" anchor="t">
-            <a:normAutofit fontScale="92500"/>
-          </a:bodyPr>
-          <a:lstStyle/>
-          <a:p>
-            <a:pPr marL="0" indent="0">
-              <a:buNone/>
-            </a:pPr>
-            <a:r>
-              <a:rPr lang="pt-BR" sz="2000" b="1" dirty="0">
-                <a:solidFill>
-                  <a:srgbClr val="FF0000"/>
-                </a:solidFill>
-              </a:rPr>
-              <a:t> b) O móvel passa pela origem de espaços (marco zero) quando seu espaço S=0. Na equação, </a:t>
-            </a:r>
-            <a:r>
-              <a:rPr lang="pt-BR" sz="2000" dirty="0">
-                <a:solidFill>
-                  <a:srgbClr val="FF0000"/>
-                </a:solidFill>
-                <a:latin typeface="Consolas"/>
-              </a:rPr>
-              <a:t>S = 9 + 3t − 2t²</a:t>
-            </a:r>
-            <a:r>
-              <a:rPr lang="pt-BR" sz="1200" b="1" dirty="0">
-                <a:solidFill>
-                  <a:srgbClr val="FF0000"/>
-                </a:solidFill>
-                <a:latin typeface="Aptos"/>
-              </a:rPr>
-              <a:t>, </a:t>
-            </a:r>
-            <a:r>
-              <a:rPr lang="pt-BR" sz="2000" b="1" dirty="0">
-                <a:solidFill>
-                  <a:srgbClr val="FF0000"/>
-                </a:solidFill>
-                <a:latin typeface="Aptos"/>
-              </a:rPr>
-              <a:t>sendo S=0, organizando a equação, teremos: </a:t>
-            </a:r>
-            <a:r>
-              <a:rPr lang="pt-BR" sz="2000" dirty="0">
-                <a:solidFill>
-                  <a:srgbClr val="FF0000"/>
-                </a:solidFill>
-                <a:latin typeface="Consolas"/>
-              </a:rPr>
-              <a:t>2t² − 3t − 9 = 0.</a:t>
-            </a:r>
-            <a:endParaRPr lang="pt-BR" dirty="0"/>
-          </a:p>
-          <a:p>
-            <a:pPr algn="just">
-              <a:buNone/>
-            </a:pPr>
-            <a:endParaRPr lang="pt-BR" sz="2000" dirty="0">
-              <a:solidFill>
-                <a:srgbClr val="FF0000"/>
-              </a:solidFill>
-            </a:endParaRPr>
-          </a:p>
-          <a:p>
-            <a:pPr marL="0" indent="0" algn="just">
-              <a:buNone/>
-            </a:pPr>
-            <a:endParaRPr lang="pt-BR" sz="2000" b="1" dirty="0">
-              <a:solidFill>
-                <a:srgbClr val="FF0000"/>
-              </a:solidFill>
-              <a:latin typeface="Aptos"/>
-            </a:endParaRPr>
-          </a:p>
-          <a:p>
-            <a:pPr marL="0" indent="0">
-              <a:buNone/>
-            </a:pPr>
-            <a:endParaRPr lang="pt-BR" sz="2000" dirty="0">
-              <a:solidFill>
-                <a:srgbClr val="FF0000"/>
-              </a:solidFill>
-              <a:latin typeface="Consolas"/>
-            </a:endParaRPr>
-          </a:p>
-          <a:p>
-            <a:pPr marL="0" indent="0">
-              <a:buNone/>
-            </a:pPr>
-            <a:endParaRPr lang="pt-BR" sz="2000" b="1" dirty="0">
-              <a:solidFill>
-                <a:srgbClr val="FF0000"/>
-              </a:solidFill>
-            </a:endParaRPr>
-          </a:p>
-        </p:txBody>
-      </p:sp>
-      <p:sp>
-        <p:nvSpPr>
-          <p:cNvPr id="4" name="CaixaDeTexto 3">
-            <a:extLst>
-              <a:ext uri="{FF2B5EF4-FFF2-40B4-BE49-F238E27FC236}">
-                <a16:creationId xmlns:a16="http://schemas.microsoft.com/office/drawing/2014/main" id="{5397D842-AF9C-6FE1-E39F-5CC6C5DEFF24}"/>
-              </a:ext>
-            </a:extLst>
-          </p:cNvPr>
-          <p:cNvSpPr txBox="1"/>
-          <p:nvPr/>
-        </p:nvSpPr>
-        <p:spPr>
-          <a:xfrm>
-            <a:off x="587914" y="2043876"/>
-            <a:ext cx="11013141" cy="1631216"/>
-          </a:xfrm>
-          <a:prstGeom prst="rect">
-            <a:avLst/>
-          </a:prstGeom>
-          <a:noFill/>
-        </p:spPr>
-        <p:txBody>
-          <a:bodyPr rot="0" spcFirstLastPara="0" vertOverflow="overflow" horzOverflow="overflow" vert="horz" wrap="square" lIns="91440" tIns="45720" rIns="91440" bIns="45720" numCol="1" spcCol="0" rtlCol="0" fromWordArt="0" anchor="t" anchorCtr="0" forceAA="0" compatLnSpc="1">
-            <a:prstTxWarp prst="textNoShape">
-              <a:avLst/>
-            </a:prstTxWarp>
-            <a:spAutoFit/>
-          </a:bodyPr>
-          <a:lstStyle/>
-          <a:p>
-            <a:pPr algn="just"/>
-            <a:r>
-              <a:rPr lang="pt-BR" sz="2000" b="1" dirty="0">
-                <a:solidFill>
-                  <a:srgbClr val="FF0000"/>
-                </a:solidFill>
-                <a:ea typeface="+mn-lt"/>
-                <a:cs typeface="+mn-lt"/>
-              </a:rPr>
-              <a:t> Tratando-se de uma equação de segundo grau, poderemos achar o valor correspondentes do instante achando as raízes da equação, convém observar que o valor da raiz que procuramos deve ser maior que zero, pois a função horária define apenas instantes posteriores a um evento, nesse caso o tempo igual a zero. </a:t>
-            </a:r>
-            <a:endParaRPr lang="pt-BR" sz="2000" b="1">
-              <a:solidFill>
-                <a:srgbClr val="FF0000"/>
-              </a:solidFill>
-            </a:endParaRPr>
-          </a:p>
-          <a:p>
-            <a:pPr algn="just"/>
-            <a:r>
-              <a:rPr lang="pt-BR" sz="2000" b="1">
-                <a:solidFill>
-                  <a:srgbClr val="FF0000"/>
-                </a:solidFill>
-                <a:ea typeface="+mn-lt"/>
-                <a:cs typeface="+mn-lt"/>
-              </a:rPr>
-              <a:t> </a:t>
-            </a:r>
-            <a:r>
-              <a:rPr lang="pt-BR" sz="2000" b="1" dirty="0">
-                <a:solidFill>
-                  <a:srgbClr val="FF0000"/>
-                </a:solidFill>
-                <a:ea typeface="+mn-lt"/>
-                <a:cs typeface="+mn-lt"/>
-              </a:rPr>
-              <a:t>Prosseguindo o desenvolvimento pela fórmula de Bhaskara teremos:</a:t>
-            </a:r>
-            <a:r>
-              <a:rPr lang="pt-BR" dirty="0">
-                <a:ea typeface="+mn-lt"/>
-                <a:cs typeface="+mn-lt"/>
-              </a:rPr>
-              <a:t> </a:t>
-            </a:r>
-            <a:endParaRPr lang="pt-BR" dirty="0"/>
-          </a:p>
-        </p:txBody>
-      </p:sp>
-      <p:pic>
-        <p:nvPicPr>
-          <p:cNvPr id="5" name="Imagem 4" descr="Uma imagem contendo Diagrama&#10;&#10;O conteúdo gerado por IA pode estar incorreto.">
-            <a:extLst>
-              <a:ext uri="{FF2B5EF4-FFF2-40B4-BE49-F238E27FC236}">
-                <a16:creationId xmlns:a16="http://schemas.microsoft.com/office/drawing/2014/main" id="{FBB79119-94EA-7B46-5AE6-4A5124822E41}"/>
-              </a:ext>
-            </a:extLst>
-          </p:cNvPr>
-          <p:cNvPicPr>
-            <a:picLocks noChangeAspect="1"/>
-          </p:cNvPicPr>
-          <p:nvPr/>
-        </p:nvPicPr>
-        <p:blipFill>
-          <a:blip r:embed="rId2"/>
-          <a:stretch>
-            <a:fillRect/>
-          </a:stretch>
-        </p:blipFill>
-        <p:spPr>
-          <a:xfrm>
-            <a:off x="3248025" y="3957918"/>
-            <a:ext cx="5695950" cy="1295400"/>
-          </a:xfrm>
-          <a:prstGeom prst="rect">
-            <a:avLst/>
-          </a:prstGeom>
-        </p:spPr>
-      </p:pic>
-      <p:sp>
-        <p:nvSpPr>
-          <p:cNvPr id="6" name="CaixaDeTexto 5">
-            <a:extLst>
-              <a:ext uri="{FF2B5EF4-FFF2-40B4-BE49-F238E27FC236}">
-                <a16:creationId xmlns:a16="http://schemas.microsoft.com/office/drawing/2014/main" id="{44C037D8-3730-5B74-4690-FEF266F0EE22}"/>
-              </a:ext>
-            </a:extLst>
-          </p:cNvPr>
-          <p:cNvSpPr txBox="1"/>
-          <p:nvPr/>
-        </p:nvSpPr>
-        <p:spPr>
-          <a:xfrm>
-            <a:off x="1932387" y="5701044"/>
-            <a:ext cx="8783172" cy="400110"/>
-          </a:xfrm>
-          <a:prstGeom prst="rect">
-            <a:avLst/>
-          </a:prstGeom>
-          <a:noFill/>
-        </p:spPr>
-        <p:txBody>
-          <a:bodyPr rot="0" spcFirstLastPara="0" vertOverflow="overflow" horzOverflow="overflow" vert="horz" wrap="square" lIns="91440" tIns="45720" rIns="91440" bIns="45720" numCol="1" spcCol="0" rtlCol="0" fromWordArt="0" anchor="t" anchorCtr="0" forceAA="0" compatLnSpc="1">
-            <a:prstTxWarp prst="textNoShape">
-              <a:avLst/>
-            </a:prstTxWarp>
-            <a:spAutoFit/>
-          </a:bodyPr>
-          <a:lstStyle/>
-          <a:p>
-            <a:pPr algn="just"/>
-            <a:r>
-              <a:rPr lang="pt-BR" sz="2000" b="1" dirty="0">
-                <a:solidFill>
-                  <a:srgbClr val="FF0000"/>
-                </a:solidFill>
-              </a:rPr>
-              <a:t>Resposta: </a:t>
-            </a:r>
-            <a:r>
-              <a:rPr lang="pt-BR" sz="2000" b="1" i="1" dirty="0">
-                <a:solidFill>
-                  <a:srgbClr val="FF0000"/>
-                </a:solidFill>
-              </a:rPr>
-              <a:t>t'=3s</a:t>
-            </a:r>
-            <a:r>
-              <a:rPr lang="pt-BR" sz="2000" b="1" dirty="0">
-                <a:solidFill>
-                  <a:srgbClr val="FF0000"/>
-                </a:solidFill>
-              </a:rPr>
-              <a:t>, o móvel passa pela origem no instante 3s.</a:t>
-            </a:r>
-          </a:p>
-        </p:txBody>
-      </p:sp>
-    </p:spTree>
-    <p:extLst>
-      <p:ext uri="{BB962C8B-B14F-4D97-AF65-F5344CB8AC3E}">
-        <p14:creationId xmlns:p14="http://schemas.microsoft.com/office/powerpoint/2010/main" val="73761084"/>
-      </p:ext>
-    </p:extLst>
-  </p:cSld>
-  <p:clrMapOvr>
-    <a:masterClrMapping/>
-  </p:clrMapOvr>
-</p:sld>
-</file>
-
-<file path=ppt/slides/slide22.xml><?xml version="1.0" encoding="utf-8"?>
-<p:sld xmlns:a="http://schemas.openxmlformats.org/drawingml/2006/main" xmlns:r="http://schemas.openxmlformats.org/officeDocument/2006/relationships" xmlns:p="http://schemas.openxmlformats.org/presentationml/2006/main">
-  <p:cSld>
-    <p:spTree>
-      <p:nvGrpSpPr>
-        <p:cNvPr id="1" name=""/>
-        <p:cNvGrpSpPr/>
-        <p:nvPr/>
-      </p:nvGrpSpPr>
-      <p:grpSpPr>
-        <a:xfrm>
-          <a:off x="0" y="0"/>
-          <a:ext cx="0" cy="0"/>
-          <a:chOff x="0" y="0"/>
-          <a:chExt cx="0" cy="0"/>
-        </a:xfrm>
-      </p:grpSpPr>
-      <p:sp>
-        <p:nvSpPr>
-          <p:cNvPr id="2" name="Título 1">
-            <a:extLst>
-              <a:ext uri="{FF2B5EF4-FFF2-40B4-BE49-F238E27FC236}">
-                <a16:creationId xmlns:a16="http://schemas.microsoft.com/office/drawing/2014/main" id="{031C0F50-B4CF-8C1B-FC4E-7D82EA7DD454}"/>
-              </a:ext>
-            </a:extLst>
-          </p:cNvPr>
-          <p:cNvSpPr>
-            <a:spLocks noGrp="1"/>
-          </p:cNvSpPr>
-          <p:nvPr>
-            <p:ph type="title"/>
-          </p:nvPr>
-        </p:nvSpPr>
-        <p:spPr>
-          <a:xfrm>
-            <a:off x="3830171" y="-5471"/>
-            <a:ext cx="4531659" cy="899739"/>
-          </a:xfrm>
-        </p:spPr>
-        <p:txBody>
-          <a:bodyPr/>
-          <a:lstStyle/>
-          <a:p>
-            <a:r>
-              <a:rPr lang="pt-BR" sz="3200" b="1" dirty="0">
-                <a:solidFill>
-                  <a:srgbClr val="FF0000"/>
-                </a:solidFill>
-              </a:rPr>
-              <a:t>O gráfico da função será:</a:t>
-            </a:r>
-            <a:endParaRPr lang="pt-BR" dirty="0"/>
-          </a:p>
-        </p:txBody>
-      </p:sp>
-      <p:pic>
-        <p:nvPicPr>
-          <p:cNvPr id="3" name="Imagem 2" descr="Gráfico, Gráfico de linhas&#10;&#10;O conteúdo gerado por IA pode estar incorreto.">
-            <a:extLst>
-              <a:ext uri="{FF2B5EF4-FFF2-40B4-BE49-F238E27FC236}">
-                <a16:creationId xmlns:a16="http://schemas.microsoft.com/office/drawing/2014/main" id="{80948616-0D45-4015-2ECF-059BD507AEEE}"/>
-              </a:ext>
-            </a:extLst>
-          </p:cNvPr>
-          <p:cNvPicPr>
-            <a:picLocks noChangeAspect="1"/>
-          </p:cNvPicPr>
-          <p:nvPr/>
-        </p:nvPicPr>
-        <p:blipFill>
-          <a:blip r:embed="rId2"/>
-          <a:stretch>
-            <a:fillRect/>
-          </a:stretch>
-        </p:blipFill>
-        <p:spPr>
-          <a:xfrm>
-            <a:off x="2019841" y="897062"/>
-            <a:ext cx="8157246" cy="4513479"/>
-          </a:xfrm>
-          <a:prstGeom prst="rect">
-            <a:avLst/>
-          </a:prstGeom>
-        </p:spPr>
-      </p:pic>
-      <p:sp>
-        <p:nvSpPr>
-          <p:cNvPr id="4" name="CaixaDeTexto 3">
-            <a:extLst>
-              <a:ext uri="{FF2B5EF4-FFF2-40B4-BE49-F238E27FC236}">
-                <a16:creationId xmlns:a16="http://schemas.microsoft.com/office/drawing/2014/main" id="{4925E413-0C51-834F-2D09-0B1865FCA40E}"/>
-              </a:ext>
-            </a:extLst>
-          </p:cNvPr>
-          <p:cNvSpPr txBox="1"/>
-          <p:nvPr/>
-        </p:nvSpPr>
-        <p:spPr>
-          <a:xfrm>
-            <a:off x="322413" y="5618025"/>
-            <a:ext cx="11547021" cy="1077218"/>
-          </a:xfrm>
-          <a:prstGeom prst="rect">
-            <a:avLst/>
-          </a:prstGeom>
-          <a:noFill/>
-        </p:spPr>
-        <p:txBody>
-          <a:bodyPr rot="0" spcFirstLastPara="0" vertOverflow="overflow" horzOverflow="overflow" vert="horz" wrap="square" lIns="91440" tIns="45720" rIns="91440" bIns="45720" numCol="1" spcCol="0" rtlCol="0" fromWordArt="0" anchor="t" anchorCtr="0" forceAA="0" compatLnSpc="1">
-            <a:prstTxWarp prst="textNoShape">
-              <a:avLst/>
-            </a:prstTxWarp>
-            <a:spAutoFit/>
-          </a:bodyPr>
-          <a:lstStyle/>
-          <a:p>
-            <a:pPr algn="just"/>
-            <a:r>
-              <a:rPr lang="pt-BR" sz="1600" b="1" dirty="0">
-                <a:solidFill>
-                  <a:schemeClr val="accent2"/>
-                </a:solidFill>
-              </a:rPr>
-              <a:t>Observação: A função horária é uma equação do 2° grau, no entanto, a análise do seu gráfico nem sempre atende aos requisitos de uma questão, na resolução do problema proposto destaca-se que, uma das raízes da equação não faz sentido como resposta, pela problemática proposta as razões matemáticas analisadas foram submetidas a condições físicas relativas.</a:t>
-            </a:r>
-            <a:endParaRPr lang="pt-BR">
-              <a:solidFill>
-                <a:schemeClr val="accent2"/>
-              </a:solidFill>
-            </a:endParaRPr>
-          </a:p>
-        </p:txBody>
-      </p:sp>
-    </p:spTree>
-    <p:extLst>
-      <p:ext uri="{BB962C8B-B14F-4D97-AF65-F5344CB8AC3E}">
-        <p14:creationId xmlns:p14="http://schemas.microsoft.com/office/powerpoint/2010/main" val="4106589359"/>
-      </p:ext>
-    </p:extLst>
-  </p:cSld>
-  <p:clrMapOvr>
-    <a:masterClrMapping/>
-  </p:clrMapOvr>
-</p:sld>
-</file>
-
-<file path=ppt/slides/slide23.xml><?xml version="1.0" encoding="utf-8"?>
-<p:sld xmlns:a="http://schemas.openxmlformats.org/drawingml/2006/main" xmlns:r="http://schemas.openxmlformats.org/officeDocument/2006/relationships" xmlns:p="http://schemas.openxmlformats.org/presentationml/2006/main">
-  <p:cSld>
-    <p:spTree>
-      <p:nvGrpSpPr>
-        <p:cNvPr id="1" name=""/>
-        <p:cNvGrpSpPr/>
-        <p:nvPr/>
-      </p:nvGrpSpPr>
-      <p:grpSpPr>
-        <a:xfrm>
-          <a:off x="0" y="0"/>
-          <a:ext cx="0" cy="0"/>
-          <a:chOff x="0" y="0"/>
-          <a:chExt cx="0" cy="0"/>
-        </a:xfrm>
-      </p:grpSpPr>
-      <p:sp>
-        <p:nvSpPr>
-          <p:cNvPr id="2" name="Título 1">
-            <a:extLst>
-              <a:ext uri="{FF2B5EF4-FFF2-40B4-BE49-F238E27FC236}">
-                <a16:creationId xmlns:a16="http://schemas.microsoft.com/office/drawing/2014/main" id="{4ED26C64-DCF1-0B20-6E28-399DC4EC8450}"/>
-              </a:ext>
-            </a:extLst>
-          </p:cNvPr>
-          <p:cNvSpPr>
-            <a:spLocks noGrp="1"/>
-          </p:cNvSpPr>
-          <p:nvPr>
-            <p:ph type="title"/>
-          </p:nvPr>
-        </p:nvSpPr>
-        <p:spPr/>
-        <p:txBody>
-          <a:bodyPr/>
-          <a:lstStyle/>
-          <a:p>
-            <a:r>
-              <a:rPr lang="pt-BR" dirty="0"/>
-              <a:t>Conclusão</a:t>
-            </a:r>
-          </a:p>
-        </p:txBody>
-      </p:sp>
-      <p:sp>
-        <p:nvSpPr>
-          <p:cNvPr id="3" name="Espaço Reservado para Conteúdo 2">
-            <a:extLst>
-              <a:ext uri="{FF2B5EF4-FFF2-40B4-BE49-F238E27FC236}">
-                <a16:creationId xmlns:a16="http://schemas.microsoft.com/office/drawing/2014/main" id="{B5B67827-D717-9798-7763-C4CBA3B4903C}"/>
-              </a:ext>
-            </a:extLst>
-          </p:cNvPr>
-          <p:cNvSpPr>
-            <a:spLocks noGrp="1"/>
-          </p:cNvSpPr>
-          <p:nvPr>
-            <p:ph idx="1"/>
-          </p:nvPr>
-        </p:nvSpPr>
-        <p:spPr>
-          <a:xfrm>
-            <a:off x="838200" y="2075658"/>
-            <a:ext cx="10515600" cy="3494087"/>
-          </a:xfrm>
-        </p:spPr>
-        <p:txBody>
-          <a:bodyPr vert="horz" lIns="91440" tIns="45720" rIns="91440" bIns="45720" rtlCol="0" anchor="t">
-            <a:normAutofit/>
-          </a:bodyPr>
-          <a:lstStyle/>
-          <a:p>
-            <a:pPr marL="0" indent="0" algn="just">
-              <a:buNone/>
-            </a:pPr>
-            <a:r>
-              <a:rPr lang="pt-BR" dirty="0"/>
-              <a:t> </a:t>
-            </a:r>
-            <a:r>
-              <a:rPr lang="pt-BR" b="1" dirty="0"/>
-              <a:t>As funções de primeiro e segundo grau são ferramentas indispensáveis para os cálculos Físicos, convém observar que a Física procura explicar os eventos em todas as perspectivas, aninhando cálculos e fórmulas muitas vezes de forma complexa, no entanto a Matemática e seus fundamentos são o alicerce de todo o conhecimento, dominar a matemática é dominar a arte do saber.</a:t>
-            </a:r>
-            <a:endParaRPr lang="pt-BR"/>
-          </a:p>
-        </p:txBody>
-      </p:sp>
-    </p:spTree>
-    <p:extLst>
-      <p:ext uri="{BB962C8B-B14F-4D97-AF65-F5344CB8AC3E}">
-        <p14:creationId xmlns:p14="http://schemas.microsoft.com/office/powerpoint/2010/main" val="3558005273"/>
-      </p:ext>
-    </p:extLst>
-  </p:cSld>
-  <p:clrMapOvr>
-    <a:masterClrMapping/>
-  </p:clrMapOvr>
-</p:sld>
-</file>
-
-<file path=ppt/slides/slide24.xml><?xml version="1.0" encoding="utf-8"?>
-<p:sld xmlns:a="http://schemas.openxmlformats.org/drawingml/2006/main" xmlns:r="http://schemas.openxmlformats.org/officeDocument/2006/relationships" xmlns:p="http://schemas.openxmlformats.org/presentationml/2006/main">
-  <p:cSld>
-    <p:spTree>
-      <p:nvGrpSpPr>
-        <p:cNvPr id="1" name=""/>
-        <p:cNvGrpSpPr/>
-        <p:nvPr/>
-      </p:nvGrpSpPr>
-      <p:grpSpPr>
-        <a:xfrm>
-          <a:off x="0" y="0"/>
-          <a:ext cx="0" cy="0"/>
-          <a:chOff x="0" y="0"/>
-          <a:chExt cx="0" cy="0"/>
-        </a:xfrm>
-      </p:grpSpPr>
-      <p:sp>
-        <p:nvSpPr>
-          <p:cNvPr id="2" name="Título 1">
-            <a:extLst>
-              <a:ext uri="{FF2B5EF4-FFF2-40B4-BE49-F238E27FC236}">
-                <a16:creationId xmlns:a16="http://schemas.microsoft.com/office/drawing/2014/main" id="{8D4EF041-2689-DD29-22F1-83FE7A39B02E}"/>
-              </a:ext>
-            </a:extLst>
-          </p:cNvPr>
-          <p:cNvSpPr>
-            <a:spLocks noGrp="1"/>
-          </p:cNvSpPr>
-          <p:nvPr>
-            <p:ph type="title"/>
-          </p:nvPr>
-        </p:nvSpPr>
-        <p:spPr/>
-        <p:txBody>
-          <a:bodyPr/>
-          <a:lstStyle/>
-          <a:p>
-            <a:r>
-              <a:rPr lang="pt-BR" dirty="0"/>
-              <a:t>Referências</a:t>
-            </a:r>
-          </a:p>
-        </p:txBody>
-      </p:sp>
-      <p:sp>
-        <p:nvSpPr>
-          <p:cNvPr id="3" name="Espaço Reservado para Conteúdo 2">
-            <a:extLst>
-              <a:ext uri="{FF2B5EF4-FFF2-40B4-BE49-F238E27FC236}">
-                <a16:creationId xmlns:a16="http://schemas.microsoft.com/office/drawing/2014/main" id="{4306702C-EEB1-E495-8400-3DD2097D7CA0}"/>
-              </a:ext>
-            </a:extLst>
-          </p:cNvPr>
-          <p:cNvSpPr>
-            <a:spLocks noGrp="1"/>
-          </p:cNvSpPr>
-          <p:nvPr>
-            <p:ph idx="1"/>
-          </p:nvPr>
-        </p:nvSpPr>
-        <p:spPr/>
-        <p:txBody>
-          <a:bodyPr vert="horz" lIns="91440" tIns="45720" rIns="91440" bIns="45720" rtlCol="0" anchor="t">
-            <a:normAutofit/>
-          </a:bodyPr>
-          <a:lstStyle/>
-          <a:p>
-            <a:pPr algn="just"/>
-            <a:r>
-              <a:rPr lang="pt-BR" sz="2000" b="1" dirty="0"/>
-              <a:t>ChatGPT,</a:t>
-            </a:r>
-          </a:p>
-          <a:p>
-            <a:pPr algn="just"/>
-            <a:r>
-              <a:rPr lang="pt-BR" sz="2000" b="1" dirty="0"/>
-              <a:t>Microsoft </a:t>
-            </a:r>
-            <a:r>
-              <a:rPr lang="pt-BR" sz="2000" b="1" err="1"/>
-              <a:t>copilot</a:t>
-            </a:r>
-            <a:r>
-              <a:rPr lang="pt-BR" sz="2000" b="1" dirty="0"/>
-              <a:t>,</a:t>
-            </a:r>
-          </a:p>
-          <a:p>
-            <a:pPr algn="just"/>
-            <a:r>
-              <a:rPr lang="pt-BR" sz="2000" b="1" dirty="0"/>
-              <a:t>Google AI,</a:t>
-            </a:r>
-          </a:p>
-          <a:p>
-            <a:pPr algn="just"/>
-            <a:endParaRPr lang="pt-BR" sz="2000" b="1" dirty="0"/>
-          </a:p>
-          <a:p>
-            <a:pPr algn="just"/>
-            <a:r>
-              <a:rPr lang="pt-BR" sz="2000" b="1" dirty="0"/>
-              <a:t>Os fundamentos da Física, Ramalho, Ivan, Nicolau, Toledo. Volume um, mecânica, páginas 44,45. (exercícios resolvidos, R.14).</a:t>
-            </a:r>
-          </a:p>
-          <a:p>
-            <a:endParaRPr lang="pt-BR" dirty="0"/>
-          </a:p>
-        </p:txBody>
-      </p:sp>
-    </p:spTree>
-    <p:extLst>
-      <p:ext uri="{BB962C8B-B14F-4D97-AF65-F5344CB8AC3E}">
-        <p14:creationId xmlns:p14="http://schemas.microsoft.com/office/powerpoint/2010/main" val="1113526587"/>
-      </p:ext>
-    </p:extLst>
-  </p:cSld>
-  <p:clrMapOvr>
-    <a:masterClrMapping/>
-  </p:clrMapOvr>
-</p:sld>
-</file>
-
-<file path=ppt/slides/slide25.xml><?xml version="1.0" encoding="utf-8"?>
-<p:sld xmlns:a="http://schemas.openxmlformats.org/drawingml/2006/main" xmlns:r="http://schemas.openxmlformats.org/officeDocument/2006/relationships" xmlns:p="http://schemas.openxmlformats.org/presentationml/2006/main">
-  <p:cSld>
-    <p:spTree>
-      <p:nvGrpSpPr>
-        <p:cNvPr id="1" name=""/>
-        <p:cNvGrpSpPr/>
-        <p:nvPr/>
-      </p:nvGrpSpPr>
-      <p:grpSpPr>
-        <a:xfrm>
-          <a:off x="0" y="0"/>
-          <a:ext cx="0" cy="0"/>
-          <a:chOff x="0" y="0"/>
-          <a:chExt cx="0" cy="0"/>
-        </a:xfrm>
-      </p:grpSpPr>
-      <p:sp>
-        <p:nvSpPr>
-          <p:cNvPr id="2" name="Título 1">
-            <a:extLst>
-              <a:ext uri="{FF2B5EF4-FFF2-40B4-BE49-F238E27FC236}">
-                <a16:creationId xmlns:a16="http://schemas.microsoft.com/office/drawing/2014/main" id="{E8E54657-1E17-489E-F829-EEDA04AE0552}"/>
-              </a:ext>
-            </a:extLst>
-          </p:cNvPr>
-          <p:cNvSpPr>
-            <a:spLocks noGrp="1"/>
-          </p:cNvSpPr>
-          <p:nvPr>
-            <p:ph type="title"/>
-          </p:nvPr>
-        </p:nvSpPr>
-        <p:spPr>
-          <a:xfrm>
-            <a:off x="5088731" y="365125"/>
-            <a:ext cx="2014538" cy="873126"/>
-          </a:xfrm>
-        </p:spPr>
-        <p:txBody>
-          <a:bodyPr>
-            <a:normAutofit/>
-          </a:bodyPr>
-          <a:lstStyle/>
-          <a:p>
-            <a:r>
-              <a:rPr lang="pt-BR" sz="2000" b="1" dirty="0"/>
-              <a:t>Interatividade</a:t>
-            </a:r>
-          </a:p>
-        </p:txBody>
-      </p:sp>
-      <p:pic>
-        <p:nvPicPr>
-          <p:cNvPr id="4" name="Imagem 3" descr="Código QR&#10;&#10;O conteúdo gerado por IA pode estar incorreto.">
-            <a:extLst>
-              <a:ext uri="{FF2B5EF4-FFF2-40B4-BE49-F238E27FC236}">
-                <a16:creationId xmlns:a16="http://schemas.microsoft.com/office/drawing/2014/main" id="{0EE23786-9A3E-0BF6-266C-771738BA0B0F}"/>
-              </a:ext>
-            </a:extLst>
-          </p:cNvPr>
-          <p:cNvPicPr>
-            <a:picLocks noChangeAspect="1"/>
-          </p:cNvPicPr>
-          <p:nvPr/>
-        </p:nvPicPr>
-        <p:blipFill>
-          <a:blip r:embed="rId2"/>
-          <a:stretch>
-            <a:fillRect/>
-          </a:stretch>
-        </p:blipFill>
-        <p:spPr>
-          <a:xfrm>
-            <a:off x="3952875" y="1285875"/>
-            <a:ext cx="4286250" cy="4286250"/>
-          </a:xfrm>
-          <a:prstGeom prst="rect">
-            <a:avLst/>
-          </a:prstGeom>
-        </p:spPr>
-      </p:pic>
-    </p:spTree>
-    <p:extLst>
-      <p:ext uri="{BB962C8B-B14F-4D97-AF65-F5344CB8AC3E}">
-        <p14:creationId xmlns:p14="http://schemas.microsoft.com/office/powerpoint/2010/main" val="1372514761"/>
-      </p:ext>
-    </p:extLst>
-  </p:cSld>
-  <p:clrMapOvr>
-    <a:masterClrMapping/>
-  </p:clrMapOvr>
-</p:sld>
-</file>
-
 <file path=ppt/slides/slide3.xml><?xml version="1.0" encoding="utf-8"?>
 <p:sld xmlns:a="http://schemas.openxmlformats.org/drawingml/2006/main" xmlns:r="http://schemas.openxmlformats.org/officeDocument/2006/relationships" xmlns:p="http://schemas.openxmlformats.org/presentationml/2006/main">
   <p:cSld>
     <p:bg>
       <p:bgPr>
         <a:solidFill>
-          <a:schemeClr val="bg1"/>
+          <a:schemeClr val="tx1"/>
         </a:solidFill>
         <a:effectLst/>
       </p:bgPr>
@@ -5762,12 +3811,43 @@
           <a:chExt cx="0" cy="0"/>
         </a:xfrm>
       </p:grpSpPr>
-      <p:sp>
-        <p:nvSpPr>
-          <p:cNvPr id="25" name="Rectangle 24">
+      <p:pic>
+        <p:nvPicPr>
+          <p:cNvPr id="4" name="Picture 3" descr="Fórmulas escritas em um quadro-negro">
             <a:extLst>
               <a:ext uri="{FF2B5EF4-FFF2-40B4-BE49-F238E27FC236}">
-                <a16:creationId xmlns:a16="http://schemas.microsoft.com/office/drawing/2014/main" id="{8A95209C-5275-4E15-8EA7-7F42980ABF2D}"/>
+                <a16:creationId xmlns:a16="http://schemas.microsoft.com/office/drawing/2014/main" id="{F0511FFB-007C-193F-6BC1-D9BDBAE1DF09}"/>
+              </a:ext>
+            </a:extLst>
+          </p:cNvPr>
+          <p:cNvPicPr>
+            <a:picLocks noChangeAspect="1"/>
+          </p:cNvPicPr>
+          <p:nvPr/>
+        </p:nvPicPr>
+        <p:blipFill>
+          <a:blip r:embed="rId2"/>
+          <a:srcRect t="15730"/>
+          <a:stretch>
+            <a:fillRect/>
+          </a:stretch>
+        </p:blipFill>
+        <p:spPr>
+          <a:xfrm>
+            <a:off x="20" y="10"/>
+            <a:ext cx="12191980" cy="6857990"/>
+          </a:xfrm>
+          <a:prstGeom prst="rect">
+            <a:avLst/>
+          </a:prstGeom>
+        </p:spPr>
+      </p:pic>
+      <p:sp>
+        <p:nvSpPr>
+          <p:cNvPr id="34" name="Rectangle 33">
+            <a:extLst>
+              <a:ext uri="{FF2B5EF4-FFF2-40B4-BE49-F238E27FC236}">
+                <a16:creationId xmlns:a16="http://schemas.microsoft.com/office/drawing/2014/main" id="{B4916930-E76E-4100-9DCF-4981566A372A}"/>
               </a:ext>
               <a:ext uri="{C183D7F6-B498-43B3-948B-1728B52AA6E4}">
                 <adec:decorative xmlns:adec="http://schemas.microsoft.com/office/drawing/2017/decorative" val="1"/>
@@ -5787,17 +3867,21 @@
         </p:nvSpPr>
         <p:spPr>
           <a:xfrm>
-            <a:off x="0" y="0"/>
-            <a:ext cx="12188952" cy="6858000"/>
+            <a:off x="1857375" y="1885950"/>
+            <a:ext cx="8505825" cy="3152775"/>
           </a:xfrm>
           <a:prstGeom prst="rect">
             <a:avLst/>
           </a:prstGeom>
           <a:solidFill>
-            <a:schemeClr val="tx1"/>
+            <a:schemeClr val="bg1">
+              <a:alpha val="75000"/>
+            </a:schemeClr>
           </a:solidFill>
-          <a:ln>
-            <a:noFill/>
+          <a:ln w="63500" cmpd="dbl">
+            <a:solidFill>
+              <a:schemeClr val="bg1"/>
+            </a:solidFill>
           </a:ln>
         </p:spPr>
         <p:style>
@@ -5825,39 +3909,6 @@
           </a:p>
         </p:txBody>
       </p:sp>
-      <p:pic>
-        <p:nvPicPr>
-          <p:cNvPr id="4" name="Picture 3" descr="Fórmulas escritas em um quadro-negro">
-            <a:extLst>
-              <a:ext uri="{FF2B5EF4-FFF2-40B4-BE49-F238E27FC236}">
-                <a16:creationId xmlns:a16="http://schemas.microsoft.com/office/drawing/2014/main" id="{F0511FFB-007C-193F-6BC1-D9BDBAE1DF09}"/>
-              </a:ext>
-            </a:extLst>
-          </p:cNvPr>
-          <p:cNvPicPr>
-            <a:picLocks noChangeAspect="1"/>
-          </p:cNvPicPr>
-          <p:nvPr/>
-        </p:nvPicPr>
-        <p:blipFill>
-          <a:blip r:embed="rId2">
-            <a:alphaModFix amt="50000"/>
-          </a:blip>
-          <a:srcRect t="15709" r="-1" b="-1"/>
-          <a:stretch>
-            <a:fillRect/>
-          </a:stretch>
-        </p:blipFill>
-        <p:spPr>
-          <a:xfrm>
-            <a:off x="20" y="11916"/>
-            <a:ext cx="12188931" cy="6857990"/>
-          </a:xfrm>
-          <a:prstGeom prst="rect">
-            <a:avLst/>
-          </a:prstGeom>
-        </p:spPr>
-      </p:pic>
       <p:sp>
         <p:nvSpPr>
           <p:cNvPr id="2" name="Título 1">
@@ -5876,1079 +3927,31 @@
         </p:nvSpPr>
         <p:spPr>
           <a:xfrm>
-            <a:off x="1050798" y="1357546"/>
-            <a:ext cx="9144000" cy="3063240"/>
+            <a:off x="2276475" y="2247900"/>
+            <a:ext cx="7581900" cy="2514600"/>
           </a:xfrm>
         </p:spPr>
         <p:txBody>
-          <a:bodyPr vert="horz" lIns="91440" tIns="45720" rIns="91440" bIns="45720" rtlCol="0" anchor="b">
+          <a:bodyPr vert="horz" lIns="91440" tIns="45720" rIns="91440" bIns="45720" rtlCol="0" anchor="ctr">
             <a:normAutofit/>
           </a:bodyPr>
           <a:lstStyle/>
           <a:p>
             <a:pPr algn="ctr"/>
             <a:r>
-              <a:rPr lang="en-US" sz="5100" b="1" dirty="0" err="1">
+              <a:rPr lang="en-US" sz="5100" b="1">
                 <a:solidFill>
-                  <a:schemeClr val="bg1"/>
+                  <a:schemeClr val="tx1">
+                    <a:lumMod val="75000"/>
+                    <a:lumOff val="25000"/>
+                  </a:schemeClr>
                 </a:solidFill>
+                <a:highlight>
+                  <a:srgbClr val="FFFFFF"/>
+                </a:highlight>
               </a:rPr>
-              <a:t>Problema</a:t>
-            </a:r>
-            <a:r>
-              <a:rPr lang="en-US" sz="5100" b="1" dirty="0">
-                <a:solidFill>
-                  <a:schemeClr val="bg1"/>
-                </a:solidFill>
-              </a:rPr>
-              <a:t> de </a:t>
-            </a:r>
-            <a:r>
-              <a:rPr lang="en-US" sz="5100" b="1" dirty="0" err="1">
-                <a:solidFill>
-                  <a:schemeClr val="bg1"/>
-                </a:solidFill>
-              </a:rPr>
-              <a:t>Matemática</a:t>
-            </a:r>
-            <a:r>
-              <a:rPr lang="en-US" sz="5100" b="1" dirty="0">
-                <a:solidFill>
-                  <a:schemeClr val="bg1"/>
-                </a:solidFill>
-              </a:rPr>
-              <a:t> </a:t>
-            </a:r>
-            <a:br>
-              <a:rPr lang="en-US" sz="5100" b="1" dirty="0"/>
-            </a:br>
-            <a:r>
-              <a:rPr lang="en-US" sz="5100" b="1" dirty="0" err="1">
-                <a:solidFill>
-                  <a:schemeClr val="bg1"/>
-                </a:solidFill>
-              </a:rPr>
-              <a:t>contextualizado</a:t>
-            </a:r>
-            <a:r>
-              <a:rPr lang="en-US" sz="5100" b="1" dirty="0">
-                <a:solidFill>
-                  <a:schemeClr val="bg1"/>
-                </a:solidFill>
-              </a:rPr>
-              <a:t> </a:t>
-            </a:r>
-            <a:r>
-              <a:rPr lang="en-US" sz="5100" b="1" dirty="0" err="1">
-                <a:solidFill>
-                  <a:schemeClr val="bg1"/>
-                </a:solidFill>
-              </a:rPr>
-              <a:t>na</a:t>
-            </a:r>
-            <a:r>
-              <a:rPr lang="en-US" sz="5100" b="1" dirty="0">
-                <a:solidFill>
-                  <a:schemeClr val="bg1"/>
-                </a:solidFill>
-              </a:rPr>
-              <a:t>  </a:t>
-            </a:r>
-            <a:r>
-              <a:rPr lang="en-US" sz="5100" b="1" dirty="0" err="1">
-                <a:solidFill>
-                  <a:schemeClr val="bg1"/>
-                </a:solidFill>
-              </a:rPr>
-              <a:t>Física</a:t>
-            </a:r>
-            <a:br>
-              <a:rPr lang="en-US" sz="5100" b="1" dirty="0"/>
-            </a:br>
-            <a:r>
-              <a:rPr lang="en-US" sz="5100" b="1" dirty="0">
-                <a:solidFill>
-                  <a:schemeClr val="bg1"/>
-                </a:solidFill>
-              </a:rPr>
-              <a:t>(</a:t>
-            </a:r>
-            <a:r>
-              <a:rPr lang="en-US" sz="5100" b="1" dirty="0" err="1">
-                <a:solidFill>
-                  <a:schemeClr val="bg1"/>
-                </a:solidFill>
-              </a:rPr>
-              <a:t>Equações</a:t>
-            </a:r>
-            <a:r>
-              <a:rPr lang="en-US" sz="5100" b="1" dirty="0">
-                <a:solidFill>
-                  <a:schemeClr val="bg1"/>
-                </a:solidFill>
-              </a:rPr>
-              <a:t> de 1° e 2° </a:t>
-            </a:r>
-            <a:r>
-              <a:rPr lang="en-US" sz="5100" b="1" dirty="0" err="1">
-                <a:solidFill>
-                  <a:schemeClr val="bg1"/>
-                </a:solidFill>
-              </a:rPr>
-              <a:t>grau</a:t>
-            </a:r>
-            <a:r>
-              <a:rPr lang="en-US" sz="5100" b="1" dirty="0">
-                <a:solidFill>
-                  <a:schemeClr val="bg1"/>
-                </a:solidFill>
-              </a:rPr>
-              <a:t>)</a:t>
-            </a:r>
-          </a:p>
-        </p:txBody>
-      </p:sp>
-      <p:sp>
-        <p:nvSpPr>
-          <p:cNvPr id="27" name="sketchy box">
-            <a:extLst>
-              <a:ext uri="{FF2B5EF4-FFF2-40B4-BE49-F238E27FC236}">
-                <a16:creationId xmlns:a16="http://schemas.microsoft.com/office/drawing/2014/main" id="{4F2ED431-E304-4FF0-9F4E-032783C9D612}"/>
-              </a:ext>
-              <a:ext uri="{C183D7F6-B498-43B3-948B-1728B52AA6E4}">
-                <adec:decorative xmlns:adec="http://schemas.microsoft.com/office/drawing/2017/decorative" val="1"/>
-              </a:ext>
-            </a:extLst>
-          </p:cNvPr>
-          <p:cNvSpPr>
-            <a:spLocks noGrp="1" noRot="1" noChangeAspect="1" noMove="1" noResize="1" noEditPoints="1" noAdjustHandles="1" noChangeArrowheads="1" noChangeShapeType="1" noTextEdit="1"/>
-          </p:cNvSpPr>
-          <p:nvPr>
-            <p:extLst>
-              <p:ext uri="{386F3935-93C4-4BCD-93E2-E3B085C9AB24}">
-                <p16:designElem xmlns:p16="http://schemas.microsoft.com/office/powerpoint/2015/main" val="1"/>
-              </p:ext>
-            </p:extLst>
-          </p:nvPr>
-        </p:nvSpPr>
-        <p:spPr>
-          <a:xfrm flipV="1">
-            <a:off x="838200" y="720953"/>
-            <a:ext cx="10515600" cy="5416094"/>
-          </a:xfrm>
-          <a:custGeom>
-            <a:avLst/>
-            <a:gdLst>
-              <a:gd name="csX0" fmla="*/ 0 w 10515600"/>
-              <a:gd name="csY0" fmla="*/ 0 h 5416094"/>
-              <a:gd name="csX1" fmla="*/ 552069 w 10515600"/>
-              <a:gd name="csY1" fmla="*/ 0 h 5416094"/>
-              <a:gd name="csX2" fmla="*/ 893826 w 10515600"/>
-              <a:gd name="csY2" fmla="*/ 0 h 5416094"/>
-              <a:gd name="csX3" fmla="*/ 1761363 w 10515600"/>
-              <a:gd name="csY3" fmla="*/ 0 h 5416094"/>
-              <a:gd name="csX4" fmla="*/ 2313432 w 10515600"/>
-              <a:gd name="csY4" fmla="*/ 0 h 5416094"/>
-              <a:gd name="csX5" fmla="*/ 2865501 w 10515600"/>
-              <a:gd name="csY5" fmla="*/ 0 h 5416094"/>
-              <a:gd name="csX6" fmla="*/ 3733038 w 10515600"/>
-              <a:gd name="csY6" fmla="*/ 0 h 5416094"/>
-              <a:gd name="csX7" fmla="*/ 4179951 w 10515600"/>
-              <a:gd name="csY7" fmla="*/ 0 h 5416094"/>
-              <a:gd name="csX8" fmla="*/ 5047488 w 10515600"/>
-              <a:gd name="csY8" fmla="*/ 0 h 5416094"/>
-              <a:gd name="csX9" fmla="*/ 5915025 w 10515600"/>
-              <a:gd name="csY9" fmla="*/ 0 h 5416094"/>
-              <a:gd name="csX10" fmla="*/ 6572250 w 10515600"/>
-              <a:gd name="csY10" fmla="*/ 0 h 5416094"/>
-              <a:gd name="csX11" fmla="*/ 7439787 w 10515600"/>
-              <a:gd name="csY11" fmla="*/ 0 h 5416094"/>
-              <a:gd name="csX12" fmla="*/ 7991856 w 10515600"/>
-              <a:gd name="csY12" fmla="*/ 0 h 5416094"/>
-              <a:gd name="csX13" fmla="*/ 8543925 w 10515600"/>
-              <a:gd name="csY13" fmla="*/ 0 h 5416094"/>
-              <a:gd name="csX14" fmla="*/ 9306306 w 10515600"/>
-              <a:gd name="csY14" fmla="*/ 0 h 5416094"/>
-              <a:gd name="csX15" fmla="*/ 9858375 w 10515600"/>
-              <a:gd name="csY15" fmla="*/ 0 h 5416094"/>
-              <a:gd name="csX16" fmla="*/ 10515600 w 10515600"/>
-              <a:gd name="csY16" fmla="*/ 0 h 5416094"/>
-              <a:gd name="csX17" fmla="*/ 10515600 w 10515600"/>
-              <a:gd name="csY17" fmla="*/ 785334 h 5416094"/>
-              <a:gd name="csX18" fmla="*/ 10515600 w 10515600"/>
-              <a:gd name="csY18" fmla="*/ 1516506 h 5416094"/>
-              <a:gd name="csX19" fmla="*/ 10515600 w 10515600"/>
-              <a:gd name="csY19" fmla="*/ 2247679 h 5416094"/>
-              <a:gd name="csX20" fmla="*/ 10515600 w 10515600"/>
-              <a:gd name="csY20" fmla="*/ 2762208 h 5416094"/>
-              <a:gd name="csX21" fmla="*/ 10515600 w 10515600"/>
-              <a:gd name="csY21" fmla="*/ 3330898 h 5416094"/>
-              <a:gd name="csX22" fmla="*/ 10515600 w 10515600"/>
-              <a:gd name="csY22" fmla="*/ 4062071 h 5416094"/>
-              <a:gd name="csX23" fmla="*/ 10515600 w 10515600"/>
-              <a:gd name="csY23" fmla="*/ 4684921 h 5416094"/>
-              <a:gd name="csX24" fmla="*/ 10515600 w 10515600"/>
-              <a:gd name="csY24" fmla="*/ 5416094 h 5416094"/>
-              <a:gd name="csX25" fmla="*/ 9753219 w 10515600"/>
-              <a:gd name="csY25" fmla="*/ 5416094 h 5416094"/>
-              <a:gd name="csX26" fmla="*/ 9411462 w 10515600"/>
-              <a:gd name="csY26" fmla="*/ 5416094 h 5416094"/>
-              <a:gd name="csX27" fmla="*/ 8754237 w 10515600"/>
-              <a:gd name="csY27" fmla="*/ 5416094 h 5416094"/>
-              <a:gd name="csX28" fmla="*/ 8307324 w 10515600"/>
-              <a:gd name="csY28" fmla="*/ 5416094 h 5416094"/>
-              <a:gd name="csX29" fmla="*/ 7544943 w 10515600"/>
-              <a:gd name="csY29" fmla="*/ 5416094 h 5416094"/>
-              <a:gd name="csX30" fmla="*/ 7098030 w 10515600"/>
-              <a:gd name="csY30" fmla="*/ 5416094 h 5416094"/>
-              <a:gd name="csX31" fmla="*/ 6335649 w 10515600"/>
-              <a:gd name="csY31" fmla="*/ 5416094 h 5416094"/>
-              <a:gd name="csX32" fmla="*/ 5993892 w 10515600"/>
-              <a:gd name="csY32" fmla="*/ 5416094 h 5416094"/>
-              <a:gd name="csX33" fmla="*/ 5231511 w 10515600"/>
-              <a:gd name="csY33" fmla="*/ 5416094 h 5416094"/>
-              <a:gd name="csX34" fmla="*/ 4784598 w 10515600"/>
-              <a:gd name="csY34" fmla="*/ 5416094 h 5416094"/>
-              <a:gd name="csX35" fmla="*/ 4442841 w 10515600"/>
-              <a:gd name="csY35" fmla="*/ 5416094 h 5416094"/>
-              <a:gd name="csX36" fmla="*/ 3995928 w 10515600"/>
-              <a:gd name="csY36" fmla="*/ 5416094 h 5416094"/>
-              <a:gd name="csX37" fmla="*/ 3233547 w 10515600"/>
-              <a:gd name="csY37" fmla="*/ 5416094 h 5416094"/>
-              <a:gd name="csX38" fmla="*/ 2786634 w 10515600"/>
-              <a:gd name="csY38" fmla="*/ 5416094 h 5416094"/>
-              <a:gd name="csX39" fmla="*/ 2444877 w 10515600"/>
-              <a:gd name="csY39" fmla="*/ 5416094 h 5416094"/>
-              <a:gd name="csX40" fmla="*/ 1997964 w 10515600"/>
-              <a:gd name="csY40" fmla="*/ 5416094 h 5416094"/>
-              <a:gd name="csX41" fmla="*/ 1445895 w 10515600"/>
-              <a:gd name="csY41" fmla="*/ 5416094 h 5416094"/>
-              <a:gd name="csX42" fmla="*/ 788670 w 10515600"/>
-              <a:gd name="csY42" fmla="*/ 5416094 h 5416094"/>
-              <a:gd name="csX43" fmla="*/ 0 w 10515600"/>
-              <a:gd name="csY43" fmla="*/ 5416094 h 5416094"/>
-              <a:gd name="csX44" fmla="*/ 0 w 10515600"/>
-              <a:gd name="csY44" fmla="*/ 4630760 h 5416094"/>
-              <a:gd name="csX45" fmla="*/ 0 w 10515600"/>
-              <a:gd name="csY45" fmla="*/ 3953749 h 5416094"/>
-              <a:gd name="csX46" fmla="*/ 0 w 10515600"/>
-              <a:gd name="csY46" fmla="*/ 3276737 h 5416094"/>
-              <a:gd name="csX47" fmla="*/ 0 w 10515600"/>
-              <a:gd name="csY47" fmla="*/ 2599725 h 5416094"/>
-              <a:gd name="csX48" fmla="*/ 0 w 10515600"/>
-              <a:gd name="csY48" fmla="*/ 1922713 h 5416094"/>
-              <a:gd name="csX49" fmla="*/ 0 w 10515600"/>
-              <a:gd name="csY49" fmla="*/ 1299863 h 5416094"/>
-              <a:gd name="csX50" fmla="*/ 0 w 10515600"/>
-              <a:gd name="csY50" fmla="*/ 0 h 5416094"/>
-            </a:gdLst>
-            <a:ahLst/>
-            <a:cxnLst>
-              <a:cxn ang="0">
-                <a:pos x="csX0" y="csY0"/>
-              </a:cxn>
-              <a:cxn ang="0">
-                <a:pos x="csX1" y="csY1"/>
-              </a:cxn>
-              <a:cxn ang="0">
-                <a:pos x="csX2" y="csY2"/>
-              </a:cxn>
-              <a:cxn ang="0">
-                <a:pos x="csX3" y="csY3"/>
-              </a:cxn>
-              <a:cxn ang="0">
-                <a:pos x="csX4" y="csY4"/>
-              </a:cxn>
-              <a:cxn ang="0">
-                <a:pos x="csX5" y="csY5"/>
-              </a:cxn>
-              <a:cxn ang="0">
-                <a:pos x="csX6" y="csY6"/>
-              </a:cxn>
-              <a:cxn ang="0">
-                <a:pos x="csX7" y="csY7"/>
-              </a:cxn>
-              <a:cxn ang="0">
-                <a:pos x="csX8" y="csY8"/>
-              </a:cxn>
-              <a:cxn ang="0">
-                <a:pos x="csX9" y="csY9"/>
-              </a:cxn>
-              <a:cxn ang="0">
-                <a:pos x="csX10" y="csY10"/>
-              </a:cxn>
-              <a:cxn ang="0">
-                <a:pos x="csX11" y="csY11"/>
-              </a:cxn>
-              <a:cxn ang="0">
-                <a:pos x="csX12" y="csY12"/>
-              </a:cxn>
-              <a:cxn ang="0">
-                <a:pos x="csX13" y="csY13"/>
-              </a:cxn>
-              <a:cxn ang="0">
-                <a:pos x="csX14" y="csY14"/>
-              </a:cxn>
-              <a:cxn ang="0">
-                <a:pos x="csX15" y="csY15"/>
-              </a:cxn>
-              <a:cxn ang="0">
-                <a:pos x="csX16" y="csY16"/>
-              </a:cxn>
-              <a:cxn ang="0">
-                <a:pos x="csX17" y="csY17"/>
-              </a:cxn>
-              <a:cxn ang="0">
-                <a:pos x="csX18" y="csY18"/>
-              </a:cxn>
-              <a:cxn ang="0">
-                <a:pos x="csX19" y="csY19"/>
-              </a:cxn>
-              <a:cxn ang="0">
-                <a:pos x="csX20" y="csY20"/>
-              </a:cxn>
-              <a:cxn ang="0">
-                <a:pos x="csX21" y="csY21"/>
-              </a:cxn>
-              <a:cxn ang="0">
-                <a:pos x="csX22" y="csY22"/>
-              </a:cxn>
-              <a:cxn ang="0">
-                <a:pos x="csX23" y="csY23"/>
-              </a:cxn>
-              <a:cxn ang="0">
-                <a:pos x="csX24" y="csY24"/>
-              </a:cxn>
-              <a:cxn ang="0">
-                <a:pos x="csX25" y="csY25"/>
-              </a:cxn>
-              <a:cxn ang="0">
-                <a:pos x="csX26" y="csY26"/>
-              </a:cxn>
-              <a:cxn ang="0">
-                <a:pos x="csX27" y="csY27"/>
-              </a:cxn>
-              <a:cxn ang="0">
-                <a:pos x="csX28" y="csY28"/>
-              </a:cxn>
-              <a:cxn ang="0">
-                <a:pos x="csX29" y="csY29"/>
-              </a:cxn>
-              <a:cxn ang="0">
-                <a:pos x="csX30" y="csY30"/>
-              </a:cxn>
-              <a:cxn ang="0">
-                <a:pos x="csX31" y="csY31"/>
-              </a:cxn>
-              <a:cxn ang="0">
-                <a:pos x="csX32" y="csY32"/>
-              </a:cxn>
-              <a:cxn ang="0">
-                <a:pos x="csX33" y="csY33"/>
-              </a:cxn>
-              <a:cxn ang="0">
-                <a:pos x="csX34" y="csY34"/>
-              </a:cxn>
-              <a:cxn ang="0">
-                <a:pos x="csX35" y="csY35"/>
-              </a:cxn>
-              <a:cxn ang="0">
-                <a:pos x="csX36" y="csY36"/>
-              </a:cxn>
-              <a:cxn ang="0">
-                <a:pos x="csX37" y="csY37"/>
-              </a:cxn>
-              <a:cxn ang="0">
-                <a:pos x="csX38" y="csY38"/>
-              </a:cxn>
-              <a:cxn ang="0">
-                <a:pos x="csX39" y="csY39"/>
-              </a:cxn>
-              <a:cxn ang="0">
-                <a:pos x="csX40" y="csY40"/>
-              </a:cxn>
-              <a:cxn ang="0">
-                <a:pos x="csX41" y="csY41"/>
-              </a:cxn>
-              <a:cxn ang="0">
-                <a:pos x="csX42" y="csY42"/>
-              </a:cxn>
-              <a:cxn ang="0">
-                <a:pos x="csX43" y="csY43"/>
-              </a:cxn>
-              <a:cxn ang="0">
-                <a:pos x="csX44" y="csY44"/>
-              </a:cxn>
-              <a:cxn ang="0">
-                <a:pos x="csX45" y="csY45"/>
-              </a:cxn>
-              <a:cxn ang="0">
-                <a:pos x="csX46" y="csY46"/>
-              </a:cxn>
-              <a:cxn ang="0">
-                <a:pos x="csX47" y="csY47"/>
-              </a:cxn>
-              <a:cxn ang="0">
-                <a:pos x="csX48" y="csY48"/>
-              </a:cxn>
-              <a:cxn ang="0">
-                <a:pos x="csX49" y="csY49"/>
-              </a:cxn>
-              <a:cxn ang="0">
-                <a:pos x="csX50" y="csY50"/>
-              </a:cxn>
-            </a:cxnLst>
-            <a:rect l="l" t="t" r="r" b="b"/>
-            <a:pathLst>
-              <a:path w="10515600" h="5416094" extrusionOk="0">
-                <a:moveTo>
-                  <a:pt x="0" y="0"/>
-                </a:moveTo>
-                <a:cubicBezTo>
-                  <a:pt x="230793" y="14353"/>
-                  <a:pt x="332416" y="21392"/>
-                  <a:pt x="552069" y="0"/>
-                </a:cubicBezTo>
-                <a:cubicBezTo>
-                  <a:pt x="771722" y="-21392"/>
-                  <a:pt x="761737" y="-14337"/>
-                  <a:pt x="893826" y="0"/>
-                </a:cubicBezTo>
-                <a:cubicBezTo>
-                  <a:pt x="1025915" y="14337"/>
-                  <a:pt x="1441584" y="-15498"/>
-                  <a:pt x="1761363" y="0"/>
-                </a:cubicBezTo>
-                <a:cubicBezTo>
-                  <a:pt x="2081142" y="15498"/>
-                  <a:pt x="2111503" y="7278"/>
-                  <a:pt x="2313432" y="0"/>
-                </a:cubicBezTo>
-                <a:cubicBezTo>
-                  <a:pt x="2515361" y="-7278"/>
-                  <a:pt x="2743584" y="-17845"/>
-                  <a:pt x="2865501" y="0"/>
-                </a:cubicBezTo>
-                <a:cubicBezTo>
-                  <a:pt x="2987418" y="17845"/>
-                  <a:pt x="3345183" y="8208"/>
-                  <a:pt x="3733038" y="0"/>
-                </a:cubicBezTo>
-                <a:cubicBezTo>
-                  <a:pt x="4120893" y="-8208"/>
-                  <a:pt x="4009066" y="-3159"/>
-                  <a:pt x="4179951" y="0"/>
-                </a:cubicBezTo>
-                <a:cubicBezTo>
-                  <a:pt x="4350836" y="3159"/>
-                  <a:pt x="4735020" y="17517"/>
-                  <a:pt x="5047488" y="0"/>
-                </a:cubicBezTo>
-                <a:cubicBezTo>
-                  <a:pt x="5359956" y="-17517"/>
-                  <a:pt x="5662148" y="-17777"/>
-                  <a:pt x="5915025" y="0"/>
-                </a:cubicBezTo>
-                <a:cubicBezTo>
-                  <a:pt x="6167902" y="17777"/>
-                  <a:pt x="6308797" y="30350"/>
-                  <a:pt x="6572250" y="0"/>
-                </a:cubicBezTo>
-                <a:cubicBezTo>
-                  <a:pt x="6835703" y="-30350"/>
-                  <a:pt x="7107419" y="-9627"/>
-                  <a:pt x="7439787" y="0"/>
-                </a:cubicBezTo>
-                <a:cubicBezTo>
-                  <a:pt x="7772155" y="9627"/>
-                  <a:pt x="7844034" y="-9098"/>
-                  <a:pt x="7991856" y="0"/>
-                </a:cubicBezTo>
-                <a:cubicBezTo>
-                  <a:pt x="8139678" y="9098"/>
-                  <a:pt x="8289889" y="-20239"/>
-                  <a:pt x="8543925" y="0"/>
-                </a:cubicBezTo>
-                <a:cubicBezTo>
-                  <a:pt x="8797961" y="20239"/>
-                  <a:pt x="8994198" y="29575"/>
-                  <a:pt x="9306306" y="0"/>
-                </a:cubicBezTo>
-                <a:cubicBezTo>
-                  <a:pt x="9618414" y="-29575"/>
-                  <a:pt x="9739118" y="-23835"/>
-                  <a:pt x="9858375" y="0"/>
-                </a:cubicBezTo>
-                <a:cubicBezTo>
-                  <a:pt x="9977632" y="23835"/>
-                  <a:pt x="10370488" y="-4069"/>
-                  <a:pt x="10515600" y="0"/>
-                </a:cubicBezTo>
-                <a:cubicBezTo>
-                  <a:pt x="10524919" y="196329"/>
-                  <a:pt x="10549062" y="488432"/>
-                  <a:pt x="10515600" y="785334"/>
-                </a:cubicBezTo>
-                <a:cubicBezTo>
-                  <a:pt x="10482138" y="1082236"/>
-                  <a:pt x="10536385" y="1323726"/>
-                  <a:pt x="10515600" y="1516506"/>
-                </a:cubicBezTo>
-                <a:cubicBezTo>
-                  <a:pt x="10494815" y="1709286"/>
-                  <a:pt x="10546328" y="2097632"/>
-                  <a:pt x="10515600" y="2247679"/>
-                </a:cubicBezTo>
-                <a:cubicBezTo>
-                  <a:pt x="10484872" y="2397726"/>
-                  <a:pt x="10491771" y="2577292"/>
-                  <a:pt x="10515600" y="2762208"/>
-                </a:cubicBezTo>
-                <a:cubicBezTo>
-                  <a:pt x="10539429" y="2947124"/>
-                  <a:pt x="10511007" y="3105736"/>
-                  <a:pt x="10515600" y="3330898"/>
-                </a:cubicBezTo>
-                <a:cubicBezTo>
-                  <a:pt x="10520194" y="3556060"/>
-                  <a:pt x="10497393" y="3882611"/>
-                  <a:pt x="10515600" y="4062071"/>
-                </a:cubicBezTo>
-                <a:cubicBezTo>
-                  <a:pt x="10533807" y="4241531"/>
-                  <a:pt x="10544791" y="4505155"/>
-                  <a:pt x="10515600" y="4684921"/>
-                </a:cubicBezTo>
-                <a:cubicBezTo>
-                  <a:pt x="10486410" y="4864687"/>
-                  <a:pt x="10497356" y="5246484"/>
-                  <a:pt x="10515600" y="5416094"/>
-                </a:cubicBezTo>
-                <a:cubicBezTo>
-                  <a:pt x="10245623" y="5445692"/>
-                  <a:pt x="10029676" y="5415505"/>
-                  <a:pt x="9753219" y="5416094"/>
-                </a:cubicBezTo>
-                <a:cubicBezTo>
-                  <a:pt x="9476762" y="5416683"/>
-                  <a:pt x="9553148" y="5422760"/>
-                  <a:pt x="9411462" y="5416094"/>
-                </a:cubicBezTo>
-                <a:cubicBezTo>
-                  <a:pt x="9269776" y="5409428"/>
-                  <a:pt x="8927709" y="5385012"/>
-                  <a:pt x="8754237" y="5416094"/>
-                </a:cubicBezTo>
-                <a:cubicBezTo>
-                  <a:pt x="8580766" y="5447176"/>
-                  <a:pt x="8413264" y="5410024"/>
-                  <a:pt x="8307324" y="5416094"/>
-                </a:cubicBezTo>
-                <a:cubicBezTo>
-                  <a:pt x="8201384" y="5422164"/>
-                  <a:pt x="7912690" y="5421686"/>
-                  <a:pt x="7544943" y="5416094"/>
-                </a:cubicBezTo>
-                <a:cubicBezTo>
-                  <a:pt x="7177196" y="5410502"/>
-                  <a:pt x="7304235" y="5418502"/>
-                  <a:pt x="7098030" y="5416094"/>
-                </a:cubicBezTo>
-                <a:cubicBezTo>
-                  <a:pt x="6891825" y="5413686"/>
-                  <a:pt x="6541479" y="5434609"/>
-                  <a:pt x="6335649" y="5416094"/>
-                </a:cubicBezTo>
-                <a:cubicBezTo>
-                  <a:pt x="6129819" y="5397579"/>
-                  <a:pt x="6106541" y="5402791"/>
-                  <a:pt x="5993892" y="5416094"/>
-                </a:cubicBezTo>
-                <a:cubicBezTo>
-                  <a:pt x="5881243" y="5429397"/>
-                  <a:pt x="5545248" y="5437743"/>
-                  <a:pt x="5231511" y="5416094"/>
-                </a:cubicBezTo>
-                <a:cubicBezTo>
-                  <a:pt x="4917774" y="5394445"/>
-                  <a:pt x="4963237" y="5426599"/>
-                  <a:pt x="4784598" y="5416094"/>
-                </a:cubicBezTo>
-                <a:cubicBezTo>
-                  <a:pt x="4605959" y="5405589"/>
-                  <a:pt x="4605904" y="5406658"/>
-                  <a:pt x="4442841" y="5416094"/>
-                </a:cubicBezTo>
-                <a:cubicBezTo>
-                  <a:pt x="4279778" y="5425530"/>
-                  <a:pt x="4177180" y="5426138"/>
-                  <a:pt x="3995928" y="5416094"/>
-                </a:cubicBezTo>
-                <a:cubicBezTo>
-                  <a:pt x="3814676" y="5406050"/>
-                  <a:pt x="3516440" y="5429234"/>
-                  <a:pt x="3233547" y="5416094"/>
-                </a:cubicBezTo>
-                <a:cubicBezTo>
-                  <a:pt x="2950654" y="5402954"/>
-                  <a:pt x="2884354" y="5436103"/>
-                  <a:pt x="2786634" y="5416094"/>
-                </a:cubicBezTo>
-                <a:cubicBezTo>
-                  <a:pt x="2688914" y="5396085"/>
-                  <a:pt x="2522958" y="5423232"/>
-                  <a:pt x="2444877" y="5416094"/>
-                </a:cubicBezTo>
-                <a:cubicBezTo>
-                  <a:pt x="2366796" y="5408956"/>
-                  <a:pt x="2104768" y="5395479"/>
-                  <a:pt x="1997964" y="5416094"/>
-                </a:cubicBezTo>
-                <a:cubicBezTo>
-                  <a:pt x="1891160" y="5436709"/>
-                  <a:pt x="1573016" y="5412376"/>
-                  <a:pt x="1445895" y="5416094"/>
-                </a:cubicBezTo>
-                <a:cubicBezTo>
-                  <a:pt x="1318774" y="5419812"/>
-                  <a:pt x="986443" y="5400529"/>
-                  <a:pt x="788670" y="5416094"/>
-                </a:cubicBezTo>
-                <a:cubicBezTo>
-                  <a:pt x="590897" y="5431659"/>
-                  <a:pt x="363709" y="5381266"/>
-                  <a:pt x="0" y="5416094"/>
-                </a:cubicBezTo>
-                <a:cubicBezTo>
-                  <a:pt x="-22973" y="5218643"/>
-                  <a:pt x="-26699" y="5010779"/>
-                  <a:pt x="0" y="4630760"/>
-                </a:cubicBezTo>
-                <a:cubicBezTo>
-                  <a:pt x="26699" y="4250741"/>
-                  <a:pt x="-15389" y="4196664"/>
-                  <a:pt x="0" y="3953749"/>
-                </a:cubicBezTo>
-                <a:cubicBezTo>
-                  <a:pt x="15389" y="3710834"/>
-                  <a:pt x="468" y="3611311"/>
-                  <a:pt x="0" y="3276737"/>
-                </a:cubicBezTo>
-                <a:cubicBezTo>
-                  <a:pt x="-468" y="2942163"/>
-                  <a:pt x="15360" y="2781998"/>
-                  <a:pt x="0" y="2599725"/>
-                </a:cubicBezTo>
-                <a:cubicBezTo>
-                  <a:pt x="-15360" y="2417452"/>
-                  <a:pt x="14816" y="2100232"/>
-                  <a:pt x="0" y="1922713"/>
-                </a:cubicBezTo>
-                <a:cubicBezTo>
-                  <a:pt x="-14816" y="1745194"/>
-                  <a:pt x="-24648" y="1604167"/>
-                  <a:pt x="0" y="1299863"/>
-                </a:cubicBezTo>
-                <a:cubicBezTo>
-                  <a:pt x="24648" y="995559"/>
-                  <a:pt x="2182" y="279525"/>
-                  <a:pt x="0" y="0"/>
-                </a:cubicBezTo>
-                <a:close/>
-              </a:path>
-            </a:pathLst>
-          </a:custGeom>
-          <a:noFill/>
-          <a:ln w="47625" cap="rnd">
-            <a:solidFill>
-              <a:schemeClr val="bg1">
-                <a:alpha val="75000"/>
-              </a:schemeClr>
-            </a:solidFill>
-            <a:round/>
-            <a:extLst>
-              <a:ext uri="{C807C97D-BFC1-408E-A445-0C87EB9F89A2}">
-                <ask:lineSketchStyleProps xmlns:ask="http://schemas.microsoft.com/office/drawing/2018/sketchyshapes" sd="1219033472">
-                  <a:prstGeom prst="rect">
-                    <a:avLst/>
-                  </a:prstGeom>
-                  <ask:type>
-                    <ask:lineSketchFreehand/>
-                  </ask:type>
-                </ask:lineSketchStyleProps>
-              </a:ext>
-            </a:extLst>
-          </a:ln>
-        </p:spPr>
-        <p:style>
-          <a:lnRef idx="2">
-            <a:schemeClr val="accent1">
-              <a:shade val="50000"/>
-            </a:schemeClr>
-          </a:lnRef>
-          <a:fillRef idx="1">
-            <a:schemeClr val="accent1"/>
-          </a:fillRef>
-          <a:effectRef idx="0">
-            <a:schemeClr val="accent1"/>
-          </a:effectRef>
-          <a:fontRef idx="minor">
-            <a:schemeClr val="lt1"/>
-          </a:fontRef>
-        </p:style>
-        <p:txBody>
-          <a:bodyPr rtlCol="0" anchor="ctr"/>
-          <a:lstStyle/>
-          <a:p>
-            <a:pPr algn="ctr"/>
-            <a:endParaRPr lang="en-US"/>
-          </a:p>
-        </p:txBody>
-      </p:sp>
-      <p:sp>
-        <p:nvSpPr>
-          <p:cNvPr id="29" name="sketchy line">
-            <a:extLst>
-              <a:ext uri="{FF2B5EF4-FFF2-40B4-BE49-F238E27FC236}">
-                <a16:creationId xmlns:a16="http://schemas.microsoft.com/office/drawing/2014/main" id="{4E87FCFB-2CCE-460D-B3DD-557C8BD1B94A}"/>
-              </a:ext>
-              <a:ext uri="{C183D7F6-B498-43B3-948B-1728B52AA6E4}">
-                <adec:decorative xmlns:adec="http://schemas.microsoft.com/office/drawing/2017/decorative" val="1"/>
-              </a:ext>
-            </a:extLst>
-          </p:cNvPr>
-          <p:cNvSpPr>
-            <a:spLocks noGrp="1" noRot="1" noChangeAspect="1" noMove="1" noResize="1" noEditPoints="1" noAdjustHandles="1" noChangeArrowheads="1" noChangeShapeType="1" noTextEdit="1"/>
-          </p:cNvSpPr>
-          <p:nvPr>
-            <p:extLst>
-              <p:ext uri="{386F3935-93C4-4BCD-93E2-E3B085C9AB24}">
-                <p16:designElem xmlns:p16="http://schemas.microsoft.com/office/powerpoint/2015/main" val="1"/>
-              </p:ext>
-            </p:extLst>
-          </p:nvPr>
-        </p:nvSpPr>
-        <p:spPr>
-          <a:xfrm>
-            <a:off x="3974206" y="4419423"/>
-            <a:ext cx="4243589" cy="18288"/>
-          </a:xfrm>
-          <a:custGeom>
-            <a:avLst/>
-            <a:gdLst>
-              <a:gd name="csX0" fmla="*/ 0 w 4243589"/>
-              <a:gd name="csY0" fmla="*/ 0 h 18288"/>
-              <a:gd name="csX1" fmla="*/ 563791 w 4243589"/>
-              <a:gd name="csY1" fmla="*/ 0 h 18288"/>
-              <a:gd name="csX2" fmla="*/ 1042710 w 4243589"/>
-              <a:gd name="csY2" fmla="*/ 0 h 18288"/>
-              <a:gd name="csX3" fmla="*/ 1564066 w 4243589"/>
-              <a:gd name="csY3" fmla="*/ 0 h 18288"/>
-              <a:gd name="csX4" fmla="*/ 2212729 w 4243589"/>
-              <a:gd name="csY4" fmla="*/ 0 h 18288"/>
-              <a:gd name="csX5" fmla="*/ 2776520 w 4243589"/>
-              <a:gd name="csY5" fmla="*/ 0 h 18288"/>
-              <a:gd name="csX6" fmla="*/ 3297875 w 4243589"/>
-              <a:gd name="csY6" fmla="*/ 0 h 18288"/>
-              <a:gd name="csX7" fmla="*/ 4243589 w 4243589"/>
-              <a:gd name="csY7" fmla="*/ 0 h 18288"/>
-              <a:gd name="csX8" fmla="*/ 4243589 w 4243589"/>
-              <a:gd name="csY8" fmla="*/ 18288 h 18288"/>
-              <a:gd name="csX9" fmla="*/ 3637362 w 4243589"/>
-              <a:gd name="csY9" fmla="*/ 18288 h 18288"/>
-              <a:gd name="csX10" fmla="*/ 3116007 w 4243589"/>
-              <a:gd name="csY10" fmla="*/ 18288 h 18288"/>
-              <a:gd name="csX11" fmla="*/ 2424908 w 4243589"/>
-              <a:gd name="csY11" fmla="*/ 18288 h 18288"/>
-              <a:gd name="csX12" fmla="*/ 1861117 w 4243589"/>
-              <a:gd name="csY12" fmla="*/ 18288 h 18288"/>
-              <a:gd name="csX13" fmla="*/ 1382198 w 4243589"/>
-              <a:gd name="csY13" fmla="*/ 18288 h 18288"/>
-              <a:gd name="csX14" fmla="*/ 733535 w 4243589"/>
-              <a:gd name="csY14" fmla="*/ 18288 h 18288"/>
-              <a:gd name="csX15" fmla="*/ 0 w 4243589"/>
-              <a:gd name="csY15" fmla="*/ 18288 h 18288"/>
-              <a:gd name="csX16" fmla="*/ 0 w 4243589"/>
-              <a:gd name="csY16" fmla="*/ 0 h 18288"/>
-            </a:gdLst>
-            <a:ahLst/>
-            <a:cxnLst>
-              <a:cxn ang="0">
-                <a:pos x="csX0" y="csY0"/>
-              </a:cxn>
-              <a:cxn ang="0">
-                <a:pos x="csX1" y="csY1"/>
-              </a:cxn>
-              <a:cxn ang="0">
-                <a:pos x="csX2" y="csY2"/>
-              </a:cxn>
-              <a:cxn ang="0">
-                <a:pos x="csX3" y="csY3"/>
-              </a:cxn>
-              <a:cxn ang="0">
-                <a:pos x="csX4" y="csY4"/>
-              </a:cxn>
-              <a:cxn ang="0">
-                <a:pos x="csX5" y="csY5"/>
-              </a:cxn>
-              <a:cxn ang="0">
-                <a:pos x="csX6" y="csY6"/>
-              </a:cxn>
-              <a:cxn ang="0">
-                <a:pos x="csX7" y="csY7"/>
-              </a:cxn>
-              <a:cxn ang="0">
-                <a:pos x="csX8" y="csY8"/>
-              </a:cxn>
-              <a:cxn ang="0">
-                <a:pos x="csX9" y="csY9"/>
-              </a:cxn>
-              <a:cxn ang="0">
-                <a:pos x="csX10" y="csY10"/>
-              </a:cxn>
-              <a:cxn ang="0">
-                <a:pos x="csX11" y="csY11"/>
-              </a:cxn>
-              <a:cxn ang="0">
-                <a:pos x="csX12" y="csY12"/>
-              </a:cxn>
-              <a:cxn ang="0">
-                <a:pos x="csX13" y="csY13"/>
-              </a:cxn>
-              <a:cxn ang="0">
-                <a:pos x="csX14" y="csY14"/>
-              </a:cxn>
-              <a:cxn ang="0">
-                <a:pos x="csX15" y="csY15"/>
-              </a:cxn>
-              <a:cxn ang="0">
-                <a:pos x="csX16" y="csY16"/>
-              </a:cxn>
-            </a:cxnLst>
-            <a:rect l="l" t="t" r="r" b="b"/>
-            <a:pathLst>
-              <a:path w="4243589" h="18288" fill="none" extrusionOk="0">
-                <a:moveTo>
-                  <a:pt x="0" y="0"/>
-                </a:moveTo>
-                <a:cubicBezTo>
-                  <a:pt x="157351" y="-15653"/>
-                  <a:pt x="378877" y="-5828"/>
-                  <a:pt x="563791" y="0"/>
-                </a:cubicBezTo>
-                <a:cubicBezTo>
-                  <a:pt x="748705" y="5828"/>
-                  <a:pt x="905659" y="-5525"/>
-                  <a:pt x="1042710" y="0"/>
-                </a:cubicBezTo>
-                <a:cubicBezTo>
-                  <a:pt x="1179761" y="5525"/>
-                  <a:pt x="1356845" y="-21288"/>
-                  <a:pt x="1564066" y="0"/>
-                </a:cubicBezTo>
-                <a:cubicBezTo>
-                  <a:pt x="1771287" y="21288"/>
-                  <a:pt x="1912099" y="25135"/>
-                  <a:pt x="2212729" y="0"/>
-                </a:cubicBezTo>
-                <a:cubicBezTo>
-                  <a:pt x="2513359" y="-25135"/>
-                  <a:pt x="2514918" y="-27119"/>
-                  <a:pt x="2776520" y="0"/>
-                </a:cubicBezTo>
-                <a:cubicBezTo>
-                  <a:pt x="3038122" y="27119"/>
-                  <a:pt x="3178771" y="18116"/>
-                  <a:pt x="3297875" y="0"/>
-                </a:cubicBezTo>
-                <a:cubicBezTo>
-                  <a:pt x="3416980" y="-18116"/>
-                  <a:pt x="4012240" y="-40869"/>
-                  <a:pt x="4243589" y="0"/>
-                </a:cubicBezTo>
-                <a:cubicBezTo>
-                  <a:pt x="4243987" y="7429"/>
-                  <a:pt x="4243569" y="10822"/>
-                  <a:pt x="4243589" y="18288"/>
-                </a:cubicBezTo>
-                <a:cubicBezTo>
-                  <a:pt x="4112949" y="-2855"/>
-                  <a:pt x="3928037" y="1831"/>
-                  <a:pt x="3637362" y="18288"/>
-                </a:cubicBezTo>
-                <a:cubicBezTo>
-                  <a:pt x="3346687" y="34745"/>
-                  <a:pt x="3254446" y="26669"/>
-                  <a:pt x="3116007" y="18288"/>
-                </a:cubicBezTo>
-                <a:cubicBezTo>
-                  <a:pt x="2977569" y="9907"/>
-                  <a:pt x="2620228" y="28873"/>
-                  <a:pt x="2424908" y="18288"/>
-                </a:cubicBezTo>
-                <a:cubicBezTo>
-                  <a:pt x="2229588" y="7703"/>
-                  <a:pt x="2088287" y="-3854"/>
-                  <a:pt x="1861117" y="18288"/>
-                </a:cubicBezTo>
-                <a:cubicBezTo>
-                  <a:pt x="1633947" y="40430"/>
-                  <a:pt x="1502447" y="-871"/>
-                  <a:pt x="1382198" y="18288"/>
-                </a:cubicBezTo>
-                <a:cubicBezTo>
-                  <a:pt x="1261949" y="37447"/>
-                  <a:pt x="1045440" y="28353"/>
-                  <a:pt x="733535" y="18288"/>
-                </a:cubicBezTo>
-                <a:cubicBezTo>
-                  <a:pt x="421630" y="8223"/>
-                  <a:pt x="341257" y="-18359"/>
-                  <a:pt x="0" y="18288"/>
-                </a:cubicBezTo>
-                <a:cubicBezTo>
-                  <a:pt x="-591" y="13205"/>
-                  <a:pt x="-663" y="6329"/>
-                  <a:pt x="0" y="0"/>
-                </a:cubicBezTo>
-                <a:close/>
-              </a:path>
-              <a:path w="4243589" h="18288" stroke="0" extrusionOk="0">
-                <a:moveTo>
-                  <a:pt x="0" y="0"/>
-                </a:moveTo>
-                <a:cubicBezTo>
-                  <a:pt x="128164" y="17204"/>
-                  <a:pt x="312653" y="1129"/>
-                  <a:pt x="563791" y="0"/>
-                </a:cubicBezTo>
-                <a:cubicBezTo>
-                  <a:pt x="814929" y="-1129"/>
-                  <a:pt x="837271" y="8503"/>
-                  <a:pt x="1042710" y="0"/>
-                </a:cubicBezTo>
-                <a:cubicBezTo>
-                  <a:pt x="1248149" y="-8503"/>
-                  <a:pt x="1588432" y="-28862"/>
-                  <a:pt x="1733809" y="0"/>
-                </a:cubicBezTo>
-                <a:cubicBezTo>
-                  <a:pt x="1879186" y="28862"/>
-                  <a:pt x="2052815" y="5974"/>
-                  <a:pt x="2297600" y="0"/>
-                </a:cubicBezTo>
-                <a:cubicBezTo>
-                  <a:pt x="2542385" y="-5974"/>
-                  <a:pt x="2699960" y="-23550"/>
-                  <a:pt x="2861391" y="0"/>
-                </a:cubicBezTo>
-                <a:cubicBezTo>
-                  <a:pt x="3022822" y="23550"/>
-                  <a:pt x="3390411" y="25272"/>
-                  <a:pt x="3552490" y="0"/>
-                </a:cubicBezTo>
-                <a:cubicBezTo>
-                  <a:pt x="3714569" y="-25272"/>
-                  <a:pt x="3950585" y="-31327"/>
-                  <a:pt x="4243589" y="0"/>
-                </a:cubicBezTo>
-                <a:cubicBezTo>
-                  <a:pt x="4242703" y="5429"/>
-                  <a:pt x="4244410" y="14046"/>
-                  <a:pt x="4243589" y="18288"/>
-                </a:cubicBezTo>
-                <a:cubicBezTo>
-                  <a:pt x="4130424" y="-1240"/>
-                  <a:pt x="3932803" y="42249"/>
-                  <a:pt x="3722234" y="18288"/>
-                </a:cubicBezTo>
-                <a:cubicBezTo>
-                  <a:pt x="3511665" y="-5673"/>
-                  <a:pt x="3269903" y="45994"/>
-                  <a:pt x="3116007" y="18288"/>
-                </a:cubicBezTo>
-                <a:cubicBezTo>
-                  <a:pt x="2962111" y="-9418"/>
-                  <a:pt x="2744280" y="23224"/>
-                  <a:pt x="2509780" y="18288"/>
-                </a:cubicBezTo>
-                <a:cubicBezTo>
-                  <a:pt x="2275280" y="13352"/>
-                  <a:pt x="2066059" y="43664"/>
-                  <a:pt x="1945989" y="18288"/>
-                </a:cubicBezTo>
-                <a:cubicBezTo>
-                  <a:pt x="1825919" y="-7088"/>
-                  <a:pt x="1407329" y="12616"/>
-                  <a:pt x="1254890" y="18288"/>
-                </a:cubicBezTo>
-                <a:cubicBezTo>
-                  <a:pt x="1102451" y="23960"/>
-                  <a:pt x="837950" y="31673"/>
-                  <a:pt x="563791" y="18288"/>
-                </a:cubicBezTo>
-                <a:cubicBezTo>
-                  <a:pt x="289632" y="4903"/>
-                  <a:pt x="132768" y="7105"/>
-                  <a:pt x="0" y="18288"/>
-                </a:cubicBezTo>
-                <a:cubicBezTo>
-                  <a:pt x="668" y="13665"/>
-                  <a:pt x="578" y="5675"/>
-                  <a:pt x="0" y="0"/>
-                </a:cubicBezTo>
-                <a:close/>
-              </a:path>
-            </a:pathLst>
-          </a:custGeom>
-          <a:solidFill>
-            <a:srgbClr val="FFFFFF">
-              <a:alpha val="75000"/>
-            </a:srgbClr>
-          </a:solidFill>
-          <a:ln w="41275" cap="rnd">
-            <a:solidFill>
-              <a:schemeClr val="bg1">
-                <a:alpha val="75000"/>
-              </a:schemeClr>
-            </a:solidFill>
-            <a:round/>
-            <a:extLst>
-              <a:ext uri="{C807C97D-BFC1-408E-A445-0C87EB9F89A2}">
-                <ask:lineSketchStyleProps xmlns:ask="http://schemas.microsoft.com/office/drawing/2018/sketchyshapes" sd="1219033472">
-                  <a:prstGeom prst="rect">
-                    <a:avLst/>
-                  </a:prstGeom>
-                  <ask:type>
-                    <ask:lineSketchFreehand/>
-                  </ask:type>
-                </ask:lineSketchStyleProps>
-              </a:ext>
-            </a:extLst>
-          </a:ln>
-        </p:spPr>
-        <p:style>
-          <a:lnRef idx="2">
-            <a:schemeClr val="accent1">
-              <a:shade val="50000"/>
-            </a:schemeClr>
-          </a:lnRef>
-          <a:fillRef idx="1">
-            <a:schemeClr val="accent1"/>
-          </a:fillRef>
-          <a:effectRef idx="0">
-            <a:schemeClr val="accent1"/>
-          </a:effectRef>
-          <a:fontRef idx="minor">
-            <a:schemeClr val="lt1"/>
-          </a:fontRef>
-        </p:style>
-        <p:txBody>
-          <a:bodyPr rtlCol="0" anchor="ctr"/>
-          <a:lstStyle/>
-          <a:p>
-            <a:pPr algn="ctr"/>
-            <a:endParaRPr lang="en-US"/>
+              <a:t>Problema de Matemática contextualizado na Física</a:t>
+            </a:r>
           </a:p>
         </p:txBody>
       </p:sp>
@@ -7199,7 +4202,7 @@
               <a:buNone/>
             </a:pPr>
             <a:r>
-              <a:rPr lang="pt-BR" sz="2000" b="1" dirty="0"/>
+              <a:rPr lang="pt-BR" sz="2400" b="1" dirty="0"/>
               <a:t>Índice:</a:t>
             </a:r>
           </a:p>
@@ -7207,13 +4210,7 @@
             <a:pPr>
               <a:buNone/>
             </a:pPr>
-            <a:endParaRPr lang="pt-BR" sz="2000" b="1" dirty="0"/>
-          </a:p>
-          <a:p>
-            <a:pPr>
-              <a:buNone/>
-            </a:pPr>
-            <a:endParaRPr lang="pt-BR" sz="2000" b="1" dirty="0"/>
+            <a:endParaRPr lang="pt-BR" sz="2400" b="1" dirty="0"/>
           </a:p>
           <a:p>
             <a:pPr>
@@ -7221,7 +4218,7 @@
               <a:buChar char="•"/>
             </a:pPr>
             <a:r>
-              <a:rPr lang="pt-BR" sz="2000" b="1" dirty="0"/>
+              <a:rPr lang="pt-BR" sz="2400" b="1" dirty="0"/>
               <a:t>Introdução.</a:t>
             </a:r>
           </a:p>
@@ -7231,8 +4228,8 @@
               <a:buChar char="•"/>
             </a:pPr>
             <a:r>
-              <a:rPr lang="pt-BR" sz="2000" b="1" dirty="0"/>
-              <a:t>Noções matemáticas (Resumo de Equações de 1° e 2° grau).</a:t>
+              <a:rPr lang="pt-BR" sz="2400" b="1" dirty="0"/>
+              <a:t>Noções matemáticas (Equações de 1° grau).</a:t>
             </a:r>
           </a:p>
           <a:p>
@@ -7241,8 +4238,8 @@
               <a:buChar char="•"/>
             </a:pPr>
             <a:r>
-              <a:rPr lang="pt-BR" sz="2000" b="1" dirty="0"/>
-              <a:t>Função da velocidade, contextualizando cálculos Físicos (equação de 1° grau).</a:t>
+              <a:rPr lang="pt-BR" sz="2400" b="1" dirty="0"/>
+              <a:t>Função da velocidade, cálculos Físicos.</a:t>
             </a:r>
           </a:p>
           <a:p>
@@ -7251,8 +4248,8 @@
               <a:buChar char="•"/>
             </a:pPr>
             <a:r>
-              <a:rPr lang="pt-BR" sz="2000" b="1" dirty="0"/>
-              <a:t>Função horária, contextualizando cálculos Físicos (Equação de 2° grau).</a:t>
+              <a:rPr lang="pt-BR" sz="2400" b="1" dirty="0"/>
+              <a:t>Problema matemático contextualizado na Física.</a:t>
             </a:r>
           </a:p>
           <a:p>
@@ -7261,8 +4258,8 @@
               <a:buChar char="•"/>
             </a:pPr>
             <a:r>
-              <a:rPr lang="pt-BR" sz="2000" b="1" dirty="0"/>
-              <a:t>Problema matemático contextualizado na Física.</a:t>
+              <a:rPr lang="pt-BR" sz="2400" b="1" dirty="0"/>
+              <a:t>Conclusão.</a:t>
             </a:r>
           </a:p>
           <a:p>
@@ -7271,17 +4268,7 @@
               <a:buChar char="•"/>
             </a:pPr>
             <a:r>
-              <a:rPr lang="pt-BR" sz="2000" b="1" dirty="0"/>
-              <a:t>Conclusão.</a:t>
-            </a:r>
-          </a:p>
-          <a:p>
-            <a:pPr>
-              <a:buFont typeface="Arial"/>
-              <a:buChar char="•"/>
-            </a:pPr>
-            <a:r>
-              <a:rPr lang="pt-BR" sz="2000" b="1" dirty="0"/>
+              <a:rPr lang="pt-BR" sz="2400" b="1" dirty="0"/>
               <a:t>Referências.</a:t>
             </a:r>
             <a:r>
@@ -8960,8 +5947,8 @@
         </p:nvSpPr>
         <p:spPr>
           <a:xfrm>
-            <a:off x="838200" y="-3969"/>
-            <a:ext cx="10515600" cy="1004095"/>
+            <a:off x="3796553" y="-3969"/>
+            <a:ext cx="4083424" cy="1004095"/>
           </a:xfrm>
         </p:spPr>
         <p:txBody>
@@ -8974,7 +5961,7 @@
               <a:rPr lang="pt-BR" sz="2800" b="1" dirty="0">
                 <a:latin typeface="Aptos"/>
               </a:rPr>
-              <a:t>Noções matemáticas (Resumo de Equações de 1° e 2° grau).</a:t>
+              <a:t>Noções matemáticas</a:t>
             </a:r>
             <a:endParaRPr lang="pt-BR" sz="2800" b="1" dirty="0"/>
           </a:p>
@@ -8998,8 +5985,8 @@
         </p:nvSpPr>
         <p:spPr>
           <a:xfrm>
-            <a:off x="707231" y="825498"/>
-            <a:ext cx="10515600" cy="1112839"/>
+            <a:off x="572760" y="993586"/>
+            <a:ext cx="10515600" cy="608575"/>
           </a:xfrm>
         </p:spPr>
         <p:txBody>
@@ -9012,45 +5999,18 @@
               <a:buNone/>
             </a:pPr>
             <a:r>
-              <a:rPr lang="pt-BR" sz="2000" dirty="0"/>
-              <a:t> Para iniciar, precisamos lembrar dois tipos fundamentais de equações:</a:t>
-            </a:r>
-            <a:br>
-              <a:rPr lang="pt-BR" sz="2000" dirty="0"/>
-            </a:br>
-            <a:r>
-              <a:rPr lang="pt-BR" sz="2000" dirty="0"/>
-              <a:t>as </a:t>
-            </a:r>
-            <a:r>
-              <a:rPr lang="pt-BR" sz="2000" b="1" dirty="0"/>
-              <a:t>equações do primeiro grau</a:t>
-            </a:r>
-            <a:r>
-              <a:rPr lang="pt-BR" sz="2000" dirty="0"/>
-              <a:t> e as </a:t>
-            </a:r>
-            <a:r>
-              <a:rPr lang="pt-BR" sz="2000" b="1" dirty="0"/>
-              <a:t>equações do segundo grau</a:t>
-            </a:r>
-            <a:r>
-              <a:rPr lang="pt-BR" sz="2000" dirty="0"/>
-              <a:t>.</a:t>
-            </a:r>
-          </a:p>
-          <a:p>
-            <a:pPr marL="0" indent="0" algn="just">
-              <a:buNone/>
-            </a:pPr>
-            <a:r>
-              <a:rPr lang="pt-BR" sz="2400" b="1" dirty="0">
+              <a:rPr lang="pt-BR" sz="2400" b="1">
                 <a:solidFill>
                   <a:schemeClr val="accent1"/>
                 </a:solidFill>
               </a:rPr>
               <a:t>Equação do Primeiro Grau</a:t>
             </a:r>
+            <a:endParaRPr lang="pt-BR" sz="2000">
+              <a:solidFill>
+                <a:schemeClr val="accent1"/>
+              </a:solidFill>
+            </a:endParaRPr>
           </a:p>
           <a:p>
             <a:pPr marL="0" indent="0" algn="just">
@@ -9074,7 +6034,7 @@
         </p:nvSpPr>
         <p:spPr>
           <a:xfrm>
-            <a:off x="122108" y="2390519"/>
+            <a:off x="-1157" y="1964695"/>
             <a:ext cx="6874669" cy="4462760"/>
           </a:xfrm>
           <a:prstGeom prst="rect">
@@ -9298,8 +6258,8 @@
         </p:blipFill>
         <p:spPr>
           <a:xfrm>
-            <a:off x="7188993" y="2178844"/>
-            <a:ext cx="4862513" cy="4024313"/>
+            <a:off x="7043316" y="1719403"/>
+            <a:ext cx="4996983" cy="4024313"/>
           </a:xfrm>
           <a:prstGeom prst="rect">
             <a:avLst/>
@@ -9341,297 +6301,6 @@
           <p:cNvPr id="2" name="Título 1">
             <a:extLst>
               <a:ext uri="{FF2B5EF4-FFF2-40B4-BE49-F238E27FC236}">
-                <a16:creationId xmlns:a16="http://schemas.microsoft.com/office/drawing/2014/main" id="{82CDC54B-B311-A6BC-899D-7CE444F4C109}"/>
-              </a:ext>
-            </a:extLst>
-          </p:cNvPr>
-          <p:cNvSpPr>
-            <a:spLocks noGrp="1"/>
-          </p:cNvSpPr>
-          <p:nvPr>
-            <p:ph type="title"/>
-          </p:nvPr>
-        </p:nvSpPr>
-        <p:spPr>
-          <a:xfrm>
-            <a:off x="1910166" y="132650"/>
-            <a:ext cx="4574584" cy="577487"/>
-          </a:xfrm>
-        </p:spPr>
-        <p:txBody>
-          <a:bodyPr>
-            <a:normAutofit/>
-          </a:bodyPr>
-          <a:lstStyle/>
-          <a:p>
-            <a:r>
-              <a:rPr lang="pt-BR" sz="2800" b="1" dirty="0">
-                <a:solidFill>
-                  <a:schemeClr val="accent1"/>
-                </a:solidFill>
-              </a:rPr>
-              <a:t>Equação do segundo grau</a:t>
-            </a:r>
-          </a:p>
-        </p:txBody>
-      </p:sp>
-      <p:sp>
-        <p:nvSpPr>
-          <p:cNvPr id="3" name="Espaço Reservado para Conteúdo 2">
-            <a:extLst>
-              <a:ext uri="{FF2B5EF4-FFF2-40B4-BE49-F238E27FC236}">
-                <a16:creationId xmlns:a16="http://schemas.microsoft.com/office/drawing/2014/main" id="{00A488A8-3DF7-15CE-A329-2D5CDEEC842D}"/>
-              </a:ext>
-            </a:extLst>
-          </p:cNvPr>
-          <p:cNvSpPr>
-            <a:spLocks noGrp="1"/>
-          </p:cNvSpPr>
-          <p:nvPr>
-            <p:ph idx="1"/>
-          </p:nvPr>
-        </p:nvSpPr>
-        <p:spPr>
-          <a:xfrm>
-            <a:off x="229972" y="1362494"/>
-            <a:ext cx="6253164" cy="4528919"/>
-          </a:xfrm>
-        </p:spPr>
-        <p:txBody>
-          <a:bodyPr vert="horz" lIns="91440" tIns="45720" rIns="91440" bIns="45720" rtlCol="0" anchor="t">
-            <a:normAutofit/>
-          </a:bodyPr>
-          <a:lstStyle/>
-          <a:p>
-            <a:pPr algn="just">
-              <a:buFont typeface="Arial"/>
-              <a:buChar char="•"/>
-            </a:pPr>
-            <a:r>
-              <a:rPr lang="pt-BR" sz="2000" dirty="0"/>
-              <a:t>Tem a forma </a:t>
-            </a:r>
-            <a:r>
-              <a:rPr lang="pt-BR" sz="2000" b="1" i="1" dirty="0"/>
-              <a:t>y = ax² + </a:t>
-            </a:r>
-            <a:r>
-              <a:rPr lang="pt-BR" sz="2000" b="1" i="1" err="1"/>
-              <a:t>bx</a:t>
-            </a:r>
-            <a:r>
-              <a:rPr lang="pt-BR" sz="2000" b="1" i="1" dirty="0"/>
-              <a:t> + c</a:t>
-            </a:r>
-            <a:r>
-              <a:rPr lang="pt-BR" sz="2000" i="1" dirty="0"/>
-              <a:t>.</a:t>
-            </a:r>
-            <a:endParaRPr lang="pt-BR" sz="2000" dirty="0"/>
-          </a:p>
-          <a:p>
-            <a:pPr algn="just">
-              <a:buFont typeface="Arial"/>
-              <a:buChar char="•"/>
-            </a:pPr>
-            <a:r>
-              <a:rPr lang="pt-BR" sz="2000" dirty="0"/>
-              <a:t>O gráfico é uma </a:t>
-            </a:r>
-            <a:r>
-              <a:rPr lang="pt-BR" sz="2000" b="1" dirty="0"/>
-              <a:t>parábola</a:t>
-            </a:r>
-            <a:r>
-              <a:rPr lang="pt-BR" sz="2000" dirty="0"/>
-              <a:t>.</a:t>
-            </a:r>
-          </a:p>
-          <a:p>
-            <a:pPr algn="just">
-              <a:buFont typeface="Arial"/>
-              <a:buChar char="•"/>
-            </a:pPr>
-            <a:r>
-              <a:rPr lang="pt-BR" sz="2000" dirty="0"/>
-              <a:t>A variável aparece elevada ao quadrado, o que faz o valor de y crescer (ou diminuir) de maneira, não linear.</a:t>
-            </a:r>
-          </a:p>
-          <a:p>
-            <a:pPr algn="just">
-              <a:buFont typeface="Arial"/>
-              <a:buChar char="•"/>
-            </a:pPr>
-            <a:r>
-              <a:rPr lang="pt-BR" sz="2000" dirty="0"/>
-              <a:t>A parábola pode abrir para cima (a &gt; 0) ou para baixo (a &lt; 0).</a:t>
-            </a:r>
-          </a:p>
-          <a:p>
-            <a:pPr algn="just">
-              <a:buFont typeface="Arial"/>
-              <a:buChar char="•"/>
-            </a:pPr>
-            <a:r>
-              <a:rPr lang="pt-BR" sz="2000" dirty="0"/>
-              <a:t>Se o </a:t>
-            </a:r>
-            <a:r>
-              <a:rPr lang="pt-BR" sz="2000" b="1" dirty="0"/>
-              <a:t>delta </a:t>
-            </a:r>
-            <a:r>
-              <a:rPr lang="pt-BR" sz="2000" dirty="0"/>
-              <a:t>da função for maior que zero teremos duas raízes reais.</a:t>
-            </a:r>
-          </a:p>
-          <a:p>
-            <a:pPr algn="just">
-              <a:buFont typeface="Arial"/>
-              <a:buChar char="•"/>
-            </a:pPr>
-            <a:r>
-              <a:rPr lang="pt-BR" sz="2000" dirty="0"/>
-              <a:t>Se o </a:t>
-            </a:r>
-            <a:r>
-              <a:rPr lang="pt-BR" sz="2000" b="1" dirty="0"/>
-              <a:t>delta </a:t>
-            </a:r>
-            <a:r>
-              <a:rPr lang="pt-BR" sz="2000" dirty="0"/>
-              <a:t>da função for igual a zero teremos somente uma raiz.</a:t>
-            </a:r>
-          </a:p>
-          <a:p>
-            <a:pPr algn="just">
-              <a:buFont typeface="Arial"/>
-              <a:buChar char="•"/>
-            </a:pPr>
-            <a:r>
-              <a:rPr lang="pt-BR" sz="2000" dirty="0"/>
-              <a:t>Se o </a:t>
-            </a:r>
-            <a:r>
-              <a:rPr lang="pt-BR" sz="2000" b="1" dirty="0"/>
-              <a:t>delta </a:t>
-            </a:r>
-            <a:r>
-              <a:rPr lang="pt-BR" sz="2000" dirty="0"/>
-              <a:t>da função for menor que zero não existirá raízes.</a:t>
-            </a:r>
-          </a:p>
-          <a:p>
-            <a:pPr marL="0" indent="0">
-              <a:buNone/>
-            </a:pPr>
-            <a:endParaRPr lang="pt-BR" sz="2000" dirty="0"/>
-          </a:p>
-        </p:txBody>
-      </p:sp>
-      <p:pic>
-        <p:nvPicPr>
-          <p:cNvPr id="4" name="Imagem 3" descr="Gráfico, Gráfico de linhas&#10;&#10;O conteúdo gerado por IA pode estar incorreto.">
-            <a:extLst>
-              <a:ext uri="{FF2B5EF4-FFF2-40B4-BE49-F238E27FC236}">
-                <a16:creationId xmlns:a16="http://schemas.microsoft.com/office/drawing/2014/main" id="{242088AA-BC5B-B4FF-F687-08B69154A109}"/>
-              </a:ext>
-            </a:extLst>
-          </p:cNvPr>
-          <p:cNvPicPr>
-            <a:picLocks noChangeAspect="1"/>
-          </p:cNvPicPr>
-          <p:nvPr/>
-        </p:nvPicPr>
-        <p:blipFill>
-          <a:blip r:embed="rId2"/>
-          <a:stretch>
-            <a:fillRect/>
-          </a:stretch>
-        </p:blipFill>
-        <p:spPr>
-          <a:xfrm>
-            <a:off x="6667540" y="443560"/>
-            <a:ext cx="5387397" cy="5450438"/>
-          </a:xfrm>
-          <a:prstGeom prst="rect">
-            <a:avLst/>
-          </a:prstGeom>
-        </p:spPr>
-      </p:pic>
-      <p:sp>
-        <p:nvSpPr>
-          <p:cNvPr id="5" name="CaixaDeTexto 4">
-            <a:extLst>
-              <a:ext uri="{FF2B5EF4-FFF2-40B4-BE49-F238E27FC236}">
-                <a16:creationId xmlns:a16="http://schemas.microsoft.com/office/drawing/2014/main" id="{0546AF0F-254F-2B0C-DD37-7F3901AB9A73}"/>
-              </a:ext>
-            </a:extLst>
-          </p:cNvPr>
-          <p:cNvSpPr txBox="1"/>
-          <p:nvPr/>
-        </p:nvSpPr>
-        <p:spPr>
-          <a:xfrm>
-            <a:off x="495172" y="6016118"/>
-            <a:ext cx="10625135" cy="400110"/>
-          </a:xfrm>
-          <a:prstGeom prst="rect">
-            <a:avLst/>
-          </a:prstGeom>
-          <a:noFill/>
-        </p:spPr>
-        <p:txBody>
-          <a:bodyPr rot="0" spcFirstLastPara="0" vertOverflow="overflow" horzOverflow="overflow" vert="horz" wrap="square" lIns="91440" tIns="45720" rIns="91440" bIns="45720" numCol="1" spcCol="0" rtlCol="0" fromWordArt="0" anchor="t" anchorCtr="0" forceAA="0" compatLnSpc="1">
-            <a:prstTxWarp prst="textNoShape">
-              <a:avLst/>
-            </a:prstTxWarp>
-            <a:spAutoFit/>
-          </a:bodyPr>
-          <a:lstStyle/>
-          <a:p>
-            <a:r>
-              <a:rPr lang="pt-BR" sz="2000" dirty="0"/>
-              <a:t> Esses dois tipos de equação serão essenciais para interpretarmos os movimentos na Física.</a:t>
-            </a:r>
-          </a:p>
-        </p:txBody>
-      </p:sp>
-    </p:spTree>
-    <p:extLst>
-      <p:ext uri="{BB962C8B-B14F-4D97-AF65-F5344CB8AC3E}">
-        <p14:creationId xmlns:p14="http://schemas.microsoft.com/office/powerpoint/2010/main" val="490173364"/>
-      </p:ext>
-    </p:extLst>
-  </p:cSld>
-  <p:clrMapOvr>
-    <a:masterClrMapping/>
-  </p:clrMapOvr>
-</p:sld>
-</file>
-
-<file path=ppt/slides/slide8.xml><?xml version="1.0" encoding="utf-8"?>
-<p:sld xmlns:a="http://schemas.openxmlformats.org/drawingml/2006/main" xmlns:r="http://schemas.openxmlformats.org/officeDocument/2006/relationships" xmlns:p="http://schemas.openxmlformats.org/presentationml/2006/main">
-  <p:cSld>
-    <p:spTree>
-      <p:nvGrpSpPr>
-        <p:cNvPr id="1" name=""/>
-        <p:cNvGrpSpPr/>
-        <p:nvPr/>
-      </p:nvGrpSpPr>
-      <p:grpSpPr>
-        <a:xfrm>
-          <a:off x="0" y="0"/>
-          <a:ext cx="0" cy="0"/>
-          <a:chOff x="0" y="0"/>
-          <a:chExt cx="0" cy="0"/>
-        </a:xfrm>
-      </p:grpSpPr>
-      <p:sp>
-        <p:nvSpPr>
-          <p:cNvPr id="2" name="Título 1">
-            <a:extLst>
-              <a:ext uri="{FF2B5EF4-FFF2-40B4-BE49-F238E27FC236}">
                 <a16:creationId xmlns:a16="http://schemas.microsoft.com/office/drawing/2014/main" id="{D489213B-701E-1E9F-8B6A-5B3ED6FA05FA}"/>
               </a:ext>
             </a:extLst>
@@ -9645,8 +6314,8 @@
         </p:nvSpPr>
         <p:spPr>
           <a:xfrm>
-            <a:off x="481013" y="-3969"/>
-            <a:ext cx="11134724" cy="813594"/>
+            <a:off x="2240336" y="-3969"/>
+            <a:ext cx="6663577" cy="813594"/>
           </a:xfrm>
         </p:spPr>
         <p:txBody>
@@ -9656,7 +6325,7 @@
           <a:lstStyle/>
           <a:p>
             <a:r>
-              <a:rPr lang="pt-BR" sz="2400" b="1" dirty="0">
+              <a:rPr lang="pt-BR" sz="2800" b="1">
                 <a:solidFill>
                   <a:schemeClr val="accent2">
                     <a:lumMod val="76000"/>
@@ -9664,8 +6333,16 @@
                 </a:solidFill>
                 <a:latin typeface="Aptos"/>
               </a:rPr>
-              <a:t>Função da velocidade, contextualizando cálculos Físicos (equação de 1° grau).</a:t>
-            </a:r>
+              <a:t>Função da velocidade, cálculos Físicos.</a:t>
+            </a:r>
+            <a:endParaRPr lang="pt-BR" sz="2800" b="1" dirty="0">
+              <a:solidFill>
+                <a:schemeClr val="accent2">
+                  <a:lumMod val="76000"/>
+                </a:schemeClr>
+              </a:solidFill>
+              <a:latin typeface="Aptos"/>
+            </a:endParaRPr>
           </a:p>
         </p:txBody>
       </p:sp>
@@ -9687,8 +6364,8 @@
         </p:nvSpPr>
         <p:spPr>
           <a:xfrm>
-            <a:off x="2636044" y="801689"/>
-            <a:ext cx="6836569" cy="481806"/>
+            <a:off x="675014" y="588777"/>
+            <a:ext cx="8483833" cy="425777"/>
           </a:xfrm>
         </p:spPr>
         <p:txBody>
@@ -9702,7 +6379,11 @@
             </a:pPr>
             <a:r>
               <a:rPr lang="pt-BR" sz="2000" b="1" dirty="0"/>
-              <a:t>Como chegamos na fórmula da velocidade no MUV?</a:t>
+              <a:t>C</a:t>
+            </a:r>
+            <a:r>
+              <a:rPr lang="pt-BR" sz="2400" b="1" dirty="0"/>
+              <a:t>omo chegamos na fórmula da velocidade no MUV?</a:t>
             </a:r>
           </a:p>
         </p:txBody>
@@ -10081,49 +6762,6 @@
           </a:prstGeom>
         </p:spPr>
       </p:pic>
-      <p:sp>
-        <p:nvSpPr>
-          <p:cNvPr id="13" name="CaixaDeTexto 12">
-            <a:extLst>
-              <a:ext uri="{FF2B5EF4-FFF2-40B4-BE49-F238E27FC236}">
-                <a16:creationId xmlns:a16="http://schemas.microsoft.com/office/drawing/2014/main" id="{87F4860D-F71C-5FAB-6B37-57CCA1B31D11}"/>
-              </a:ext>
-            </a:extLst>
-          </p:cNvPr>
-          <p:cNvSpPr txBox="1"/>
-          <p:nvPr/>
-        </p:nvSpPr>
-        <p:spPr>
-          <a:xfrm>
-            <a:off x="10822417" y="6369995"/>
-            <a:ext cx="2743199" cy="461665"/>
-          </a:xfrm>
-          <a:prstGeom prst="rect">
-            <a:avLst/>
-          </a:prstGeom>
-          <a:noFill/>
-        </p:spPr>
-        <p:txBody>
-          <a:bodyPr rot="0" spcFirstLastPara="0" vertOverflow="overflow" horzOverflow="overflow" vert="horz" wrap="square" lIns="91440" tIns="45720" rIns="91440" bIns="45720" numCol="1" spcCol="0" rtlCol="0" fromWordArt="0" anchor="t" anchorCtr="0" forceAA="0" compatLnSpc="1">
-            <a:prstTxWarp prst="textNoShape">
-              <a:avLst/>
-            </a:prstTxWarp>
-            <a:spAutoFit/>
-          </a:bodyPr>
-          <a:lstStyle/>
-          <a:p>
-            <a:pPr algn="l"/>
-            <a:r>
-              <a:rPr lang="pt-BR" sz="2400" b="1" dirty="0">
-                <a:solidFill>
-                  <a:srgbClr val="FF0000"/>
-                </a:solidFill>
-              </a:rPr>
-              <a:t>(Quadro)</a:t>
-            </a:r>
-          </a:p>
-        </p:txBody>
-      </p:sp>
     </p:spTree>
     <p:extLst>
       <p:ext uri="{BB962C8B-B14F-4D97-AF65-F5344CB8AC3E}">
@@ -10137,7 +6775,7 @@
 </p:sld>
 </file>
 
-<file path=ppt/slides/slide9.xml><?xml version="1.0" encoding="utf-8"?>
+<file path=ppt/slides/slide8.xml><?xml version="1.0" encoding="utf-8"?>
 <p:sld xmlns:a="http://schemas.openxmlformats.org/drawingml/2006/main" xmlns:r="http://schemas.openxmlformats.org/officeDocument/2006/relationships" xmlns:p="http://schemas.openxmlformats.org/presentationml/2006/main">
   <p:cSld>
     <p:spTree>
@@ -10431,6 +7069,111 @@
     <p:extLst>
       <p:ext uri="{BB962C8B-B14F-4D97-AF65-F5344CB8AC3E}">
         <p14:creationId xmlns:p14="http://schemas.microsoft.com/office/powerpoint/2010/main" val="1522954161"/>
+      </p:ext>
+    </p:extLst>
+  </p:cSld>
+  <p:clrMapOvr>
+    <a:masterClrMapping/>
+  </p:clrMapOvr>
+</p:sld>
+</file>
+
+<file path=ppt/slides/slide9.xml><?xml version="1.0" encoding="utf-8"?>
+<p:sld xmlns:a="http://schemas.openxmlformats.org/drawingml/2006/main" xmlns:r="http://schemas.openxmlformats.org/officeDocument/2006/relationships" xmlns:p="http://schemas.openxmlformats.org/presentationml/2006/main">
+  <p:cSld>
+    <p:spTree>
+      <p:nvGrpSpPr>
+        <p:cNvPr id="1" name=""/>
+        <p:cNvGrpSpPr/>
+        <p:nvPr/>
+      </p:nvGrpSpPr>
+      <p:grpSpPr>
+        <a:xfrm>
+          <a:off x="0" y="0"/>
+          <a:ext cx="0" cy="0"/>
+          <a:chOff x="0" y="0"/>
+          <a:chExt cx="0" cy="0"/>
+        </a:xfrm>
+      </p:grpSpPr>
+      <p:sp>
+        <p:nvSpPr>
+          <p:cNvPr id="2" name="Título 1">
+            <a:extLst>
+              <a:ext uri="{FF2B5EF4-FFF2-40B4-BE49-F238E27FC236}">
+                <a16:creationId xmlns:a16="http://schemas.microsoft.com/office/drawing/2014/main" id="{D9D4FF0B-91C7-2EEC-7B71-66C519BFD7C6}"/>
+              </a:ext>
+            </a:extLst>
+          </p:cNvPr>
+          <p:cNvSpPr>
+            <a:spLocks noGrp="1"/>
+          </p:cNvSpPr>
+          <p:nvPr>
+            <p:ph type="title"/>
+          </p:nvPr>
+        </p:nvSpPr>
+        <p:spPr>
+          <a:xfrm>
+            <a:off x="1362075" y="-3969"/>
+            <a:ext cx="9467851" cy="956470"/>
+          </a:xfrm>
+        </p:spPr>
+        <p:txBody>
+          <a:bodyPr>
+            <a:normAutofit/>
+          </a:bodyPr>
+          <a:lstStyle/>
+          <a:p>
+            <a:r>
+              <a:rPr lang="pt-BR" sz="3200" b="1" dirty="0">
+                <a:solidFill>
+                  <a:schemeClr val="accent2"/>
+                </a:solidFill>
+                <a:latin typeface="Aptos"/>
+              </a:rPr>
+              <a:t>Problema matemático contextualizado na Física.</a:t>
+            </a:r>
+            <a:endParaRPr lang="pt-BR" sz="3200" dirty="0">
+              <a:solidFill>
+                <a:schemeClr val="accent2"/>
+              </a:solidFill>
+            </a:endParaRPr>
+          </a:p>
+        </p:txBody>
+      </p:sp>
+      <p:pic>
+        <p:nvPicPr>
+          <p:cNvPr id="4" name="Imagem 3" descr="Interface gráfica do usuário, Texto, Aplicativo&#10;&#10;O conteúdo gerado por IA pode estar incorreto.">
+            <a:extLst>
+              <a:ext uri="{FF2B5EF4-FFF2-40B4-BE49-F238E27FC236}">
+                <a16:creationId xmlns:a16="http://schemas.microsoft.com/office/drawing/2014/main" id="{D0C7C922-F1D6-C35A-A6BF-F6709DC92476}"/>
+              </a:ext>
+            </a:extLst>
+          </p:cNvPr>
+          <p:cNvPicPr>
+            <a:picLocks noChangeAspect="1"/>
+          </p:cNvPicPr>
+          <p:nvPr/>
+        </p:nvPicPr>
+        <p:blipFill>
+          <a:blip r:embed="rId2"/>
+          <a:stretch>
+            <a:fillRect/>
+          </a:stretch>
+        </p:blipFill>
+        <p:spPr>
+          <a:xfrm>
+            <a:off x="1052311" y="1147480"/>
+            <a:ext cx="10086974" cy="4576762"/>
+          </a:xfrm>
+          <a:prstGeom prst="rect">
+            <a:avLst/>
+          </a:prstGeom>
+        </p:spPr>
+      </p:pic>
+    </p:spTree>
+    <p:extLst>
+      <p:ext uri="{BB962C8B-B14F-4D97-AF65-F5344CB8AC3E}">
+        <p14:creationId xmlns:p14="http://schemas.microsoft.com/office/powerpoint/2010/main" val="3698281848"/>
       </p:ext>
     </p:extLst>
   </p:cSld>

</xml_diff>